<commit_message>
Sunuma CK Tool açıklama slaytları eklendi (8 → 10 slayt)
- Slayt 4: CK Tool nedir, nasıl kurulur, çalıştırma komutu
- Slayt 5: Otomasyon scripti, çıktı yapısı, CSV format örneği

Co-Authored-By: Claude Opus 4.6 (1M context) <noreply@anthropic.com>
</commit_message>
<xml_diff>
--- a/sunum.pptx
+++ b/sunum.pptx
@@ -9,6 +9,8 @@
     <p:sldId id="257" r:id="rId9"/>
     <p:sldId id="258" r:id="rId10"/>
     <p:sldId id="259" r:id="rId11"/>
+    <p:sldId id="264" r:id="rId16"/>
+    <p:sldId id="265" r:id="rId17"/>
     <p:sldId id="260" r:id="rId12"/>
     <p:sldId id="261" r:id="rId13"/>
     <p:sldId id="262" r:id="rId14"/>
@@ -545,6 +547,99 @@
 </p:notes>
 </file>
 
+<file path=ppt/notesSlides/notesSlide10.xml><?xml version="1.0" encoding="utf-8"?>
+<p:notes xmlns:a="http://schemas.openxmlformats.org/drawingml/2006/main" xmlns:p="http://schemas.openxmlformats.org/presentationml/2006/main" xmlns:r="http://schemas.openxmlformats.org/officeDocument/2006/relationships">
+  <p:cSld>
+    <p:spTree>
+      <p:nvGrpSpPr>
+        <p:cNvPr id="1" name=""/>
+        <p:cNvGrpSpPr/>
+        <p:nvPr/>
+      </p:nvGrpSpPr>
+      <p:grpSpPr>
+        <a:xfrm>
+          <a:off x="0" y="0"/>
+          <a:ext cx="0" cy="0"/>
+          <a:chOff x="0" y="0"/>
+          <a:chExt cx="0" cy="0"/>
+        </a:xfrm>
+      </p:grpSpPr>
+      <p:sp>
+        <p:nvSpPr>
+          <p:cNvPr id="2" name="Slide Image Placeholder 1"/>
+          <p:cNvSpPr>
+            <a:spLocks noGrp="1"/>
+          </p:cNvSpPr>
+          <p:nvPr>
+            <p:ph type="sldImg" idx="2"/>
+          </p:nvPr>
+        </p:nvSpPr>
+        <p:spPr/>
+      </p:sp>
+      <p:sp>
+        <p:nvSpPr>
+          <p:cNvPr id="3" name="Notes Placeholder 2"/>
+          <p:cNvSpPr>
+            <a:spLocks noGrp="1"/>
+          </p:cNvSpPr>
+          <p:nvPr>
+            <p:ph type="body" idx="3" sz="quarter"/>
+          </p:nvPr>
+        </p:nvSpPr>
+        <p:spPr/>
+        <p:txBody>
+          <a:bodyPr/>
+          <a:lstStyle/>
+          <a:p>
+            <a:r>
+              <a:t>OTOMASYON VE CIKTILAR (40 sn):</a:t>
+            </a:r>
+          </a:p>
+          <a:p>
+            <a:r>
+              <a:t>12 surumu tek tek elle calistirmak yerine bir bash scripti yazdik — extract_metrics.sh. Bu script bir dongu icinde her surum icin git checkout yapip CK Tool'u calistiriyor ve ciktilari metrics klasorune kaydediyor.</a:t>
+            </a:r>
+          </a:p>
+          <a:p/>
+          <a:p>
+            <a:r>
+              <a:t>Cikti olarak her surum icin bir class.csv dosyasi elde ettik. Ornegin 1.0.0.0 surumunde 288 sinif, 2.16.0.0 surumunde 591 sinif analiz edildi.</a:t>
+            </a:r>
+          </a:p>
+          <a:p/>
+          <a:p>
+            <a:r>
+              <a:t>CSV dosyasinin her satiri bir Java sinifi. Sutunlarda CBO, WMC, DIT, LCOM gibi metrikler var. Ornegin bir sinifin cbo degeri 15 ise, 15 farkli sinifa bagimli demek. wmc 42 ise karmasiklik yuksek.</a:t>
+            </a:r>
+          </a:p>
+          <a:p/>
+          <a:p>
+            <a:r>
+              <a:t>Bu ham CSV verilerini sonra Python ile okuyup QMOOD tasarim ozelliklerine donusturduk. Ornegin privateFieldsQty bolü totalFieldsQty bize DAM yani Encapsulation degerini veriyor. tcc degeri dogrudan CAM yani Cohesion olarak kullaniliyor.</a:t>
+            </a:r>
+          </a:p>
+        </p:txBody>
+      </p:sp>
+      <p:sp>
+        <p:nvSpPr>
+          <p:cNvPr id="4" name="Slide Number Placeholder 3"/>
+          <p:cNvSpPr>
+            <a:spLocks noGrp="1"/>
+          </p:cNvSpPr>
+          <p:nvPr>
+            <p:ph type="sldNum" idx="5" sz="quarter"/>
+          </p:nvPr>
+        </p:nvSpPr>
+        <p:spPr/>
+      </p:sp>
+    </p:spTree>
+  </p:cSld>
+  <p:clrMapOvr>
+    <a:masterClrMapping/>
+  </p:clrMapOvr>
+</p:notes>
+</file>
+
 <file path=ppt/notesSlides/notesSlide2.xml><?xml version="1.0" encoding="utf-8"?>
 <p:notes xmlns:a="http://schemas.openxmlformats.org/drawingml/2006/main" xmlns:p="http://schemas.openxmlformats.org/presentationml/2006/main" xmlns:r="http://schemas.openxmlformats.org/officeDocument/2006/relationships">
   <p:cSld>
@@ -1227,6 +1322,99 @@
           <a:p>
             <a:r>
               <a:t>Tesekkur ederim, sorularinizi bekliyorum.</a:t>
+            </a:r>
+          </a:p>
+        </p:txBody>
+      </p:sp>
+      <p:sp>
+        <p:nvSpPr>
+          <p:cNvPr id="4" name="Slide Number Placeholder 3"/>
+          <p:cNvSpPr>
+            <a:spLocks noGrp="1"/>
+          </p:cNvSpPr>
+          <p:nvPr>
+            <p:ph type="sldNum" idx="5" sz="quarter"/>
+          </p:nvPr>
+        </p:nvSpPr>
+        <p:spPr/>
+      </p:sp>
+    </p:spTree>
+  </p:cSld>
+  <p:clrMapOvr>
+    <a:masterClrMapping/>
+  </p:clrMapOvr>
+</p:notes>
+</file>
+
+<file path=ppt/notesSlides/notesSlide9.xml><?xml version="1.0" encoding="utf-8"?>
+<p:notes xmlns:a="http://schemas.openxmlformats.org/drawingml/2006/main" xmlns:p="http://schemas.openxmlformats.org/presentationml/2006/main" xmlns:r="http://schemas.openxmlformats.org/officeDocument/2006/relationships">
+  <p:cSld>
+    <p:spTree>
+      <p:nvGrpSpPr>
+        <p:cNvPr id="1" name=""/>
+        <p:cNvGrpSpPr/>
+        <p:nvPr/>
+      </p:nvGrpSpPr>
+      <p:grpSpPr>
+        <a:xfrm>
+          <a:off x="0" y="0"/>
+          <a:ext cx="0" cy="0"/>
+          <a:chOff x="0" y="0"/>
+          <a:chExt cx="0" cy="0"/>
+        </a:xfrm>
+      </p:grpSpPr>
+      <p:sp>
+        <p:nvSpPr>
+          <p:cNvPr id="2" name="Slide Image Placeholder 1"/>
+          <p:cNvSpPr>
+            <a:spLocks noGrp="1"/>
+          </p:cNvSpPr>
+          <p:nvPr>
+            <p:ph type="sldImg" idx="2"/>
+          </p:nvPr>
+        </p:nvSpPr>
+        <p:spPr/>
+      </p:sp>
+      <p:sp>
+        <p:nvSpPr>
+          <p:cNvPr id="3" name="Notes Placeholder 2"/>
+          <p:cNvSpPr>
+            <a:spLocks noGrp="1"/>
+          </p:cNvSpPr>
+          <p:nvPr>
+            <p:ph type="body" idx="3" sz="quarter"/>
+          </p:nvPr>
+        </p:nvSpPr>
+        <p:spPr/>
+        <p:txBody>
+          <a:bodyPr/>
+          <a:lstStyle/>
+          <a:p>
+            <a:r>
+              <a:t>CK TOOL NEDIR (40 sn):</a:t>
+            </a:r>
+          </a:p>
+          <a:p>
+            <a:r>
+              <a:t>CK Tool, Mauricio Aniche tarafindan gelistirilen acik kaynak bir Java metrik analiz aracidir.</a:t>
+            </a:r>
+          </a:p>
+          <a:p/>
+          <a:p>
+            <a:r>
+              <a:t>En onemli ozelligi: Java kodunu DERLEMEDEN analiz eder. Yani projeyi build etmenize gerek yok. Dogrudan .java dosyalarini parse edip sinif bazinda CSV ciktisi uretir.</a:t>
+            </a:r>
+          </a:p>
+          <a:p/>
+          <a:p>
+            <a:r>
+              <a:t>Olctugu metrikler arasinda CBO, DIT, WMC, RFC, LCOM gibi Chidamber-Kemerer metrikleri var. Bunun yaninda TCC, publicMethodsQty, privateFieldsQty gibi ek metrikler de sagliyor ki bunlar QMOOD hesaplamalari icin kritik.</a:t>
+            </a:r>
+          </a:p>
+          <a:p/>
+          <a:p>
+            <a:r>
+              <a:t>Kurulumu cok basit — Maven Central'dan tek bir JAR dosyasi indiriyorsunuz. Sonra java -jar komutuyla calistiriyorsunuz. Analiz edilecek dizini, cikti dizinini parametre olarak veriyorsunuz.</a:t>
             </a:r>
           </a:p>
         </p:txBody>
@@ -4446,6 +4634,1368 @@
 </p:sld>
 </file>
 
+<file path=ppt/slides/slide10.xml><?xml version="1.0" encoding="utf-8"?>
+<p:sld xmlns:a="http://schemas.openxmlformats.org/drawingml/2006/main" xmlns:p="http://schemas.openxmlformats.org/presentationml/2006/main" xmlns:r="http://schemas.openxmlformats.org/officeDocument/2006/relationships">
+  <p:cSld>
+    <p:bg>
+      <p:bgPr>
+        <a:solidFill>
+          <a:srgbClr val="F5F6FA"/>
+        </a:solidFill>
+        <a:effectLst/>
+      </p:bgPr>
+    </p:bg>
+    <p:spTree>
+      <p:nvGrpSpPr>
+        <p:cNvPr id="1" name=""/>
+        <p:cNvGrpSpPr/>
+        <p:nvPr/>
+      </p:nvGrpSpPr>
+      <p:grpSpPr/>
+      <p:sp>
+        <p:nvSpPr>
+          <p:cNvPr id="2" name="Rectangle 1"/>
+          <p:cNvSpPr/>
+          <p:nvPr/>
+        </p:nvSpPr>
+        <p:spPr>
+          <a:xfrm>
+            <a:off x="0" y="0"/>
+            <a:ext cx="12191695" cy="1005840"/>
+          </a:xfrm>
+          <a:prstGeom prst="rect">
+            <a:avLst/>
+          </a:prstGeom>
+          <a:solidFill>
+            <a:srgbClr val="00528A"/>
+          </a:solidFill>
+          <a:ln>
+            <a:noFill/>
+          </a:ln>
+        </p:spPr>
+        <p:style>
+          <a:lnRef idx="1">
+            <a:schemeClr val="accent1"/>
+          </a:lnRef>
+          <a:fillRef idx="3">
+            <a:schemeClr val="accent1"/>
+          </a:fillRef>
+          <a:effectRef idx="2">
+            <a:schemeClr val="accent1"/>
+          </a:effectRef>
+          <a:fontRef idx="minor">
+            <a:schemeClr val="lt1"/>
+          </a:fontRef>
+        </p:style>
+        <p:txBody>
+          <a:bodyPr rtlCol="0" anchor="ctr"/>
+          <a:lstStyle/>
+          <a:p>
+            <a:pPr algn="ctr"/>
+          </a:p>
+        </p:txBody>
+      </p:sp>
+      <p:sp>
+        <p:nvSpPr>
+          <p:cNvPr id="3" name="TextBox 2"/>
+          <p:cNvSpPr txBox="1"/>
+          <p:nvPr/>
+        </p:nvSpPr>
+        <p:spPr>
+          <a:xfrm>
+            <a:off x="731520" y="182880"/>
+            <a:ext cx="10058400" cy="640080"/>
+          </a:xfrm>
+          <a:prstGeom prst="rect">
+            <a:avLst/>
+          </a:prstGeom>
+          <a:noFill/>
+        </p:spPr>
+        <p:txBody>
+          <a:bodyPr wrap="square">
+            <a:spAutoFit/>
+          </a:bodyPr>
+          <a:lstStyle/>
+          <a:p>
+            <a:pPr algn="l">
+              <a:defRPr sz="3000" b="1">
+                <a:solidFill>
+                  <a:srgbClr val="FFFFFF"/>
+                </a:solidFill>
+                <a:latin typeface="Calibri"/>
+              </a:defRPr>
+            </a:pPr>
+            <a:r>
+              <a:t>CK Tool: Otomasyon ve Ciktilar</a:t>
+            </a:r>
+          </a:p>
+        </p:txBody>
+      </p:sp>
+      <p:sp>
+        <p:nvSpPr>
+          <p:cNvPr id="4" name="Rectangle 3"/>
+          <p:cNvSpPr/>
+          <p:nvPr/>
+        </p:nvSpPr>
+        <p:spPr>
+          <a:xfrm>
+            <a:off x="274320" y="1188720"/>
+            <a:ext cx="5669280" cy="2926080"/>
+          </a:xfrm>
+          <a:prstGeom prst="rect">
+            <a:avLst/>
+          </a:prstGeom>
+          <a:solidFill>
+            <a:srgbClr val="FFFFFF"/>
+          </a:solidFill>
+          <a:ln>
+            <a:noFill/>
+          </a:ln>
+        </p:spPr>
+        <p:style>
+          <a:lnRef idx="1">
+            <a:schemeClr val="accent1"/>
+          </a:lnRef>
+          <a:fillRef idx="3">
+            <a:schemeClr val="accent1"/>
+          </a:fillRef>
+          <a:effectRef idx="2">
+            <a:schemeClr val="accent1"/>
+          </a:effectRef>
+          <a:fontRef idx="minor">
+            <a:schemeClr val="lt1"/>
+          </a:fontRef>
+        </p:style>
+        <p:txBody>
+          <a:bodyPr rtlCol="0" anchor="ctr"/>
+          <a:lstStyle/>
+          <a:p>
+            <a:pPr algn="ctr"/>
+          </a:p>
+        </p:txBody>
+      </p:sp>
+      <p:sp>
+        <p:nvSpPr>
+          <p:cNvPr id="5" name="TextBox 4"/>
+          <p:cNvSpPr txBox="1"/>
+          <p:nvPr/>
+        </p:nvSpPr>
+        <p:spPr>
+          <a:xfrm>
+            <a:off x="457200" y="1280160"/>
+            <a:ext cx="5303520" cy="365760"/>
+          </a:xfrm>
+          <a:prstGeom prst="rect">
+            <a:avLst/>
+          </a:prstGeom>
+          <a:noFill/>
+        </p:spPr>
+        <p:txBody>
+          <a:bodyPr wrap="square">
+            <a:spAutoFit/>
+          </a:bodyPr>
+          <a:lstStyle/>
+          <a:p>
+            <a:pPr algn="l">
+              <a:defRPr sz="1800" b="1">
+                <a:solidFill>
+                  <a:srgbClr val="0096D6"/>
+                </a:solidFill>
+                <a:latin typeface="Calibri"/>
+              </a:defRPr>
+            </a:pPr>
+            <a:r>
+              <a:t>3. Otomasyon Scripti (extract_metrics.sh)</a:t>
+            </a:r>
+          </a:p>
+        </p:txBody>
+      </p:sp>
+      <p:sp>
+        <p:nvSpPr>
+          <p:cNvPr id="6" name="TextBox 5"/>
+          <p:cNvSpPr txBox="1"/>
+          <p:nvPr/>
+        </p:nvSpPr>
+        <p:spPr>
+          <a:xfrm>
+            <a:off x="457200" y="1737360"/>
+            <a:ext cx="5303520" cy="274320"/>
+          </a:xfrm>
+          <a:prstGeom prst="rect">
+            <a:avLst/>
+          </a:prstGeom>
+          <a:noFill/>
+        </p:spPr>
+        <p:txBody>
+          <a:bodyPr wrap="square">
+            <a:spAutoFit/>
+          </a:bodyPr>
+          <a:lstStyle/>
+          <a:p>
+            <a:pPr algn="l">
+              <a:defRPr sz="1400" b="0">
+                <a:solidFill>
+                  <a:srgbClr val="333333"/>
+                </a:solidFill>
+                <a:latin typeface="Calibri"/>
+              </a:defRPr>
+            </a:pPr>
+            <a:r>
+              <a:t>12 surum icin dongu ile otomatik calistirma:</a:t>
+            </a:r>
+          </a:p>
+        </p:txBody>
+      </p:sp>
+      <p:sp>
+        <p:nvSpPr>
+          <p:cNvPr id="7" name="Rectangle 6"/>
+          <p:cNvSpPr/>
+          <p:nvPr/>
+        </p:nvSpPr>
+        <p:spPr>
+          <a:xfrm>
+            <a:off x="457200" y="2103120"/>
+            <a:ext cx="5303520" cy="1828800"/>
+          </a:xfrm>
+          <a:prstGeom prst="rect">
+            <a:avLst/>
+          </a:prstGeom>
+          <a:solidFill>
+            <a:srgbClr val="2D2D2D"/>
+          </a:solidFill>
+          <a:ln>
+            <a:noFill/>
+          </a:ln>
+        </p:spPr>
+        <p:style>
+          <a:lnRef idx="1">
+            <a:schemeClr val="accent1"/>
+          </a:lnRef>
+          <a:fillRef idx="3">
+            <a:schemeClr val="accent1"/>
+          </a:fillRef>
+          <a:effectRef idx="2">
+            <a:schemeClr val="accent1"/>
+          </a:effectRef>
+          <a:fontRef idx="minor">
+            <a:schemeClr val="lt1"/>
+          </a:fontRef>
+        </p:style>
+        <p:txBody>
+          <a:bodyPr rtlCol="0" anchor="ctr"/>
+          <a:lstStyle/>
+          <a:p>
+            <a:pPr algn="ctr"/>
+          </a:p>
+        </p:txBody>
+      </p:sp>
+      <p:sp>
+        <p:nvSpPr>
+          <p:cNvPr id="8" name="TextBox 7"/>
+          <p:cNvSpPr txBox="1"/>
+          <p:nvPr/>
+        </p:nvSpPr>
+        <p:spPr>
+          <a:xfrm>
+            <a:off x="548640" y="2148840"/>
+            <a:ext cx="5120640" cy="1737360"/>
+          </a:xfrm>
+          <a:prstGeom prst="rect">
+            <a:avLst/>
+          </a:prstGeom>
+          <a:noFill/>
+        </p:spPr>
+        <p:txBody>
+          <a:bodyPr wrap="square">
+            <a:spAutoFit/>
+          </a:bodyPr>
+          <a:lstStyle/>
+          <a:p>
+            <a:pPr algn="l">
+              <a:defRPr sz="1200" b="0">
+                <a:solidFill>
+                  <a:srgbClr val="2ECC71"/>
+                </a:solidFill>
+                <a:latin typeface="Calibri"/>
+              </a:defRPr>
+            </a:pPr>
+            <a:r>
+              <a:t>VERSIONS=("1.0.0.0" "1.1.0.0" ... "3.0.0.0")</a:t>
+            </a:r>
+            <a:br/>
+            <a:br/>
+            <a:r>
+              <a:t>for VERSION in ${VERSIONS[@]}; do</a:t>
+            </a:r>
+            <a:br/>
+            <a:r>
+              <a:t>    git checkout "$VERSION"          # surumu sec</a:t>
+            </a:r>
+            <a:br/>
+            <a:r>
+              <a:t>    java -jar ck-0.7.0-...jar \     # CK Tool</a:t>
+            </a:r>
+            <a:br/>
+            <a:r>
+              <a:t>        "src/main/java" ...          # analiz et</a:t>
+            </a:r>
+            <a:br/>
+            <a:r>
+              <a:t>        "metrics/$VERSION/"           # kaydet</a:t>
+            </a:r>
+            <a:br/>
+            <a:r>
+              <a:t>done</a:t>
+            </a:r>
+          </a:p>
+        </p:txBody>
+      </p:sp>
+      <p:sp>
+        <p:nvSpPr>
+          <p:cNvPr id="9" name="Rectangle 8"/>
+          <p:cNvSpPr/>
+          <p:nvPr/>
+        </p:nvSpPr>
+        <p:spPr>
+          <a:xfrm>
+            <a:off x="6217920" y="1188720"/>
+            <a:ext cx="5669280" cy="2926080"/>
+          </a:xfrm>
+          <a:prstGeom prst="rect">
+            <a:avLst/>
+          </a:prstGeom>
+          <a:solidFill>
+            <a:srgbClr val="FFFFFF"/>
+          </a:solidFill>
+          <a:ln>
+            <a:noFill/>
+          </a:ln>
+        </p:spPr>
+        <p:style>
+          <a:lnRef idx="1">
+            <a:schemeClr val="accent1"/>
+          </a:lnRef>
+          <a:fillRef idx="3">
+            <a:schemeClr val="accent1"/>
+          </a:fillRef>
+          <a:effectRef idx="2">
+            <a:schemeClr val="accent1"/>
+          </a:effectRef>
+          <a:fontRef idx="minor">
+            <a:schemeClr val="lt1"/>
+          </a:fontRef>
+        </p:style>
+        <p:txBody>
+          <a:bodyPr rtlCol="0" anchor="ctr"/>
+          <a:lstStyle/>
+          <a:p>
+            <a:pPr algn="ctr"/>
+          </a:p>
+        </p:txBody>
+      </p:sp>
+      <p:sp>
+        <p:nvSpPr>
+          <p:cNvPr id="10" name="TextBox 9"/>
+          <p:cNvSpPr txBox="1"/>
+          <p:nvPr/>
+        </p:nvSpPr>
+        <p:spPr>
+          <a:xfrm>
+            <a:off x="6400800" y="1280160"/>
+            <a:ext cx="5303520" cy="365760"/>
+          </a:xfrm>
+          <a:prstGeom prst="rect">
+            <a:avLst/>
+          </a:prstGeom>
+          <a:noFill/>
+        </p:spPr>
+        <p:txBody>
+          <a:bodyPr wrap="square">
+            <a:spAutoFit/>
+          </a:bodyPr>
+          <a:lstStyle/>
+          <a:p>
+            <a:pPr algn="l">
+              <a:defRPr sz="1800" b="1">
+                <a:solidFill>
+                  <a:srgbClr val="0096D6"/>
+                </a:solidFill>
+                <a:latin typeface="Calibri"/>
+              </a:defRPr>
+            </a:pPr>
+            <a:r>
+              <a:t>4. Cikti Yapisi</a:t>
+            </a:r>
+          </a:p>
+        </p:txBody>
+      </p:sp>
+      <p:sp>
+        <p:nvSpPr>
+          <p:cNvPr id="11" name="Rectangle 10"/>
+          <p:cNvSpPr/>
+          <p:nvPr/>
+        </p:nvSpPr>
+        <p:spPr>
+          <a:xfrm>
+            <a:off x="6400800" y="1737360"/>
+            <a:ext cx="5303520" cy="2194560"/>
+          </a:xfrm>
+          <a:prstGeom prst="rect">
+            <a:avLst/>
+          </a:prstGeom>
+          <a:solidFill>
+            <a:srgbClr val="2D2D2D"/>
+          </a:solidFill>
+          <a:ln>
+            <a:noFill/>
+          </a:ln>
+        </p:spPr>
+        <p:style>
+          <a:lnRef idx="1">
+            <a:schemeClr val="accent1"/>
+          </a:lnRef>
+          <a:fillRef idx="3">
+            <a:schemeClr val="accent1"/>
+          </a:fillRef>
+          <a:effectRef idx="2">
+            <a:schemeClr val="accent1"/>
+          </a:effectRef>
+          <a:fontRef idx="minor">
+            <a:schemeClr val="lt1"/>
+          </a:fontRef>
+        </p:style>
+        <p:txBody>
+          <a:bodyPr rtlCol="0" anchor="ctr"/>
+          <a:lstStyle/>
+          <a:p>
+            <a:pPr algn="ctr"/>
+          </a:p>
+        </p:txBody>
+      </p:sp>
+      <p:sp>
+        <p:nvSpPr>
+          <p:cNvPr id="12" name="TextBox 11"/>
+          <p:cNvSpPr txBox="1"/>
+          <p:nvPr/>
+        </p:nvSpPr>
+        <p:spPr>
+          <a:xfrm>
+            <a:off x="6492240" y="1783080"/>
+            <a:ext cx="5120640" cy="2103120"/>
+          </a:xfrm>
+          <a:prstGeom prst="rect">
+            <a:avLst/>
+          </a:prstGeom>
+          <a:noFill/>
+        </p:spPr>
+        <p:txBody>
+          <a:bodyPr wrap="square">
+            <a:spAutoFit/>
+          </a:bodyPr>
+          <a:lstStyle/>
+          <a:p>
+            <a:pPr algn="l">
+              <a:defRPr sz="1300" b="0">
+                <a:solidFill>
+                  <a:srgbClr val="2ECC71"/>
+                </a:solidFill>
+                <a:latin typeface="Calibri"/>
+              </a:defRPr>
+            </a:pPr>
+            <a:r>
+              <a:t>metrics/</a:t>
+            </a:r>
+            <a:br/>
+            <a:r>
+              <a:t>|-- 1.0.0.0/class.csv    -&gt; 288 sinif</a:t>
+            </a:r>
+            <a:br/>
+            <a:r>
+              <a:t>|-- 1.1.0.0/class.csv    -&gt; 327 sinif</a:t>
+            </a:r>
+            <a:br/>
+            <a:r>
+              <a:t>|-- 1.3.0.0/class.csv    -&gt; 351 sinif</a:t>
+            </a:r>
+            <a:br/>
+            <a:r>
+              <a:t>|-- 2.0.0.0/class.csv    -&gt; 351 sinif</a:t>
+            </a:r>
+            <a:br/>
+            <a:r>
+              <a:t>|-- ...                            </a:t>
+            </a:r>
+            <a:br/>
+            <a:r>
+              <a:t>|-- 2.16.0.0/class.csv   -&gt; 591 sinif (!)</a:t>
+            </a:r>
+            <a:br/>
+            <a:r>
+              <a:t>|-- 2.19.0.0/class.csv   -&gt; 609 sinif</a:t>
+            </a:r>
+            <a:br/>
+            <a:r>
+              <a:t>|-- 3.0.0.0/class.csv    -&gt; 609 sinif</a:t>
+            </a:r>
+          </a:p>
+        </p:txBody>
+      </p:sp>
+      <p:sp>
+        <p:nvSpPr>
+          <p:cNvPr id="13" name="Rectangle 12"/>
+          <p:cNvSpPr/>
+          <p:nvPr/>
+        </p:nvSpPr>
+        <p:spPr>
+          <a:xfrm>
+            <a:off x="274320" y="4297680"/>
+            <a:ext cx="11612880" cy="2377440"/>
+          </a:xfrm>
+          <a:prstGeom prst="rect">
+            <a:avLst/>
+          </a:prstGeom>
+          <a:solidFill>
+            <a:srgbClr val="FFFFFF"/>
+          </a:solidFill>
+          <a:ln>
+            <a:noFill/>
+          </a:ln>
+        </p:spPr>
+        <p:style>
+          <a:lnRef idx="1">
+            <a:schemeClr val="accent1"/>
+          </a:lnRef>
+          <a:fillRef idx="3">
+            <a:schemeClr val="accent1"/>
+          </a:fillRef>
+          <a:effectRef idx="2">
+            <a:schemeClr val="accent1"/>
+          </a:effectRef>
+          <a:fontRef idx="minor">
+            <a:schemeClr val="lt1"/>
+          </a:fontRef>
+        </p:style>
+        <p:txBody>
+          <a:bodyPr rtlCol="0" anchor="ctr"/>
+          <a:lstStyle/>
+          <a:p>
+            <a:pPr algn="ctr"/>
+          </a:p>
+        </p:txBody>
+      </p:sp>
+      <p:sp>
+        <p:nvSpPr>
+          <p:cNvPr id="14" name="TextBox 13"/>
+          <p:cNvSpPr txBox="1"/>
+          <p:nvPr/>
+        </p:nvSpPr>
+        <p:spPr>
+          <a:xfrm>
+            <a:off x="457200" y="4389120"/>
+            <a:ext cx="11247120" cy="365760"/>
+          </a:xfrm>
+          <a:prstGeom prst="rect">
+            <a:avLst/>
+          </a:prstGeom>
+          <a:noFill/>
+        </p:spPr>
+        <p:txBody>
+          <a:bodyPr wrap="square">
+            <a:spAutoFit/>
+          </a:bodyPr>
+          <a:lstStyle/>
+          <a:p>
+            <a:pPr algn="l">
+              <a:defRPr sz="1800" b="1">
+                <a:solidFill>
+                  <a:srgbClr val="0096D6"/>
+                </a:solidFill>
+                <a:latin typeface="Calibri"/>
+              </a:defRPr>
+            </a:pPr>
+            <a:r>
+              <a:t>5. CSV Ciktisi Nasil Gorunuyor? (class.csv)</a:t>
+            </a:r>
+          </a:p>
+        </p:txBody>
+      </p:sp>
+      <p:sp>
+        <p:nvSpPr>
+          <p:cNvPr id="15" name="TextBox 14"/>
+          <p:cNvSpPr txBox="1"/>
+          <p:nvPr/>
+        </p:nvSpPr>
+        <p:spPr>
+          <a:xfrm>
+            <a:off x="457200" y="4800600"/>
+            <a:ext cx="11247120" cy="274320"/>
+          </a:xfrm>
+          <a:prstGeom prst="rect">
+            <a:avLst/>
+          </a:prstGeom>
+          <a:noFill/>
+        </p:spPr>
+        <p:txBody>
+          <a:bodyPr wrap="square">
+            <a:spAutoFit/>
+          </a:bodyPr>
+          <a:lstStyle/>
+          <a:p>
+            <a:pPr algn="l">
+              <a:defRPr sz="1400" b="0">
+                <a:solidFill>
+                  <a:srgbClr val="333333"/>
+                </a:solidFill>
+                <a:latin typeface="Calibri"/>
+              </a:defRPr>
+            </a:pPr>
+            <a:r>
+              <a:t>Her satir bir Java sinifi, her sutun bir metrik:</a:t>
+            </a:r>
+          </a:p>
+        </p:txBody>
+      </p:sp>
+      <p:sp>
+        <p:nvSpPr>
+          <p:cNvPr id="16" name="Rectangle 15"/>
+          <p:cNvSpPr/>
+          <p:nvPr/>
+        </p:nvSpPr>
+        <p:spPr>
+          <a:xfrm>
+            <a:off x="457200" y="5120640"/>
+            <a:ext cx="11247120" cy="411480"/>
+          </a:xfrm>
+          <a:prstGeom prst="rect">
+            <a:avLst/>
+          </a:prstGeom>
+          <a:solidFill>
+            <a:srgbClr val="2D2D2D"/>
+          </a:solidFill>
+          <a:ln>
+            <a:noFill/>
+          </a:ln>
+        </p:spPr>
+        <p:style>
+          <a:lnRef idx="1">
+            <a:schemeClr val="accent1"/>
+          </a:lnRef>
+          <a:fillRef idx="3">
+            <a:schemeClr val="accent1"/>
+          </a:fillRef>
+          <a:effectRef idx="2">
+            <a:schemeClr val="accent1"/>
+          </a:effectRef>
+          <a:fontRef idx="minor">
+            <a:schemeClr val="lt1"/>
+          </a:fontRef>
+        </p:style>
+        <p:txBody>
+          <a:bodyPr rtlCol="0" anchor="ctr"/>
+          <a:lstStyle/>
+          <a:p>
+            <a:pPr algn="ctr"/>
+          </a:p>
+        </p:txBody>
+      </p:sp>
+      <p:sp>
+        <p:nvSpPr>
+          <p:cNvPr id="17" name="TextBox 16"/>
+          <p:cNvSpPr txBox="1"/>
+          <p:nvPr/>
+        </p:nvSpPr>
+        <p:spPr>
+          <a:xfrm>
+            <a:off x="548640" y="5138928"/>
+            <a:ext cx="11064240" cy="365760"/>
+          </a:xfrm>
+          <a:prstGeom prst="rect">
+            <a:avLst/>
+          </a:prstGeom>
+          <a:noFill/>
+        </p:spPr>
+        <p:txBody>
+          <a:bodyPr wrap="square">
+            <a:spAutoFit/>
+          </a:bodyPr>
+          <a:lstStyle/>
+          <a:p>
+            <a:pPr algn="l">
+              <a:defRPr sz="1100" b="0">
+                <a:solidFill>
+                  <a:srgbClr val="FF8C00"/>
+                </a:solidFill>
+                <a:latin typeface="Calibri"/>
+              </a:defRPr>
+            </a:pPr>
+            <a:r>
+              <a:t>file, class, type, cbo, wmc, dit, noc, rfc, lcom, tcc, totalMethodsQty, publicMethodsQty, privateFieldsQty, abstractMethodsQty, loc, ...</a:t>
+            </a:r>
+          </a:p>
+        </p:txBody>
+      </p:sp>
+      <p:sp>
+        <p:nvSpPr>
+          <p:cNvPr id="18" name="Rectangle 17"/>
+          <p:cNvSpPr/>
+          <p:nvPr/>
+        </p:nvSpPr>
+        <p:spPr>
+          <a:xfrm>
+            <a:off x="457200" y="5532120"/>
+            <a:ext cx="11247120" cy="365760"/>
+          </a:xfrm>
+          <a:prstGeom prst="rect">
+            <a:avLst/>
+          </a:prstGeom>
+          <a:solidFill>
+            <a:srgbClr val="3D3D3D"/>
+          </a:solidFill>
+          <a:ln>
+            <a:noFill/>
+          </a:ln>
+        </p:spPr>
+        <p:style>
+          <a:lnRef idx="1">
+            <a:schemeClr val="accent1"/>
+          </a:lnRef>
+          <a:fillRef idx="3">
+            <a:schemeClr val="accent1"/>
+          </a:fillRef>
+          <a:effectRef idx="2">
+            <a:schemeClr val="accent1"/>
+          </a:effectRef>
+          <a:fontRef idx="minor">
+            <a:schemeClr val="lt1"/>
+          </a:fontRef>
+        </p:style>
+        <p:txBody>
+          <a:bodyPr rtlCol="0" anchor="ctr"/>
+          <a:lstStyle/>
+          <a:p>
+            <a:pPr algn="ctr"/>
+          </a:p>
+        </p:txBody>
+      </p:sp>
+      <p:sp>
+        <p:nvSpPr>
+          <p:cNvPr id="19" name="TextBox 18"/>
+          <p:cNvSpPr txBox="1"/>
+          <p:nvPr/>
+        </p:nvSpPr>
+        <p:spPr>
+          <a:xfrm>
+            <a:off x="548640" y="5550408"/>
+            <a:ext cx="11064240" cy="320040"/>
+          </a:xfrm>
+          <a:prstGeom prst="rect">
+            <a:avLst/>
+          </a:prstGeom>
+          <a:noFill/>
+        </p:spPr>
+        <p:txBody>
+          <a:bodyPr wrap="square">
+            <a:spAutoFit/>
+          </a:bodyPr>
+          <a:lstStyle/>
+          <a:p>
+            <a:pPr algn="l">
+              <a:defRPr sz="1100" b="0">
+                <a:solidFill>
+                  <a:srgbClr val="FFFFFF"/>
+                </a:solidFill>
+                <a:latin typeface="Calibri"/>
+              </a:defRPr>
+            </a:pPr>
+            <a:r>
+              <a:t>DiscoveryNodeFilterer.java, ...DiscoveryNodeFilterer, class, cbo=15, wmc=42, dit=2, noc=0, rfc=28, lcom=8, tcc=0.3, ..., loc=156</a:t>
+            </a:r>
+          </a:p>
+        </p:txBody>
+      </p:sp>
+      <p:sp>
+        <p:nvSpPr>
+          <p:cNvPr id="20" name="Rectangle 19"/>
+          <p:cNvSpPr/>
+          <p:nvPr/>
+        </p:nvSpPr>
+        <p:spPr>
+          <a:xfrm>
+            <a:off x="457200" y="5989320"/>
+            <a:ext cx="2148840" cy="640080"/>
+          </a:xfrm>
+          <a:prstGeom prst="rect">
+            <a:avLst/>
+          </a:prstGeom>
+          <a:solidFill>
+            <a:srgbClr val="E74C3C"/>
+          </a:solidFill>
+          <a:ln>
+            <a:noFill/>
+          </a:ln>
+        </p:spPr>
+        <p:style>
+          <a:lnRef idx="1">
+            <a:schemeClr val="accent1"/>
+          </a:lnRef>
+          <a:fillRef idx="3">
+            <a:schemeClr val="accent1"/>
+          </a:fillRef>
+          <a:effectRef idx="2">
+            <a:schemeClr val="accent1"/>
+          </a:effectRef>
+          <a:fontRef idx="minor">
+            <a:schemeClr val="lt1"/>
+          </a:fontRef>
+        </p:style>
+        <p:txBody>
+          <a:bodyPr rtlCol="0" anchor="ctr"/>
+          <a:lstStyle/>
+          <a:p>
+            <a:pPr algn="ctr"/>
+          </a:p>
+        </p:txBody>
+      </p:sp>
+      <p:sp>
+        <p:nvSpPr>
+          <p:cNvPr id="21" name="TextBox 20"/>
+          <p:cNvSpPr txBox="1"/>
+          <p:nvPr/>
+        </p:nvSpPr>
+        <p:spPr>
+          <a:xfrm>
+            <a:off x="502920" y="5989320"/>
+            <a:ext cx="2057400" cy="274320"/>
+          </a:xfrm>
+          <a:prstGeom prst="rect">
+            <a:avLst/>
+          </a:prstGeom>
+          <a:noFill/>
+        </p:spPr>
+        <p:txBody>
+          <a:bodyPr wrap="square">
+            <a:spAutoFit/>
+          </a:bodyPr>
+          <a:lstStyle/>
+          <a:p>
+            <a:pPr algn="l">
+              <a:defRPr sz="1200" b="1">
+                <a:solidFill>
+                  <a:srgbClr val="FFFFFF"/>
+                </a:solidFill>
+                <a:latin typeface="Calibri"/>
+              </a:defRPr>
+            </a:pPr>
+            <a:r>
+              <a:t>cbo=15</a:t>
+            </a:r>
+          </a:p>
+        </p:txBody>
+      </p:sp>
+      <p:sp>
+        <p:nvSpPr>
+          <p:cNvPr id="22" name="TextBox 21"/>
+          <p:cNvSpPr txBox="1"/>
+          <p:nvPr/>
+        </p:nvSpPr>
+        <p:spPr>
+          <a:xfrm>
+            <a:off x="502920" y="6236208"/>
+            <a:ext cx="2057400" cy="274320"/>
+          </a:xfrm>
+          <a:prstGeom prst="rect">
+            <a:avLst/>
+          </a:prstGeom>
+          <a:noFill/>
+        </p:spPr>
+        <p:txBody>
+          <a:bodyPr wrap="square">
+            <a:spAutoFit/>
+          </a:bodyPr>
+          <a:lstStyle/>
+          <a:p>
+            <a:pPr algn="l">
+              <a:defRPr sz="1100" b="0">
+                <a:solidFill>
+                  <a:srgbClr val="FFFFFF"/>
+                </a:solidFill>
+                <a:latin typeface="Calibri"/>
+              </a:defRPr>
+            </a:pPr>
+            <a:r>
+              <a:t>15 sinifa bagli</a:t>
+            </a:r>
+          </a:p>
+        </p:txBody>
+      </p:sp>
+      <p:sp>
+        <p:nvSpPr>
+          <p:cNvPr id="23" name="Rectangle 22"/>
+          <p:cNvSpPr/>
+          <p:nvPr/>
+        </p:nvSpPr>
+        <p:spPr>
+          <a:xfrm>
+            <a:off x="2743200" y="5989320"/>
+            <a:ext cx="2148840" cy="640080"/>
+          </a:xfrm>
+          <a:prstGeom prst="rect">
+            <a:avLst/>
+          </a:prstGeom>
+          <a:solidFill>
+            <a:srgbClr val="FF8C00"/>
+          </a:solidFill>
+          <a:ln>
+            <a:noFill/>
+          </a:ln>
+        </p:spPr>
+        <p:style>
+          <a:lnRef idx="1">
+            <a:schemeClr val="accent1"/>
+          </a:lnRef>
+          <a:fillRef idx="3">
+            <a:schemeClr val="accent1"/>
+          </a:fillRef>
+          <a:effectRef idx="2">
+            <a:schemeClr val="accent1"/>
+          </a:effectRef>
+          <a:fontRef idx="minor">
+            <a:schemeClr val="lt1"/>
+          </a:fontRef>
+        </p:style>
+        <p:txBody>
+          <a:bodyPr rtlCol="0" anchor="ctr"/>
+          <a:lstStyle/>
+          <a:p>
+            <a:pPr algn="ctr"/>
+          </a:p>
+        </p:txBody>
+      </p:sp>
+      <p:sp>
+        <p:nvSpPr>
+          <p:cNvPr id="24" name="TextBox 23"/>
+          <p:cNvSpPr txBox="1"/>
+          <p:nvPr/>
+        </p:nvSpPr>
+        <p:spPr>
+          <a:xfrm>
+            <a:off x="2788920" y="5989320"/>
+            <a:ext cx="2057400" cy="274320"/>
+          </a:xfrm>
+          <a:prstGeom prst="rect">
+            <a:avLst/>
+          </a:prstGeom>
+          <a:noFill/>
+        </p:spPr>
+        <p:txBody>
+          <a:bodyPr wrap="square">
+            <a:spAutoFit/>
+          </a:bodyPr>
+          <a:lstStyle/>
+          <a:p>
+            <a:pPr algn="l">
+              <a:defRPr sz="1200" b="1">
+                <a:solidFill>
+                  <a:srgbClr val="FFFFFF"/>
+                </a:solidFill>
+                <a:latin typeface="Calibri"/>
+              </a:defRPr>
+            </a:pPr>
+            <a:r>
+              <a:t>wmc=42</a:t>
+            </a:r>
+          </a:p>
+        </p:txBody>
+      </p:sp>
+      <p:sp>
+        <p:nvSpPr>
+          <p:cNvPr id="25" name="TextBox 24"/>
+          <p:cNvSpPr txBox="1"/>
+          <p:nvPr/>
+        </p:nvSpPr>
+        <p:spPr>
+          <a:xfrm>
+            <a:off x="2788920" y="6236208"/>
+            <a:ext cx="2057400" cy="274320"/>
+          </a:xfrm>
+          <a:prstGeom prst="rect">
+            <a:avLst/>
+          </a:prstGeom>
+          <a:noFill/>
+        </p:spPr>
+        <p:txBody>
+          <a:bodyPr wrap="square">
+            <a:spAutoFit/>
+          </a:bodyPr>
+          <a:lstStyle/>
+          <a:p>
+            <a:pPr algn="l">
+              <a:defRPr sz="1100" b="0">
+                <a:solidFill>
+                  <a:srgbClr val="FFFFFF"/>
+                </a:solidFill>
+                <a:latin typeface="Calibri"/>
+              </a:defRPr>
+            </a:pPr>
+            <a:r>
+              <a:t>42 karmasiklik</a:t>
+            </a:r>
+          </a:p>
+        </p:txBody>
+      </p:sp>
+      <p:sp>
+        <p:nvSpPr>
+          <p:cNvPr id="26" name="Rectangle 25"/>
+          <p:cNvSpPr/>
+          <p:nvPr/>
+        </p:nvSpPr>
+        <p:spPr>
+          <a:xfrm>
+            <a:off x="5029200" y="5989320"/>
+            <a:ext cx="2148840" cy="640080"/>
+          </a:xfrm>
+          <a:prstGeom prst="rect">
+            <a:avLst/>
+          </a:prstGeom>
+          <a:solidFill>
+            <a:srgbClr val="FF8C00"/>
+          </a:solidFill>
+          <a:ln>
+            <a:noFill/>
+          </a:ln>
+        </p:spPr>
+        <p:style>
+          <a:lnRef idx="1">
+            <a:schemeClr val="accent1"/>
+          </a:lnRef>
+          <a:fillRef idx="3">
+            <a:schemeClr val="accent1"/>
+          </a:fillRef>
+          <a:effectRef idx="2">
+            <a:schemeClr val="accent1"/>
+          </a:effectRef>
+          <a:fontRef idx="minor">
+            <a:schemeClr val="lt1"/>
+          </a:fontRef>
+        </p:style>
+        <p:txBody>
+          <a:bodyPr rtlCol="0" anchor="ctr"/>
+          <a:lstStyle/>
+          <a:p>
+            <a:pPr algn="ctr"/>
+          </a:p>
+        </p:txBody>
+      </p:sp>
+      <p:sp>
+        <p:nvSpPr>
+          <p:cNvPr id="27" name="TextBox 26"/>
+          <p:cNvSpPr txBox="1"/>
+          <p:nvPr/>
+        </p:nvSpPr>
+        <p:spPr>
+          <a:xfrm>
+            <a:off x="5074920" y="5989320"/>
+            <a:ext cx="2057400" cy="274320"/>
+          </a:xfrm>
+          <a:prstGeom prst="rect">
+            <a:avLst/>
+          </a:prstGeom>
+          <a:noFill/>
+        </p:spPr>
+        <p:txBody>
+          <a:bodyPr wrap="square">
+            <a:spAutoFit/>
+          </a:bodyPr>
+          <a:lstStyle/>
+          <a:p>
+            <a:pPr algn="l">
+              <a:defRPr sz="1200" b="1">
+                <a:solidFill>
+                  <a:srgbClr val="FFFFFF"/>
+                </a:solidFill>
+                <a:latin typeface="Calibri"/>
+              </a:defRPr>
+            </a:pPr>
+            <a:r>
+              <a:t>lcom=8</a:t>
+            </a:r>
+          </a:p>
+        </p:txBody>
+      </p:sp>
+      <p:sp>
+        <p:nvSpPr>
+          <p:cNvPr id="28" name="TextBox 27"/>
+          <p:cNvSpPr txBox="1"/>
+          <p:nvPr/>
+        </p:nvSpPr>
+        <p:spPr>
+          <a:xfrm>
+            <a:off x="5074920" y="6236208"/>
+            <a:ext cx="2057400" cy="274320"/>
+          </a:xfrm>
+          <a:prstGeom prst="rect">
+            <a:avLst/>
+          </a:prstGeom>
+          <a:noFill/>
+        </p:spPr>
+        <p:txBody>
+          <a:bodyPr wrap="square">
+            <a:spAutoFit/>
+          </a:bodyPr>
+          <a:lstStyle/>
+          <a:p>
+            <a:pPr algn="l">
+              <a:defRPr sz="1100" b="0">
+                <a:solidFill>
+                  <a:srgbClr val="FFFFFF"/>
+                </a:solidFill>
+                <a:latin typeface="Calibri"/>
+              </a:defRPr>
+            </a:pPr>
+            <a:r>
+              <a:t>Dusuk kohezyon</a:t>
+            </a:r>
+          </a:p>
+        </p:txBody>
+      </p:sp>
+      <p:sp>
+        <p:nvSpPr>
+          <p:cNvPr id="29" name="Rectangle 28"/>
+          <p:cNvSpPr/>
+          <p:nvPr/>
+        </p:nvSpPr>
+        <p:spPr>
+          <a:xfrm>
+            <a:off x="7315200" y="5989320"/>
+            <a:ext cx="2148840" cy="640080"/>
+          </a:xfrm>
+          <a:prstGeom prst="rect">
+            <a:avLst/>
+          </a:prstGeom>
+          <a:solidFill>
+            <a:srgbClr val="0096D6"/>
+          </a:solidFill>
+          <a:ln>
+            <a:noFill/>
+          </a:ln>
+        </p:spPr>
+        <p:style>
+          <a:lnRef idx="1">
+            <a:schemeClr val="accent1"/>
+          </a:lnRef>
+          <a:fillRef idx="3">
+            <a:schemeClr val="accent1"/>
+          </a:fillRef>
+          <a:effectRef idx="2">
+            <a:schemeClr val="accent1"/>
+          </a:effectRef>
+          <a:fontRef idx="minor">
+            <a:schemeClr val="lt1"/>
+          </a:fontRef>
+        </p:style>
+        <p:txBody>
+          <a:bodyPr rtlCol="0" anchor="ctr"/>
+          <a:lstStyle/>
+          <a:p>
+            <a:pPr algn="ctr"/>
+          </a:p>
+        </p:txBody>
+      </p:sp>
+      <p:sp>
+        <p:nvSpPr>
+          <p:cNvPr id="30" name="TextBox 29"/>
+          <p:cNvSpPr txBox="1"/>
+          <p:nvPr/>
+        </p:nvSpPr>
+        <p:spPr>
+          <a:xfrm>
+            <a:off x="7360920" y="5989320"/>
+            <a:ext cx="2057400" cy="274320"/>
+          </a:xfrm>
+          <a:prstGeom prst="rect">
+            <a:avLst/>
+          </a:prstGeom>
+          <a:noFill/>
+        </p:spPr>
+        <p:txBody>
+          <a:bodyPr wrap="square">
+            <a:spAutoFit/>
+          </a:bodyPr>
+          <a:lstStyle/>
+          <a:p>
+            <a:pPr algn="l">
+              <a:defRPr sz="1200" b="1">
+                <a:solidFill>
+                  <a:srgbClr val="FFFFFF"/>
+                </a:solidFill>
+                <a:latin typeface="Calibri"/>
+              </a:defRPr>
+            </a:pPr>
+            <a:r>
+              <a:t>privateFieldsQty=6</a:t>
+            </a:r>
+          </a:p>
+        </p:txBody>
+      </p:sp>
+      <p:sp>
+        <p:nvSpPr>
+          <p:cNvPr id="31" name="TextBox 30"/>
+          <p:cNvSpPr txBox="1"/>
+          <p:nvPr/>
+        </p:nvSpPr>
+        <p:spPr>
+          <a:xfrm>
+            <a:off x="7360920" y="6236208"/>
+            <a:ext cx="2057400" cy="274320"/>
+          </a:xfrm>
+          <a:prstGeom prst="rect">
+            <a:avLst/>
+          </a:prstGeom>
+          <a:noFill/>
+        </p:spPr>
+        <p:txBody>
+          <a:bodyPr wrap="square">
+            <a:spAutoFit/>
+          </a:bodyPr>
+          <a:lstStyle/>
+          <a:p>
+            <a:pPr algn="l">
+              <a:defRPr sz="1100" b="0">
+                <a:solidFill>
+                  <a:srgbClr val="FFFFFF"/>
+                </a:solidFill>
+                <a:latin typeface="Calibri"/>
+              </a:defRPr>
+            </a:pPr>
+            <a:r>
+              <a:t>6 private alan -&gt; DAM</a:t>
+            </a:r>
+          </a:p>
+        </p:txBody>
+      </p:sp>
+      <p:sp>
+        <p:nvSpPr>
+          <p:cNvPr id="32" name="Rectangle 31"/>
+          <p:cNvSpPr/>
+          <p:nvPr/>
+        </p:nvSpPr>
+        <p:spPr>
+          <a:xfrm>
+            <a:off x="9601200" y="5989320"/>
+            <a:ext cx="2148840" cy="640080"/>
+          </a:xfrm>
+          <a:prstGeom prst="rect">
+            <a:avLst/>
+          </a:prstGeom>
+          <a:solidFill>
+            <a:srgbClr val="2ECC71"/>
+          </a:solidFill>
+          <a:ln>
+            <a:noFill/>
+          </a:ln>
+        </p:spPr>
+        <p:style>
+          <a:lnRef idx="1">
+            <a:schemeClr val="accent1"/>
+          </a:lnRef>
+          <a:fillRef idx="3">
+            <a:schemeClr val="accent1"/>
+          </a:fillRef>
+          <a:effectRef idx="2">
+            <a:schemeClr val="accent1"/>
+          </a:effectRef>
+          <a:fontRef idx="minor">
+            <a:schemeClr val="lt1"/>
+          </a:fontRef>
+        </p:style>
+        <p:txBody>
+          <a:bodyPr rtlCol="0" anchor="ctr"/>
+          <a:lstStyle/>
+          <a:p>
+            <a:pPr algn="ctr"/>
+          </a:p>
+        </p:txBody>
+      </p:sp>
+      <p:sp>
+        <p:nvSpPr>
+          <p:cNvPr id="33" name="TextBox 32"/>
+          <p:cNvSpPr txBox="1"/>
+          <p:nvPr/>
+        </p:nvSpPr>
+        <p:spPr>
+          <a:xfrm>
+            <a:off x="9646920" y="5989320"/>
+            <a:ext cx="2057400" cy="274320"/>
+          </a:xfrm>
+          <a:prstGeom prst="rect">
+            <a:avLst/>
+          </a:prstGeom>
+          <a:noFill/>
+        </p:spPr>
+        <p:txBody>
+          <a:bodyPr wrap="square">
+            <a:spAutoFit/>
+          </a:bodyPr>
+          <a:lstStyle/>
+          <a:p>
+            <a:pPr algn="l">
+              <a:defRPr sz="1200" b="1">
+                <a:solidFill>
+                  <a:srgbClr val="FFFFFF"/>
+                </a:solidFill>
+                <a:latin typeface="Calibri"/>
+              </a:defRPr>
+            </a:pPr>
+            <a:r>
+              <a:t>tcc=0.3</a:t>
+            </a:r>
+          </a:p>
+        </p:txBody>
+      </p:sp>
+      <p:sp>
+        <p:nvSpPr>
+          <p:cNvPr id="34" name="TextBox 33"/>
+          <p:cNvSpPr txBox="1"/>
+          <p:nvPr/>
+        </p:nvSpPr>
+        <p:spPr>
+          <a:xfrm>
+            <a:off x="9646920" y="6236208"/>
+            <a:ext cx="2057400" cy="274320"/>
+          </a:xfrm>
+          <a:prstGeom prst="rect">
+            <a:avLst/>
+          </a:prstGeom>
+          <a:noFill/>
+        </p:spPr>
+        <p:txBody>
+          <a:bodyPr wrap="square">
+            <a:spAutoFit/>
+          </a:bodyPr>
+          <a:lstStyle/>
+          <a:p>
+            <a:pPr algn="l">
+              <a:defRPr sz="1100" b="0">
+                <a:solidFill>
+                  <a:srgbClr val="FFFFFF"/>
+                </a:solidFill>
+                <a:latin typeface="Calibri"/>
+              </a:defRPr>
+            </a:pPr>
+            <a:r>
+              <a:t>Sinif ici tutarlilik -&gt; CAM</a:t>
+            </a:r>
+          </a:p>
+        </p:txBody>
+      </p:sp>
+    </p:spTree>
+  </p:cSld>
+  <p:clrMapOvr>
+    <a:masterClrMapping/>
+  </p:clrMapOvr>
+</p:sld>
+</file>
+
 <file path=ppt/slides/slide2.xml><?xml version="1.0" encoding="utf-8"?>
 <p:sld xmlns:a="http://schemas.openxmlformats.org/drawingml/2006/main" xmlns:p="http://schemas.openxmlformats.org/presentationml/2006/main" xmlns:r="http://schemas.openxmlformats.org/officeDocument/2006/relationships">
   <p:cSld>
@@ -9819,6 +11369,891 @@
             </a:pPr>
             <a:r>
               <a:t>Tesekkurler  —  Sorularinizi bekliyorum</a:t>
+            </a:r>
+          </a:p>
+        </p:txBody>
+      </p:sp>
+    </p:spTree>
+  </p:cSld>
+  <p:clrMapOvr>
+    <a:masterClrMapping/>
+  </p:clrMapOvr>
+</p:sld>
+</file>
+
+<file path=ppt/slides/slide9.xml><?xml version="1.0" encoding="utf-8"?>
+<p:sld xmlns:a="http://schemas.openxmlformats.org/drawingml/2006/main" xmlns:p="http://schemas.openxmlformats.org/presentationml/2006/main" xmlns:r="http://schemas.openxmlformats.org/officeDocument/2006/relationships">
+  <p:cSld>
+    <p:bg>
+      <p:bgPr>
+        <a:solidFill>
+          <a:srgbClr val="F5F6FA"/>
+        </a:solidFill>
+        <a:effectLst/>
+      </p:bgPr>
+    </p:bg>
+    <p:spTree>
+      <p:nvGrpSpPr>
+        <p:cNvPr id="1" name=""/>
+        <p:cNvGrpSpPr/>
+        <p:nvPr/>
+      </p:nvGrpSpPr>
+      <p:grpSpPr/>
+      <p:sp>
+        <p:nvSpPr>
+          <p:cNvPr id="2" name="Rectangle 1"/>
+          <p:cNvSpPr/>
+          <p:nvPr/>
+        </p:nvSpPr>
+        <p:spPr>
+          <a:xfrm>
+            <a:off x="0" y="0"/>
+            <a:ext cx="12191695" cy="1005840"/>
+          </a:xfrm>
+          <a:prstGeom prst="rect">
+            <a:avLst/>
+          </a:prstGeom>
+          <a:solidFill>
+            <a:srgbClr val="00528A"/>
+          </a:solidFill>
+          <a:ln>
+            <a:noFill/>
+          </a:ln>
+        </p:spPr>
+        <p:style>
+          <a:lnRef idx="1">
+            <a:schemeClr val="accent1"/>
+          </a:lnRef>
+          <a:fillRef idx="3">
+            <a:schemeClr val="accent1"/>
+          </a:fillRef>
+          <a:effectRef idx="2">
+            <a:schemeClr val="accent1"/>
+          </a:effectRef>
+          <a:fontRef idx="minor">
+            <a:schemeClr val="lt1"/>
+          </a:fontRef>
+        </p:style>
+        <p:txBody>
+          <a:bodyPr rtlCol="0" anchor="ctr"/>
+          <a:lstStyle/>
+          <a:p>
+            <a:pPr algn="ctr"/>
+          </a:p>
+        </p:txBody>
+      </p:sp>
+      <p:sp>
+        <p:nvSpPr>
+          <p:cNvPr id="3" name="TextBox 2"/>
+          <p:cNvSpPr txBox="1"/>
+          <p:nvPr/>
+        </p:nvSpPr>
+        <p:spPr>
+          <a:xfrm>
+            <a:off x="731520" y="182880"/>
+            <a:ext cx="10058400" cy="640080"/>
+          </a:xfrm>
+          <a:prstGeom prst="rect">
+            <a:avLst/>
+          </a:prstGeom>
+          <a:noFill/>
+        </p:spPr>
+        <p:txBody>
+          <a:bodyPr wrap="square">
+            <a:spAutoFit/>
+          </a:bodyPr>
+          <a:lstStyle/>
+          <a:p>
+            <a:pPr algn="l">
+              <a:defRPr sz="3000" b="1">
+                <a:solidFill>
+                  <a:srgbClr val="FFFFFF"/>
+                </a:solidFill>
+                <a:latin typeface="Calibri"/>
+              </a:defRPr>
+            </a:pPr>
+            <a:r>
+              <a:t>CK Tool Nedir ve Nasil Calistirdik?</a:t>
+            </a:r>
+          </a:p>
+        </p:txBody>
+      </p:sp>
+      <p:sp>
+        <p:nvSpPr>
+          <p:cNvPr id="4" name="Rectangle 3"/>
+          <p:cNvSpPr/>
+          <p:nvPr/>
+        </p:nvSpPr>
+        <p:spPr>
+          <a:xfrm>
+            <a:off x="274320" y="1188720"/>
+            <a:ext cx="5669280" cy="5486400"/>
+          </a:xfrm>
+          <a:prstGeom prst="rect">
+            <a:avLst/>
+          </a:prstGeom>
+          <a:solidFill>
+            <a:srgbClr val="FFFFFF"/>
+          </a:solidFill>
+          <a:ln>
+            <a:noFill/>
+          </a:ln>
+        </p:spPr>
+        <p:style>
+          <a:lnRef idx="1">
+            <a:schemeClr val="accent1"/>
+          </a:lnRef>
+          <a:fillRef idx="3">
+            <a:schemeClr val="accent1"/>
+          </a:fillRef>
+          <a:effectRef idx="2">
+            <a:schemeClr val="accent1"/>
+          </a:effectRef>
+          <a:fontRef idx="minor">
+            <a:schemeClr val="lt1"/>
+          </a:fontRef>
+        </p:style>
+        <p:txBody>
+          <a:bodyPr rtlCol="0" anchor="ctr"/>
+          <a:lstStyle/>
+          <a:p>
+            <a:pPr algn="ctr"/>
+          </a:p>
+        </p:txBody>
+      </p:sp>
+      <p:sp>
+        <p:nvSpPr>
+          <p:cNvPr id="5" name="TextBox 4"/>
+          <p:cNvSpPr txBox="1"/>
+          <p:nvPr/>
+        </p:nvSpPr>
+        <p:spPr>
+          <a:xfrm>
+            <a:off x="457200" y="1280160"/>
+            <a:ext cx="5303520" cy="365760"/>
+          </a:xfrm>
+          <a:prstGeom prst="rect">
+            <a:avLst/>
+          </a:prstGeom>
+          <a:noFill/>
+        </p:spPr>
+        <p:txBody>
+          <a:bodyPr wrap="square">
+            <a:spAutoFit/>
+          </a:bodyPr>
+          <a:lstStyle/>
+          <a:p>
+            <a:pPr algn="l">
+              <a:defRPr sz="2000" b="1">
+                <a:solidFill>
+                  <a:srgbClr val="00528A"/>
+                </a:solidFill>
+                <a:latin typeface="Calibri"/>
+              </a:defRPr>
+            </a:pPr>
+            <a:r>
+              <a:t>CK Tool (Chidamber-Kemerer Tool)</a:t>
+            </a:r>
+          </a:p>
+        </p:txBody>
+      </p:sp>
+      <p:sp>
+        <p:nvSpPr>
+          <p:cNvPr id="6" name="TextBox 5"/>
+          <p:cNvSpPr txBox="1"/>
+          <p:nvPr/>
+        </p:nvSpPr>
+        <p:spPr>
+          <a:xfrm>
+            <a:off x="457200" y="1737360"/>
+            <a:ext cx="5303520" cy="4754880"/>
+          </a:xfrm>
+          <a:prstGeom prst="rect">
+            <a:avLst/>
+          </a:prstGeom>
+          <a:noFill/>
+        </p:spPr>
+        <p:txBody>
+          <a:bodyPr wrap="square">
+            <a:spAutoFit/>
+          </a:bodyPr>
+          <a:lstStyle/>
+          <a:p>
+            <a:pPr>
+              <a:spcAft>
+                <a:spcPts val="300"/>
+              </a:spcAft>
+              <a:defRPr sz="1400">
+                <a:solidFill>
+                  <a:srgbClr val="333333"/>
+                </a:solidFill>
+                <a:latin typeface="Calibri"/>
+              </a:defRPr>
+            </a:pPr>
+            <a:r>
+              <a:t>Mauricio Aniche tarafindan gelistirilen acik kaynak Java metrik analiz araci</a:t>
+            </a:r>
+          </a:p>
+          <a:p>
+            <a:pPr>
+              <a:spcAft>
+                <a:spcPts val="300"/>
+              </a:spcAft>
+              <a:defRPr sz="1400">
+                <a:solidFill>
+                  <a:srgbClr val="333333"/>
+                </a:solidFill>
+                <a:latin typeface="Calibri"/>
+              </a:defRPr>
+            </a:pPr>
+          </a:p>
+          <a:p>
+            <a:pPr>
+              <a:spcAft>
+                <a:spcPts val="300"/>
+              </a:spcAft>
+              <a:defRPr sz="1400">
+                <a:solidFill>
+                  <a:srgbClr val="333333"/>
+                </a:solidFill>
+                <a:latin typeface="Calibri"/>
+              </a:defRPr>
+            </a:pPr>
+            <a:r>
+              <a:t>Nasil calisir?</a:t>
+            </a:r>
+          </a:p>
+          <a:p>
+            <a:pPr>
+              <a:spcAft>
+                <a:spcPts val="300"/>
+              </a:spcAft>
+              <a:defRPr sz="1400">
+                <a:solidFill>
+                  <a:srgbClr val="333333"/>
+                </a:solidFill>
+                <a:latin typeface="Calibri"/>
+              </a:defRPr>
+            </a:pPr>
+            <a:r>
+              <a:t>  -&gt; Java kaynak kodunu DERLEMEDEN (compile etmeden) analiz eder</a:t>
+            </a:r>
+          </a:p>
+          <a:p>
+            <a:pPr>
+              <a:spcAft>
+                <a:spcPts val="300"/>
+              </a:spcAft>
+              <a:defRPr sz="1400">
+                <a:solidFill>
+                  <a:srgbClr val="333333"/>
+                </a:solidFill>
+                <a:latin typeface="Calibri"/>
+              </a:defRPr>
+            </a:pPr>
+            <a:r>
+              <a:t>  -&gt; .java dosyalarini statik olarak parse eder</a:t>
+            </a:r>
+          </a:p>
+          <a:p>
+            <a:pPr>
+              <a:spcAft>
+                <a:spcPts val="300"/>
+              </a:spcAft>
+              <a:defRPr sz="1400">
+                <a:solidFill>
+                  <a:srgbClr val="333333"/>
+                </a:solidFill>
+                <a:latin typeface="Calibri"/>
+              </a:defRPr>
+            </a:pPr>
+            <a:r>
+              <a:t>  -&gt; Sinif bazinda CSV ciktisi uretir (class.csv)</a:t>
+            </a:r>
+          </a:p>
+          <a:p>
+            <a:pPr>
+              <a:spcAft>
+                <a:spcPts val="300"/>
+              </a:spcAft>
+              <a:defRPr sz="1400">
+                <a:solidFill>
+                  <a:srgbClr val="333333"/>
+                </a:solidFill>
+                <a:latin typeface="Calibri"/>
+              </a:defRPr>
+            </a:pPr>
+          </a:p>
+          <a:p>
+            <a:pPr>
+              <a:spcAft>
+                <a:spcPts val="300"/>
+              </a:spcAft>
+              <a:defRPr sz="1400">
+                <a:solidFill>
+                  <a:srgbClr val="333333"/>
+                </a:solidFill>
+                <a:latin typeface="Calibri"/>
+              </a:defRPr>
+            </a:pPr>
+            <a:r>
+              <a:t>Olctugu metrikler:</a:t>
+            </a:r>
+          </a:p>
+          <a:p>
+            <a:pPr>
+              <a:spcAft>
+                <a:spcPts val="300"/>
+              </a:spcAft>
+              <a:defRPr sz="1400">
+                <a:solidFill>
+                  <a:srgbClr val="333333"/>
+                </a:solidFill>
+                <a:latin typeface="Calibri"/>
+              </a:defRPr>
+            </a:pPr>
+            <a:r>
+              <a:t>  -&gt; CBO (Coupling Between Objects)</a:t>
+            </a:r>
+          </a:p>
+          <a:p>
+            <a:pPr>
+              <a:spcAft>
+                <a:spcPts val="300"/>
+              </a:spcAft>
+              <a:defRPr sz="1400">
+                <a:solidFill>
+                  <a:srgbClr val="333333"/>
+                </a:solidFill>
+                <a:latin typeface="Calibri"/>
+              </a:defRPr>
+            </a:pPr>
+            <a:r>
+              <a:t>  -&gt; DIT (Depth of Inheritance Tree)</a:t>
+            </a:r>
+          </a:p>
+          <a:p>
+            <a:pPr>
+              <a:spcAft>
+                <a:spcPts val="300"/>
+              </a:spcAft>
+              <a:defRPr sz="1400">
+                <a:solidFill>
+                  <a:srgbClr val="333333"/>
+                </a:solidFill>
+                <a:latin typeface="Calibri"/>
+              </a:defRPr>
+            </a:pPr>
+            <a:r>
+              <a:t>  -&gt; WMC (Weighted Methods per Class)</a:t>
+            </a:r>
+          </a:p>
+          <a:p>
+            <a:pPr>
+              <a:spcAft>
+                <a:spcPts val="300"/>
+              </a:spcAft>
+              <a:defRPr sz="1400">
+                <a:solidFill>
+                  <a:srgbClr val="333333"/>
+                </a:solidFill>
+                <a:latin typeface="Calibri"/>
+              </a:defRPr>
+            </a:pPr>
+            <a:r>
+              <a:t>  -&gt; RFC (Response for a Class)</a:t>
+            </a:r>
+          </a:p>
+          <a:p>
+            <a:pPr>
+              <a:spcAft>
+                <a:spcPts val="300"/>
+              </a:spcAft>
+              <a:defRPr sz="1400">
+                <a:solidFill>
+                  <a:srgbClr val="333333"/>
+                </a:solidFill>
+                <a:latin typeface="Calibri"/>
+              </a:defRPr>
+            </a:pPr>
+            <a:r>
+              <a:t>  -&gt; LCOM (Lack of Cohesion of Methods)</a:t>
+            </a:r>
+          </a:p>
+          <a:p>
+            <a:pPr>
+              <a:spcAft>
+                <a:spcPts val="300"/>
+              </a:spcAft>
+              <a:defRPr sz="1400">
+                <a:solidFill>
+                  <a:srgbClr val="333333"/>
+                </a:solidFill>
+                <a:latin typeface="Calibri"/>
+              </a:defRPr>
+            </a:pPr>
+            <a:r>
+              <a:t>  -&gt; NOC (Number of Children)</a:t>
+            </a:r>
+          </a:p>
+          <a:p>
+            <a:pPr>
+              <a:spcAft>
+                <a:spcPts val="300"/>
+              </a:spcAft>
+              <a:defRPr sz="1400">
+                <a:solidFill>
+                  <a:srgbClr val="333333"/>
+                </a:solidFill>
+                <a:latin typeface="Calibri"/>
+              </a:defRPr>
+            </a:pPr>
+            <a:r>
+              <a:t>  -&gt; TCC (Tight Class Cohesion)</a:t>
+            </a:r>
+          </a:p>
+          <a:p>
+            <a:pPr>
+              <a:spcAft>
+                <a:spcPts val="300"/>
+              </a:spcAft>
+              <a:defRPr sz="1400">
+                <a:solidFill>
+                  <a:srgbClr val="333333"/>
+                </a:solidFill>
+                <a:latin typeface="Calibri"/>
+              </a:defRPr>
+            </a:pPr>
+            <a:r>
+              <a:t>  -&gt; publicMethodsQty, privateFieldsQty,</a:t>
+            </a:r>
+          </a:p>
+          <a:p>
+            <a:pPr>
+              <a:spcAft>
+                <a:spcPts val="300"/>
+              </a:spcAft>
+              <a:defRPr sz="1400">
+                <a:solidFill>
+                  <a:srgbClr val="333333"/>
+                </a:solidFill>
+                <a:latin typeface="Calibri"/>
+              </a:defRPr>
+            </a:pPr>
+            <a:r>
+              <a:t>     abstractMethodsQty, totalFieldsQty, LOC ...</a:t>
+            </a:r>
+          </a:p>
+        </p:txBody>
+      </p:sp>
+      <p:sp>
+        <p:nvSpPr>
+          <p:cNvPr id="7" name="Rectangle 6"/>
+          <p:cNvSpPr/>
+          <p:nvPr/>
+        </p:nvSpPr>
+        <p:spPr>
+          <a:xfrm>
+            <a:off x="6217920" y="1188720"/>
+            <a:ext cx="5669280" cy="2560320"/>
+          </a:xfrm>
+          <a:prstGeom prst="rect">
+            <a:avLst/>
+          </a:prstGeom>
+          <a:solidFill>
+            <a:srgbClr val="FFFFFF"/>
+          </a:solidFill>
+          <a:ln>
+            <a:noFill/>
+          </a:ln>
+        </p:spPr>
+        <p:style>
+          <a:lnRef idx="1">
+            <a:schemeClr val="accent1"/>
+          </a:lnRef>
+          <a:fillRef idx="3">
+            <a:schemeClr val="accent1"/>
+          </a:fillRef>
+          <a:effectRef idx="2">
+            <a:schemeClr val="accent1"/>
+          </a:effectRef>
+          <a:fontRef idx="minor">
+            <a:schemeClr val="lt1"/>
+          </a:fontRef>
+        </p:style>
+        <p:txBody>
+          <a:bodyPr rtlCol="0" anchor="ctr"/>
+          <a:lstStyle/>
+          <a:p>
+            <a:pPr algn="ctr"/>
+          </a:p>
+        </p:txBody>
+      </p:sp>
+      <p:sp>
+        <p:nvSpPr>
+          <p:cNvPr id="8" name="TextBox 7"/>
+          <p:cNvSpPr txBox="1"/>
+          <p:nvPr/>
+        </p:nvSpPr>
+        <p:spPr>
+          <a:xfrm>
+            <a:off x="6400800" y="1280160"/>
+            <a:ext cx="5303520" cy="365760"/>
+          </a:xfrm>
+          <a:prstGeom prst="rect">
+            <a:avLst/>
+          </a:prstGeom>
+          <a:noFill/>
+        </p:spPr>
+        <p:txBody>
+          <a:bodyPr wrap="square">
+            <a:spAutoFit/>
+          </a:bodyPr>
+          <a:lstStyle/>
+          <a:p>
+            <a:pPr algn="l">
+              <a:defRPr sz="1800" b="1">
+                <a:solidFill>
+                  <a:srgbClr val="0096D6"/>
+                </a:solidFill>
+                <a:latin typeface="Calibri"/>
+              </a:defRPr>
+            </a:pPr>
+            <a:r>
+              <a:t>1. Kurulum</a:t>
+            </a:r>
+          </a:p>
+        </p:txBody>
+      </p:sp>
+      <p:sp>
+        <p:nvSpPr>
+          <p:cNvPr id="9" name="TextBox 8"/>
+          <p:cNvSpPr txBox="1"/>
+          <p:nvPr/>
+        </p:nvSpPr>
+        <p:spPr>
+          <a:xfrm>
+            <a:off x="6400800" y="1737360"/>
+            <a:ext cx="5303520" cy="365760"/>
+          </a:xfrm>
+          <a:prstGeom prst="rect">
+            <a:avLst/>
+          </a:prstGeom>
+          <a:noFill/>
+        </p:spPr>
+        <p:txBody>
+          <a:bodyPr wrap="square">
+            <a:spAutoFit/>
+          </a:bodyPr>
+          <a:lstStyle/>
+          <a:p>
+            <a:pPr algn="l">
+              <a:defRPr sz="1400" b="0">
+                <a:solidFill>
+                  <a:srgbClr val="333333"/>
+                </a:solidFill>
+                <a:latin typeface="Calibri"/>
+              </a:defRPr>
+            </a:pPr>
+            <a:r>
+              <a:t>Maven Central'dan JAR indirildi:</a:t>
+            </a:r>
+          </a:p>
+        </p:txBody>
+      </p:sp>
+      <p:sp>
+        <p:nvSpPr>
+          <p:cNvPr id="10" name="Rectangle 9"/>
+          <p:cNvSpPr/>
+          <p:nvPr/>
+        </p:nvSpPr>
+        <p:spPr>
+          <a:xfrm>
+            <a:off x="6400800" y="2194560"/>
+            <a:ext cx="5303520" cy="640080"/>
+          </a:xfrm>
+          <a:prstGeom prst="rect">
+            <a:avLst/>
+          </a:prstGeom>
+          <a:solidFill>
+            <a:srgbClr val="2D2D2D"/>
+          </a:solidFill>
+          <a:ln>
+            <a:noFill/>
+          </a:ln>
+        </p:spPr>
+        <p:style>
+          <a:lnRef idx="1">
+            <a:schemeClr val="accent1"/>
+          </a:lnRef>
+          <a:fillRef idx="3">
+            <a:schemeClr val="accent1"/>
+          </a:fillRef>
+          <a:effectRef idx="2">
+            <a:schemeClr val="accent1"/>
+          </a:effectRef>
+          <a:fontRef idx="minor">
+            <a:schemeClr val="lt1"/>
+          </a:fontRef>
+        </p:style>
+        <p:txBody>
+          <a:bodyPr rtlCol="0" anchor="ctr"/>
+          <a:lstStyle/>
+          <a:p>
+            <a:pPr algn="ctr"/>
+          </a:p>
+        </p:txBody>
+      </p:sp>
+      <p:sp>
+        <p:nvSpPr>
+          <p:cNvPr id="11" name="TextBox 10"/>
+          <p:cNvSpPr txBox="1"/>
+          <p:nvPr/>
+        </p:nvSpPr>
+        <p:spPr>
+          <a:xfrm>
+            <a:off x="6492240" y="2240280"/>
+            <a:ext cx="5120640" cy="548640"/>
+          </a:xfrm>
+          <a:prstGeom prst="rect">
+            <a:avLst/>
+          </a:prstGeom>
+          <a:noFill/>
+        </p:spPr>
+        <p:txBody>
+          <a:bodyPr wrap="square">
+            <a:spAutoFit/>
+          </a:bodyPr>
+          <a:lstStyle/>
+          <a:p>
+            <a:pPr algn="l">
+              <a:defRPr sz="1100" b="0">
+                <a:solidFill>
+                  <a:srgbClr val="2ECC71"/>
+                </a:solidFill>
+                <a:latin typeface="Calibri"/>
+              </a:defRPr>
+            </a:pPr>
+            <a:r>
+              <a:t>curl -L -o ck-0.7.0-jar-with-dependencies.jar \</a:t>
+            </a:r>
+            <a:br/>
+            <a:r>
+              <a:t>  "https://repo1.maven.org/.../ck-0.7.0-..."</a:t>
+            </a:r>
+          </a:p>
+        </p:txBody>
+      </p:sp>
+      <p:sp>
+        <p:nvSpPr>
+          <p:cNvPr id="12" name="Rectangle 11"/>
+          <p:cNvSpPr/>
+          <p:nvPr/>
+        </p:nvSpPr>
+        <p:spPr>
+          <a:xfrm>
+            <a:off x="6217920" y="3931920"/>
+            <a:ext cx="5669280" cy="2743200"/>
+          </a:xfrm>
+          <a:prstGeom prst="rect">
+            <a:avLst/>
+          </a:prstGeom>
+          <a:solidFill>
+            <a:srgbClr val="FFFFFF"/>
+          </a:solidFill>
+          <a:ln>
+            <a:noFill/>
+          </a:ln>
+        </p:spPr>
+        <p:style>
+          <a:lnRef idx="1">
+            <a:schemeClr val="accent1"/>
+          </a:lnRef>
+          <a:fillRef idx="3">
+            <a:schemeClr val="accent1"/>
+          </a:fillRef>
+          <a:effectRef idx="2">
+            <a:schemeClr val="accent1"/>
+          </a:effectRef>
+          <a:fontRef idx="minor">
+            <a:schemeClr val="lt1"/>
+          </a:fontRef>
+        </p:style>
+        <p:txBody>
+          <a:bodyPr rtlCol="0" anchor="ctr"/>
+          <a:lstStyle/>
+          <a:p>
+            <a:pPr algn="ctr"/>
+          </a:p>
+        </p:txBody>
+      </p:sp>
+      <p:sp>
+        <p:nvSpPr>
+          <p:cNvPr id="13" name="TextBox 12"/>
+          <p:cNvSpPr txBox="1"/>
+          <p:nvPr/>
+        </p:nvSpPr>
+        <p:spPr>
+          <a:xfrm>
+            <a:off x="6400800" y="4023360"/>
+            <a:ext cx="5303520" cy="365760"/>
+          </a:xfrm>
+          <a:prstGeom prst="rect">
+            <a:avLst/>
+          </a:prstGeom>
+          <a:noFill/>
+        </p:spPr>
+        <p:txBody>
+          <a:bodyPr wrap="square">
+            <a:spAutoFit/>
+          </a:bodyPr>
+          <a:lstStyle/>
+          <a:p>
+            <a:pPr algn="l">
+              <a:defRPr sz="1800" b="1">
+                <a:solidFill>
+                  <a:srgbClr val="0096D6"/>
+                </a:solidFill>
+                <a:latin typeface="Calibri"/>
+              </a:defRPr>
+            </a:pPr>
+            <a:r>
+              <a:t>2. Calistirma Komutu</a:t>
+            </a:r>
+          </a:p>
+        </p:txBody>
+      </p:sp>
+      <p:sp>
+        <p:nvSpPr>
+          <p:cNvPr id="14" name="TextBox 13"/>
+          <p:cNvSpPr txBox="1"/>
+          <p:nvPr/>
+        </p:nvSpPr>
+        <p:spPr>
+          <a:xfrm>
+            <a:off x="6400800" y="4480560"/>
+            <a:ext cx="5303520" cy="365760"/>
+          </a:xfrm>
+          <a:prstGeom prst="rect">
+            <a:avLst/>
+          </a:prstGeom>
+          <a:noFill/>
+        </p:spPr>
+        <p:txBody>
+          <a:bodyPr wrap="square">
+            <a:spAutoFit/>
+          </a:bodyPr>
+          <a:lstStyle/>
+          <a:p>
+            <a:pPr algn="l">
+              <a:defRPr sz="1400" b="0">
+                <a:solidFill>
+                  <a:srgbClr val="333333"/>
+                </a:solidFill>
+                <a:latin typeface="Calibri"/>
+              </a:defRPr>
+            </a:pPr>
+            <a:r>
+              <a:t>Her surum icin tek komutla:</a:t>
+            </a:r>
+          </a:p>
+        </p:txBody>
+      </p:sp>
+      <p:sp>
+        <p:nvSpPr>
+          <p:cNvPr id="15" name="Rectangle 14"/>
+          <p:cNvSpPr/>
+          <p:nvPr/>
+        </p:nvSpPr>
+        <p:spPr>
+          <a:xfrm>
+            <a:off x="6400800" y="4846320"/>
+            <a:ext cx="5303520" cy="1554480"/>
+          </a:xfrm>
+          <a:prstGeom prst="rect">
+            <a:avLst/>
+          </a:prstGeom>
+          <a:solidFill>
+            <a:srgbClr val="2D2D2D"/>
+          </a:solidFill>
+          <a:ln>
+            <a:noFill/>
+          </a:ln>
+        </p:spPr>
+        <p:style>
+          <a:lnRef idx="1">
+            <a:schemeClr val="accent1"/>
+          </a:lnRef>
+          <a:fillRef idx="3">
+            <a:schemeClr val="accent1"/>
+          </a:fillRef>
+          <a:effectRef idx="2">
+            <a:schemeClr val="accent1"/>
+          </a:effectRef>
+          <a:fontRef idx="minor">
+            <a:schemeClr val="lt1"/>
+          </a:fontRef>
+        </p:style>
+        <p:txBody>
+          <a:bodyPr rtlCol="0" anchor="ctr"/>
+          <a:lstStyle/>
+          <a:p>
+            <a:pPr algn="ctr"/>
+          </a:p>
+        </p:txBody>
+      </p:sp>
+      <p:sp>
+        <p:nvSpPr>
+          <p:cNvPr id="16" name="TextBox 15"/>
+          <p:cNvSpPr txBox="1"/>
+          <p:nvPr/>
+        </p:nvSpPr>
+        <p:spPr>
+          <a:xfrm>
+            <a:off x="6492240" y="4892040"/>
+            <a:ext cx="5120640" cy="1463040"/>
+          </a:xfrm>
+          <a:prstGeom prst="rect">
+            <a:avLst/>
+          </a:prstGeom>
+          <a:noFill/>
+        </p:spPr>
+        <p:txBody>
+          <a:bodyPr wrap="square">
+            <a:spAutoFit/>
+          </a:bodyPr>
+          <a:lstStyle/>
+          <a:p>
+            <a:pPr algn="l">
+              <a:defRPr sz="1200" b="0">
+                <a:solidFill>
+                  <a:srgbClr val="2ECC71"/>
+                </a:solidFill>
+                <a:latin typeface="Calibri"/>
+              </a:defRPr>
+            </a:pPr>
+            <a:r>
+              <a:t>java -jar ck-0.7.0-jar-with-dependencies.jar \</a:t>
+            </a:r>
+            <a:br/>
+            <a:r>
+              <a:t>  "anomaly-detection/src/main/java" \</a:t>
+            </a:r>
+            <a:br/>
+            <a:r>
+              <a:t>  false \     # anonym siniflar</a:t>
+            </a:r>
+            <a:br/>
+            <a:r>
+              <a:t>  0 \         # metrik esik</a:t>
+            </a:r>
+            <a:br/>
+            <a:r>
+              <a:t>  false \     # JAR dahil mi</a:t>
+            </a:r>
+            <a:br/>
+            <a:r>
+              <a:t>  "metrics/1.0.0.0/"  # cikti dizini</a:t>
             </a:r>
           </a:p>
         </p:txBody>

</xml_diff>

<commit_message>
Sunuma OpenSearch Anomaly Detection açıklama slaytları eklendi (12 → 14)
- Slayt 3: OpenSearch nedir, kullanım senaryoları, 4 adımlı çalışma akışı
- Slayt 4: Java bileşenleri, RCF algoritması, neden QMOOD'a uygun, v2.16 açıklaması

Co-Authored-By: Claude Opus 4.6 (1M context) <noreply@anthropic.com>
</commit_message>
<xml_diff>
--- a/sunum.pptx
+++ b/sunum.pptx
@@ -7,6 +7,8 @@
   <p:sldIdLst>
     <p:sldId id="256" r:id="rId7"/>
     <p:sldId id="257" r:id="rId9"/>
+    <p:sldId id="268" r:id="rId20"/>
+    <p:sldId id="269" r:id="rId21"/>
     <p:sldId id="258" r:id="rId10"/>
     <p:sldId id="259" r:id="rId11"/>
     <p:sldId id="264" r:id="rId16"/>
@@ -882,6 +884,248 @@
           <a:p>
             <a:r>
               <a:t>En kritik degisimler: DAM yuzde 22 dustu (kapsulleme kaybi) ve DCC yuzde 22 artti (bagimlilik artisi). Bu ikisi birlikte Flexibility ve Extendibility'nin cokmesine neden oldu.</a:t>
+            </a:r>
+          </a:p>
+        </p:txBody>
+      </p:sp>
+      <p:sp>
+        <p:nvSpPr>
+          <p:cNvPr id="4" name="Slide Number Placeholder 3"/>
+          <p:cNvSpPr>
+            <a:spLocks noGrp="1"/>
+          </p:cNvSpPr>
+          <p:nvPr>
+            <p:ph type="sldNum" idx="5" sz="quarter"/>
+          </p:nvPr>
+        </p:nvSpPr>
+        <p:spPr/>
+      </p:sp>
+    </p:spTree>
+  </p:cSld>
+  <p:clrMapOvr>
+    <a:masterClrMapping/>
+  </p:clrMapOvr>
+</p:notes>
+</file>
+
+<file path=ppt/notesSlides/notesSlide13.xml><?xml version="1.0" encoding="utf-8"?>
+<p:notes xmlns:a="http://schemas.openxmlformats.org/drawingml/2006/main" xmlns:p="http://schemas.openxmlformats.org/presentationml/2006/main" xmlns:r="http://schemas.openxmlformats.org/officeDocument/2006/relationships">
+  <p:cSld>
+    <p:spTree>
+      <p:nvGrpSpPr>
+        <p:cNvPr id="1" name=""/>
+        <p:cNvGrpSpPr/>
+        <p:nvPr/>
+      </p:nvGrpSpPr>
+      <p:grpSpPr>
+        <a:xfrm>
+          <a:off x="0" y="0"/>
+          <a:ext cx="0" cy="0"/>
+          <a:chOff x="0" y="0"/>
+          <a:chExt cx="0" cy="0"/>
+        </a:xfrm>
+      </p:grpSpPr>
+      <p:sp>
+        <p:nvSpPr>
+          <p:cNvPr id="2" name="Slide Image Placeholder 1"/>
+          <p:cNvSpPr>
+            <a:spLocks noGrp="1"/>
+          </p:cNvSpPr>
+          <p:nvPr>
+            <p:ph type="sldImg" idx="2"/>
+          </p:nvPr>
+        </p:nvSpPr>
+        <p:spPr/>
+      </p:sp>
+      <p:sp>
+        <p:nvSpPr>
+          <p:cNvPr id="3" name="Notes Placeholder 2"/>
+          <p:cNvSpPr>
+            <a:spLocks noGrp="1"/>
+          </p:cNvSpPr>
+          <p:nvPr>
+            <p:ph type="body" idx="3" sz="quarter"/>
+          </p:nvPr>
+        </p:nvSpPr>
+        <p:spPr/>
+        <p:txBody>
+          <a:bodyPr/>
+          <a:lstStyle/>
+          <a:p>
+            <a:r>
+              <a:t>OPENSEARCH ANOMALY DETECTION NEDIR (50 sn):</a:t>
+            </a:r>
+          </a:p>
+          <a:p>
+            <a:r>
+              <a:t>Projemizin analiz ettigi yazilimi taniyalim.</a:t>
+            </a:r>
+          </a:p>
+          <a:p/>
+          <a:p>
+            <a:r>
+              <a:t>OpenSearch, Amazon'un gelistirdigi acik kaynak bir arama ve analiz platformudur — Elasticsearch'un forkudur. Anomaly Detection ise bu platformun bir eklentisi — zaman serisi verilerinde otomatik olarak anomalileri tespit eder.</a:t>
+            </a:r>
+          </a:p>
+          <a:p/>
+          <a:p>
+            <a:r>
+              <a:t>Ornek verelim: Bir e-ticaret sitesinde saatte normalde 500-700 siparis vardir. Aniden 50'ye duserse veya 5000'e firlarsa, Anomaly Detection bunu otomatik algilar ve uyari verir.</a:t>
+            </a:r>
+          </a:p>
+          <a:p/>
+          <a:p>
+            <a:r>
+              <a:t>Kullanim alanlari cok genis: sunucu izleme, ag guvenligi, IoT sensorleri, uygulama loglari...</a:t>
+            </a:r>
+          </a:p>
+          <a:p/>
+          <a:p>
+            <a:r>
+              <a:t>4 adimli calisma prensibi var:</a:t>
+            </a:r>
+          </a:p>
+          <a:p>
+            <a:r>
+              <a:t>1. Veri toplama — OpenSearch indexlerinden periyodik olarak okur</a:t>
+            </a:r>
+          </a:p>
+          <a:p>
+            <a:r>
+              <a:t>2. Model egitimi — Random Cut Forest algoritmasi ile normalin ne oldugunu ogrenir</a:t>
+            </a:r>
+          </a:p>
+          <a:p>
+            <a:r>
+              <a:t>3. Anomali tespiti — yeni gelen veriyi modelle karsilastirir, skor hesaplar</a:t>
+            </a:r>
+          </a:p>
+          <a:p>
+            <a:r>
+              <a:t>4. Sonuc — anomali tespit edilirse uyari gonderir</a:t>
+            </a:r>
+          </a:p>
+        </p:txBody>
+      </p:sp>
+      <p:sp>
+        <p:nvSpPr>
+          <p:cNvPr id="4" name="Slide Number Placeholder 3"/>
+          <p:cNvSpPr>
+            <a:spLocks noGrp="1"/>
+          </p:cNvSpPr>
+          <p:nvPr>
+            <p:ph type="sldNum" idx="5" sz="quarter"/>
+          </p:nvPr>
+        </p:nvSpPr>
+        <p:spPr/>
+      </p:sp>
+    </p:spTree>
+  </p:cSld>
+  <p:clrMapOvr>
+    <a:masterClrMapping/>
+  </p:clrMapOvr>
+</p:notes>
+</file>
+
+<file path=ppt/notesSlides/notesSlide14.xml><?xml version="1.0" encoding="utf-8"?>
+<p:notes xmlns:a="http://schemas.openxmlformats.org/drawingml/2006/main" xmlns:p="http://schemas.openxmlformats.org/presentationml/2006/main" xmlns:r="http://schemas.openxmlformats.org/officeDocument/2006/relationships">
+  <p:cSld>
+    <p:spTree>
+      <p:nvGrpSpPr>
+        <p:cNvPr id="1" name=""/>
+        <p:cNvGrpSpPr/>
+        <p:nvPr/>
+      </p:nvGrpSpPr>
+      <p:grpSpPr>
+        <a:xfrm>
+          <a:off x="0" y="0"/>
+          <a:ext cx="0" cy="0"/>
+          <a:chOff x="0" y="0"/>
+          <a:chExt cx="0" cy="0"/>
+        </a:xfrm>
+      </p:grpSpPr>
+      <p:sp>
+        <p:nvSpPr>
+          <p:cNvPr id="2" name="Slide Image Placeholder 1"/>
+          <p:cNvSpPr>
+            <a:spLocks noGrp="1"/>
+          </p:cNvSpPr>
+          <p:nvPr>
+            <p:ph type="sldImg" idx="2"/>
+          </p:nvPr>
+        </p:nvSpPr>
+        <p:spPr/>
+      </p:sp>
+      <p:sp>
+        <p:nvSpPr>
+          <p:cNvPr id="3" name="Notes Placeholder 2"/>
+          <p:cNvSpPr>
+            <a:spLocks noGrp="1"/>
+          </p:cNvSpPr>
+          <p:nvPr>
+            <p:ph type="body" idx="3" sz="quarter"/>
+          </p:nvPr>
+        </p:nvSpPr>
+        <p:spPr/>
+        <p:txBody>
+          <a:bodyPr/>
+          <a:lstStyle/>
+          <a:p>
+            <a:r>
+              <a:t>JAVA BILESENLERI VE NEDEN BU PROJE (50 sn):</a:t>
+            </a:r>
+          </a:p>
+          <a:p>
+            <a:r>
+              <a:t>Projenin Java kod yapisi 7 ana bilesenden olusuyor:</a:t>
+            </a:r>
+          </a:p>
+          <a:p/>
+          <a:p>
+            <a:r>
+              <a:t>Detector — anomali dedektoru tanimlar, hangi veri kaynagi, hangi alan, ne siklikla kontrol edilecek.</a:t>
+            </a:r>
+          </a:p>
+          <a:p>
+            <a:r>
+              <a:t>Model — Random Cut Forest makine ogrenmesi modeli, projenin kalbi.</a:t>
+            </a:r>
+          </a:p>
+          <a:p>
+            <a:r>
+              <a:t>Runner — dedektoru periyodik olarak calistirir.</a:t>
+            </a:r>
+          </a:p>
+          <a:p>
+            <a:r>
+              <a:t>Result — tespit edilen anomalileri saklar.</a:t>
+            </a:r>
+          </a:p>
+          <a:p>
+            <a:r>
+              <a:t>REST API — kullanicinin dedektoru olusturma ve yonetme arayuzu.</a:t>
+            </a:r>
+          </a:p>
+          <a:p>
+            <a:r>
+              <a:t>Transport — OpenSearch dugumleri arasi iletisim.</a:t>
+            </a:r>
+          </a:p>
+          <a:p>
+            <a:r>
+              <a:t>Feature — ham veriden ozellik cikarma.</a:t>
+            </a:r>
+          </a:p>
+          <a:p/>
+          <a:p>
+            <a:r>
+              <a:t>RCF algoritmasi cok basit bir mantikla calisir: gecmis veriden rastgele agaclar olusturur, yeni gelen veri noktasini agaca eklemeye calisir. Eger bu ekleme agaci cok degistiriyorsa — yani veri beklenmedik bir yerde — anomali skoru yuksek cikar.</a:t>
+            </a:r>
+          </a:p>
+          <a:p/>
+          <a:p>
+            <a:r>
+              <a:t>Bu proje QMOOD icin ideal cunku: Java dilinde, CK Tool uyumlu. Boyutu makul — 288 ile 609 sinif arasi. OOP yapisi zengin. 70'ten fazla release tag'i var. Ve en onemlisi v2.16'da buyuk bir yapisal degisiklik var — 227 yeni sinif eklenmis. Bu bize analiz icin mukemmel bir kirilma noktasi sagliyor.</a:t>
             </a:r>
           </a:p>
         </p:txBody>
@@ -7340,6 +7584,3959 @@
             </a:pPr>
             <a:r>
               <a:t>Tesekkurler  —  Sorularinizi bekliyorum</a:t>
+            </a:r>
+          </a:p>
+        </p:txBody>
+      </p:sp>
+    </p:spTree>
+  </p:cSld>
+  <p:clrMapOvr>
+    <a:masterClrMapping/>
+  </p:clrMapOvr>
+</p:sld>
+</file>
+
+<file path=ppt/slides/slide13.xml><?xml version="1.0" encoding="utf-8"?>
+<p:sld xmlns:a="http://schemas.openxmlformats.org/drawingml/2006/main" xmlns:p="http://schemas.openxmlformats.org/presentationml/2006/main" xmlns:r="http://schemas.openxmlformats.org/officeDocument/2006/relationships">
+  <p:cSld>
+    <p:bg>
+      <p:bgPr>
+        <a:solidFill>
+          <a:srgbClr val="F5F6FA"/>
+        </a:solidFill>
+        <a:effectLst/>
+      </p:bgPr>
+    </p:bg>
+    <p:spTree>
+      <p:nvGrpSpPr>
+        <p:cNvPr id="1" name=""/>
+        <p:cNvGrpSpPr/>
+        <p:nvPr/>
+      </p:nvGrpSpPr>
+      <p:grpSpPr/>
+      <p:sp>
+        <p:nvSpPr>
+          <p:cNvPr id="2" name="Rectangle 1"/>
+          <p:cNvSpPr/>
+          <p:nvPr/>
+        </p:nvSpPr>
+        <p:spPr>
+          <a:xfrm>
+            <a:off x="0" y="0"/>
+            <a:ext cx="12191695" cy="914400"/>
+          </a:xfrm>
+          <a:prstGeom prst="rect">
+            <a:avLst/>
+          </a:prstGeom>
+          <a:solidFill>
+            <a:srgbClr val="00528A"/>
+          </a:solidFill>
+          <a:ln>
+            <a:noFill/>
+          </a:ln>
+        </p:spPr>
+        <p:style>
+          <a:lnRef idx="1">
+            <a:schemeClr val="accent1"/>
+          </a:lnRef>
+          <a:fillRef idx="3">
+            <a:schemeClr val="accent1"/>
+          </a:fillRef>
+          <a:effectRef idx="2">
+            <a:schemeClr val="accent1"/>
+          </a:effectRef>
+          <a:fontRef idx="minor">
+            <a:schemeClr val="lt1"/>
+          </a:fontRef>
+        </p:style>
+        <p:txBody>
+          <a:bodyPr rtlCol="0" anchor="ctr"/>
+          <a:lstStyle/>
+          <a:p>
+            <a:pPr algn="ctr"/>
+          </a:p>
+        </p:txBody>
+      </p:sp>
+      <p:sp>
+        <p:nvSpPr>
+          <p:cNvPr id="3" name="TextBox 2"/>
+          <p:cNvSpPr txBox="1"/>
+          <p:nvPr/>
+        </p:nvSpPr>
+        <p:spPr>
+          <a:xfrm>
+            <a:off x="731520" y="137160"/>
+            <a:ext cx="10058400" cy="594360"/>
+          </a:xfrm>
+          <a:prstGeom prst="rect">
+            <a:avLst/>
+          </a:prstGeom>
+          <a:noFill/>
+        </p:spPr>
+        <p:txBody>
+          <a:bodyPr wrap="square">
+            <a:spAutoFit/>
+          </a:bodyPr>
+          <a:lstStyle/>
+          <a:p>
+            <a:pPr algn="l">
+              <a:defRPr sz="3000" b="1">
+                <a:solidFill>
+                  <a:srgbClr val="FFFFFF"/>
+                </a:solidFill>
+                <a:latin typeface="Calibri"/>
+              </a:defRPr>
+            </a:pPr>
+            <a:r>
+              <a:t>OpenSearch Anomaly Detection Nedir?</a:t>
+            </a:r>
+          </a:p>
+        </p:txBody>
+      </p:sp>
+      <p:sp>
+        <p:nvSpPr>
+          <p:cNvPr id="4" name="Rectangle 3"/>
+          <p:cNvSpPr/>
+          <p:nvPr/>
+        </p:nvSpPr>
+        <p:spPr>
+          <a:xfrm>
+            <a:off x="274320" y="1097280"/>
+            <a:ext cx="5669280" cy="2560320"/>
+          </a:xfrm>
+          <a:prstGeom prst="rect">
+            <a:avLst/>
+          </a:prstGeom>
+          <a:solidFill>
+            <a:srgbClr val="FFFFFF"/>
+          </a:solidFill>
+          <a:ln>
+            <a:noFill/>
+          </a:ln>
+        </p:spPr>
+        <p:style>
+          <a:lnRef idx="1">
+            <a:schemeClr val="accent1"/>
+          </a:lnRef>
+          <a:fillRef idx="3">
+            <a:schemeClr val="accent1"/>
+          </a:fillRef>
+          <a:effectRef idx="2">
+            <a:schemeClr val="accent1"/>
+          </a:effectRef>
+          <a:fontRef idx="minor">
+            <a:schemeClr val="lt1"/>
+          </a:fontRef>
+        </p:style>
+        <p:txBody>
+          <a:bodyPr rtlCol="0" anchor="ctr"/>
+          <a:lstStyle/>
+          <a:p>
+            <a:pPr algn="ctr"/>
+          </a:p>
+        </p:txBody>
+      </p:sp>
+      <p:sp>
+        <p:nvSpPr>
+          <p:cNvPr id="5" name="TextBox 4"/>
+          <p:cNvSpPr txBox="1"/>
+          <p:nvPr/>
+        </p:nvSpPr>
+        <p:spPr>
+          <a:xfrm>
+            <a:off x="457200" y="1143000"/>
+            <a:ext cx="5303520" cy="320040"/>
+          </a:xfrm>
+          <a:prstGeom prst="rect">
+            <a:avLst/>
+          </a:prstGeom>
+          <a:noFill/>
+        </p:spPr>
+        <p:txBody>
+          <a:bodyPr wrap="square">
+            <a:spAutoFit/>
+          </a:bodyPr>
+          <a:lstStyle/>
+          <a:p>
+            <a:pPr algn="l">
+              <a:defRPr sz="1800" b="1">
+                <a:solidFill>
+                  <a:srgbClr val="00528A"/>
+                </a:solidFill>
+                <a:latin typeface="Calibri"/>
+              </a:defRPr>
+            </a:pPr>
+            <a:r>
+              <a:t>Proje Tanimi</a:t>
+            </a:r>
+          </a:p>
+        </p:txBody>
+      </p:sp>
+      <p:sp>
+        <p:nvSpPr>
+          <p:cNvPr id="6" name="TextBox 5"/>
+          <p:cNvSpPr txBox="1"/>
+          <p:nvPr/>
+        </p:nvSpPr>
+        <p:spPr>
+          <a:xfrm>
+            <a:off x="457200" y="1508760"/>
+            <a:ext cx="5303520" cy="2011680"/>
+          </a:xfrm>
+          <a:prstGeom prst="rect">
+            <a:avLst/>
+          </a:prstGeom>
+          <a:noFill/>
+        </p:spPr>
+        <p:txBody>
+          <a:bodyPr wrap="square">
+            <a:spAutoFit/>
+          </a:bodyPr>
+          <a:lstStyle/>
+          <a:p>
+            <a:pPr>
+              <a:spcAft>
+                <a:spcPts val="200"/>
+              </a:spcAft>
+              <a:defRPr sz="1300">
+                <a:solidFill>
+                  <a:srgbClr val="333333"/>
+                </a:solidFill>
+                <a:latin typeface="Calibri"/>
+              </a:defRPr>
+            </a:pPr>
+            <a:r>
+              <a:t>OpenSearch: Amazon'un gelistirdigi acik kaynak</a:t>
+            </a:r>
+          </a:p>
+          <a:p>
+            <a:pPr>
+              <a:spcAft>
+                <a:spcPts val="200"/>
+              </a:spcAft>
+              <a:defRPr sz="1300">
+                <a:solidFill>
+                  <a:srgbClr val="333333"/>
+                </a:solidFill>
+                <a:latin typeface="Calibri"/>
+              </a:defRPr>
+            </a:pPr>
+            <a:r>
+              <a:t>arama ve analiz platformu (Elasticsearch forku)</a:t>
+            </a:r>
+          </a:p>
+          <a:p>
+            <a:pPr>
+              <a:spcAft>
+                <a:spcPts val="200"/>
+              </a:spcAft>
+              <a:defRPr sz="1300">
+                <a:solidFill>
+                  <a:srgbClr val="333333"/>
+                </a:solidFill>
+                <a:latin typeface="Calibri"/>
+              </a:defRPr>
+            </a:pPr>
+          </a:p>
+          <a:p>
+            <a:pPr>
+              <a:spcAft>
+                <a:spcPts val="200"/>
+              </a:spcAft>
+              <a:defRPr sz="1300">
+                <a:solidFill>
+                  <a:srgbClr val="333333"/>
+                </a:solidFill>
+                <a:latin typeface="Calibri"/>
+              </a:defRPr>
+            </a:pPr>
+            <a:r>
+              <a:t>Anomaly Detection: Bu platform uzerinde calisan</a:t>
+            </a:r>
+          </a:p>
+          <a:p>
+            <a:pPr>
+              <a:spcAft>
+                <a:spcPts val="200"/>
+              </a:spcAft>
+              <a:defRPr sz="1300">
+                <a:solidFill>
+                  <a:srgbClr val="333333"/>
+                </a:solidFill>
+                <a:latin typeface="Calibri"/>
+              </a:defRPr>
+            </a:pPr>
+            <a:r>
+              <a:t>bir eklenti — zaman serisi verilerinde otomatik</a:t>
+            </a:r>
+          </a:p>
+          <a:p>
+            <a:pPr>
+              <a:spcAft>
+                <a:spcPts val="200"/>
+              </a:spcAft>
+              <a:defRPr sz="1300">
+                <a:solidFill>
+                  <a:srgbClr val="333333"/>
+                </a:solidFill>
+                <a:latin typeface="Calibri"/>
+              </a:defRPr>
+            </a:pPr>
+            <a:r>
+              <a:t>olarak anormallikleri (anomalileri) tespit eder.</a:t>
+            </a:r>
+          </a:p>
+          <a:p>
+            <a:pPr>
+              <a:spcAft>
+                <a:spcPts val="200"/>
+              </a:spcAft>
+              <a:defRPr sz="1300">
+                <a:solidFill>
+                  <a:srgbClr val="333333"/>
+                </a:solidFill>
+                <a:latin typeface="Calibri"/>
+              </a:defRPr>
+            </a:pPr>
+          </a:p>
+          <a:p>
+            <a:pPr>
+              <a:spcAft>
+                <a:spcPts val="200"/>
+              </a:spcAft>
+              <a:defRPr sz="1300">
+                <a:solidFill>
+                  <a:srgbClr val="333333"/>
+                </a:solidFill>
+                <a:latin typeface="Calibri"/>
+              </a:defRPr>
+            </a:pPr>
+            <a:r>
+              <a:t>Ornek: Saatte 500-700 siparis olan bir sitede</a:t>
+            </a:r>
+          </a:p>
+          <a:p>
+            <a:pPr>
+              <a:spcAft>
+                <a:spcPts val="200"/>
+              </a:spcAft>
+              <a:defRPr sz="1300">
+                <a:solidFill>
+                  <a:srgbClr val="333333"/>
+                </a:solidFill>
+                <a:latin typeface="Calibri"/>
+              </a:defRPr>
+            </a:pPr>
+            <a:r>
+              <a:t>aniden 50'ye dusmesi veya 5000'e firlamasi</a:t>
+            </a:r>
+          </a:p>
+          <a:p>
+            <a:pPr>
+              <a:spcAft>
+                <a:spcPts val="200"/>
+              </a:spcAft>
+              <a:defRPr sz="1300">
+                <a:solidFill>
+                  <a:srgbClr val="333333"/>
+                </a:solidFill>
+                <a:latin typeface="Calibri"/>
+              </a:defRPr>
+            </a:pPr>
+            <a:r>
+              <a:t>-&gt; Anomaly Detection bunu otomatik algilar</a:t>
+            </a:r>
+          </a:p>
+        </p:txBody>
+      </p:sp>
+      <p:sp>
+        <p:nvSpPr>
+          <p:cNvPr id="7" name="Rectangle 6"/>
+          <p:cNvSpPr/>
+          <p:nvPr/>
+        </p:nvSpPr>
+        <p:spPr>
+          <a:xfrm>
+            <a:off x="6217920" y="1097280"/>
+            <a:ext cx="5669280" cy="2560320"/>
+          </a:xfrm>
+          <a:prstGeom prst="rect">
+            <a:avLst/>
+          </a:prstGeom>
+          <a:solidFill>
+            <a:srgbClr val="FFFFFF"/>
+          </a:solidFill>
+          <a:ln>
+            <a:noFill/>
+          </a:ln>
+        </p:spPr>
+        <p:style>
+          <a:lnRef idx="1">
+            <a:schemeClr val="accent1"/>
+          </a:lnRef>
+          <a:fillRef idx="3">
+            <a:schemeClr val="accent1"/>
+          </a:fillRef>
+          <a:effectRef idx="2">
+            <a:schemeClr val="accent1"/>
+          </a:effectRef>
+          <a:fontRef idx="minor">
+            <a:schemeClr val="lt1"/>
+          </a:fontRef>
+        </p:style>
+        <p:txBody>
+          <a:bodyPr rtlCol="0" anchor="ctr"/>
+          <a:lstStyle/>
+          <a:p>
+            <a:pPr algn="ctr"/>
+          </a:p>
+        </p:txBody>
+      </p:sp>
+      <p:sp>
+        <p:nvSpPr>
+          <p:cNvPr id="8" name="TextBox 7"/>
+          <p:cNvSpPr txBox="1"/>
+          <p:nvPr/>
+        </p:nvSpPr>
+        <p:spPr>
+          <a:xfrm>
+            <a:off x="6400800" y="1143000"/>
+            <a:ext cx="5303520" cy="320040"/>
+          </a:xfrm>
+          <a:prstGeom prst="rect">
+            <a:avLst/>
+          </a:prstGeom>
+          <a:noFill/>
+        </p:spPr>
+        <p:txBody>
+          <a:bodyPr wrap="square">
+            <a:spAutoFit/>
+          </a:bodyPr>
+          <a:lstStyle/>
+          <a:p>
+            <a:pPr algn="l">
+              <a:defRPr sz="1800" b="1">
+                <a:solidFill>
+                  <a:srgbClr val="00528A"/>
+                </a:solidFill>
+                <a:latin typeface="Calibri"/>
+              </a:defRPr>
+            </a:pPr>
+            <a:r>
+              <a:t>Gercek Kullanim Senaryolari</a:t>
+            </a:r>
+          </a:p>
+        </p:txBody>
+      </p:sp>
+      <p:sp>
+        <p:nvSpPr>
+          <p:cNvPr id="9" name="Rectangle 8"/>
+          <p:cNvSpPr/>
+          <p:nvPr/>
+        </p:nvSpPr>
+        <p:spPr>
+          <a:xfrm>
+            <a:off x="6309360" y="1554480"/>
+            <a:ext cx="109728" cy="347472"/>
+          </a:xfrm>
+          <a:prstGeom prst="rect">
+            <a:avLst/>
+          </a:prstGeom>
+          <a:solidFill>
+            <a:srgbClr val="E74C3C"/>
+          </a:solidFill>
+          <a:ln>
+            <a:noFill/>
+          </a:ln>
+        </p:spPr>
+        <p:style>
+          <a:lnRef idx="1">
+            <a:schemeClr val="accent1"/>
+          </a:lnRef>
+          <a:fillRef idx="3">
+            <a:schemeClr val="accent1"/>
+          </a:fillRef>
+          <a:effectRef idx="2">
+            <a:schemeClr val="accent1"/>
+          </a:effectRef>
+          <a:fontRef idx="minor">
+            <a:schemeClr val="lt1"/>
+          </a:fontRef>
+        </p:style>
+        <p:txBody>
+          <a:bodyPr rtlCol="0" anchor="ctr"/>
+          <a:lstStyle/>
+          <a:p>
+            <a:pPr algn="ctr"/>
+          </a:p>
+        </p:txBody>
+      </p:sp>
+      <p:sp>
+        <p:nvSpPr>
+          <p:cNvPr id="10" name="TextBox 9"/>
+          <p:cNvSpPr txBox="1"/>
+          <p:nvPr/>
+        </p:nvSpPr>
+        <p:spPr>
+          <a:xfrm>
+            <a:off x="6492240" y="1536192"/>
+            <a:ext cx="1463040" cy="182880"/>
+          </a:xfrm>
+          <a:prstGeom prst="rect">
+            <a:avLst/>
+          </a:prstGeom>
+          <a:noFill/>
+        </p:spPr>
+        <p:txBody>
+          <a:bodyPr wrap="square">
+            <a:spAutoFit/>
+          </a:bodyPr>
+          <a:lstStyle/>
+          <a:p>
+            <a:pPr algn="l">
+              <a:defRPr sz="1100" b="1">
+                <a:solidFill>
+                  <a:srgbClr val="E74C3C"/>
+                </a:solidFill>
+                <a:latin typeface="Calibri"/>
+              </a:defRPr>
+            </a:pPr>
+            <a:r>
+              <a:t>Sunucu Izleme</a:t>
+            </a:r>
+          </a:p>
+        </p:txBody>
+      </p:sp>
+      <p:sp>
+        <p:nvSpPr>
+          <p:cNvPr id="11" name="TextBox 10"/>
+          <p:cNvSpPr txBox="1"/>
+          <p:nvPr/>
+        </p:nvSpPr>
+        <p:spPr>
+          <a:xfrm>
+            <a:off x="7955279" y="1536192"/>
+            <a:ext cx="1463040" cy="182880"/>
+          </a:xfrm>
+          <a:prstGeom prst="rect">
+            <a:avLst/>
+          </a:prstGeom>
+          <a:noFill/>
+        </p:spPr>
+        <p:txBody>
+          <a:bodyPr wrap="square">
+            <a:spAutoFit/>
+          </a:bodyPr>
+          <a:lstStyle/>
+          <a:p>
+            <a:pPr algn="l">
+              <a:defRPr sz="1000" b="0">
+                <a:solidFill>
+                  <a:srgbClr val="333333"/>
+                </a:solidFill>
+                <a:latin typeface="Calibri"/>
+              </a:defRPr>
+            </a:pPr>
+            <a:r>
+              <a:t>CPU, bellek, disk</a:t>
+            </a:r>
+          </a:p>
+        </p:txBody>
+      </p:sp>
+      <p:sp>
+        <p:nvSpPr>
+          <p:cNvPr id="12" name="TextBox 11"/>
+          <p:cNvSpPr txBox="1"/>
+          <p:nvPr/>
+        </p:nvSpPr>
+        <p:spPr>
+          <a:xfrm>
+            <a:off x="9418320" y="1536192"/>
+            <a:ext cx="2286000" cy="182880"/>
+          </a:xfrm>
+          <a:prstGeom prst="rect">
+            <a:avLst/>
+          </a:prstGeom>
+          <a:noFill/>
+        </p:spPr>
+        <p:txBody>
+          <a:bodyPr wrap="square">
+            <a:spAutoFit/>
+          </a:bodyPr>
+          <a:lstStyle/>
+          <a:p>
+            <a:pPr algn="l">
+              <a:defRPr sz="1000" b="0">
+                <a:solidFill>
+                  <a:srgbClr val="E74C3C"/>
+                </a:solidFill>
+                <a:latin typeface="Calibri"/>
+              </a:defRPr>
+            </a:pPr>
+            <a:r>
+              <a:t>CPU aniden %95'e cikmasi</a:t>
+            </a:r>
+          </a:p>
+        </p:txBody>
+      </p:sp>
+      <p:sp>
+        <p:nvSpPr>
+          <p:cNvPr id="13" name="Rectangle 12"/>
+          <p:cNvSpPr/>
+          <p:nvPr/>
+        </p:nvSpPr>
+        <p:spPr>
+          <a:xfrm>
+            <a:off x="6309360" y="1938528"/>
+            <a:ext cx="109728" cy="347472"/>
+          </a:xfrm>
+          <a:prstGeom prst="rect">
+            <a:avLst/>
+          </a:prstGeom>
+          <a:solidFill>
+            <a:srgbClr val="FF8C00"/>
+          </a:solidFill>
+          <a:ln>
+            <a:noFill/>
+          </a:ln>
+        </p:spPr>
+        <p:style>
+          <a:lnRef idx="1">
+            <a:schemeClr val="accent1"/>
+          </a:lnRef>
+          <a:fillRef idx="3">
+            <a:schemeClr val="accent1"/>
+          </a:fillRef>
+          <a:effectRef idx="2">
+            <a:schemeClr val="accent1"/>
+          </a:effectRef>
+          <a:fontRef idx="minor">
+            <a:schemeClr val="lt1"/>
+          </a:fontRef>
+        </p:style>
+        <p:txBody>
+          <a:bodyPr rtlCol="0" anchor="ctr"/>
+          <a:lstStyle/>
+          <a:p>
+            <a:pPr algn="ctr"/>
+          </a:p>
+        </p:txBody>
+      </p:sp>
+      <p:sp>
+        <p:nvSpPr>
+          <p:cNvPr id="14" name="TextBox 13"/>
+          <p:cNvSpPr txBox="1"/>
+          <p:nvPr/>
+        </p:nvSpPr>
+        <p:spPr>
+          <a:xfrm>
+            <a:off x="6492240" y="1920240"/>
+            <a:ext cx="1463040" cy="182880"/>
+          </a:xfrm>
+          <a:prstGeom prst="rect">
+            <a:avLst/>
+          </a:prstGeom>
+          <a:noFill/>
+        </p:spPr>
+        <p:txBody>
+          <a:bodyPr wrap="square">
+            <a:spAutoFit/>
+          </a:bodyPr>
+          <a:lstStyle/>
+          <a:p>
+            <a:pPr algn="l">
+              <a:defRPr sz="1100" b="1">
+                <a:solidFill>
+                  <a:srgbClr val="FF8C00"/>
+                </a:solidFill>
+                <a:latin typeface="Calibri"/>
+              </a:defRPr>
+            </a:pPr>
+            <a:r>
+              <a:t>Ag Guvenligi</a:t>
+            </a:r>
+          </a:p>
+        </p:txBody>
+      </p:sp>
+      <p:sp>
+        <p:nvSpPr>
+          <p:cNvPr id="15" name="TextBox 14"/>
+          <p:cNvSpPr txBox="1"/>
+          <p:nvPr/>
+        </p:nvSpPr>
+        <p:spPr>
+          <a:xfrm>
+            <a:off x="7955279" y="1920240"/>
+            <a:ext cx="1463040" cy="182880"/>
+          </a:xfrm>
+          <a:prstGeom prst="rect">
+            <a:avLst/>
+          </a:prstGeom>
+          <a:noFill/>
+        </p:spPr>
+        <p:txBody>
+          <a:bodyPr wrap="square">
+            <a:spAutoFit/>
+          </a:bodyPr>
+          <a:lstStyle/>
+          <a:p>
+            <a:pPr algn="l">
+              <a:defRPr sz="1000" b="0">
+                <a:solidFill>
+                  <a:srgbClr val="333333"/>
+                </a:solidFill>
+                <a:latin typeface="Calibri"/>
+              </a:defRPr>
+            </a:pPr>
+            <a:r>
+              <a:t>Trafik hacmi</a:t>
+            </a:r>
+          </a:p>
+        </p:txBody>
+      </p:sp>
+      <p:sp>
+        <p:nvSpPr>
+          <p:cNvPr id="16" name="TextBox 15"/>
+          <p:cNvSpPr txBox="1"/>
+          <p:nvPr/>
+        </p:nvSpPr>
+        <p:spPr>
+          <a:xfrm>
+            <a:off x="9418320" y="1920240"/>
+            <a:ext cx="2286000" cy="182880"/>
+          </a:xfrm>
+          <a:prstGeom prst="rect">
+            <a:avLst/>
+          </a:prstGeom>
+          <a:noFill/>
+        </p:spPr>
+        <p:txBody>
+          <a:bodyPr wrap="square">
+            <a:spAutoFit/>
+          </a:bodyPr>
+          <a:lstStyle/>
+          <a:p>
+            <a:pPr algn="l">
+              <a:defRPr sz="1000" b="0">
+                <a:solidFill>
+                  <a:srgbClr val="E74C3C"/>
+                </a:solidFill>
+                <a:latin typeface="Calibri"/>
+              </a:defRPr>
+            </a:pPr>
+            <a:r>
+              <a:t>Gece 3'te anormal artis (DDoS?)</a:t>
+            </a:r>
+          </a:p>
+        </p:txBody>
+      </p:sp>
+      <p:sp>
+        <p:nvSpPr>
+          <p:cNvPr id="17" name="Rectangle 16"/>
+          <p:cNvSpPr/>
+          <p:nvPr/>
+        </p:nvSpPr>
+        <p:spPr>
+          <a:xfrm>
+            <a:off x="6309360" y="2322576"/>
+            <a:ext cx="109728" cy="347472"/>
+          </a:xfrm>
+          <a:prstGeom prst="rect">
+            <a:avLst/>
+          </a:prstGeom>
+          <a:solidFill>
+            <a:srgbClr val="0096D6"/>
+          </a:solidFill>
+          <a:ln>
+            <a:noFill/>
+          </a:ln>
+        </p:spPr>
+        <p:style>
+          <a:lnRef idx="1">
+            <a:schemeClr val="accent1"/>
+          </a:lnRef>
+          <a:fillRef idx="3">
+            <a:schemeClr val="accent1"/>
+          </a:fillRef>
+          <a:effectRef idx="2">
+            <a:schemeClr val="accent1"/>
+          </a:effectRef>
+          <a:fontRef idx="minor">
+            <a:schemeClr val="lt1"/>
+          </a:fontRef>
+        </p:style>
+        <p:txBody>
+          <a:bodyPr rtlCol="0" anchor="ctr"/>
+          <a:lstStyle/>
+          <a:p>
+            <a:pPr algn="ctr"/>
+          </a:p>
+        </p:txBody>
+      </p:sp>
+      <p:sp>
+        <p:nvSpPr>
+          <p:cNvPr id="18" name="TextBox 17"/>
+          <p:cNvSpPr txBox="1"/>
+          <p:nvPr/>
+        </p:nvSpPr>
+        <p:spPr>
+          <a:xfrm>
+            <a:off x="6492240" y="2304288"/>
+            <a:ext cx="1463040" cy="182880"/>
+          </a:xfrm>
+          <a:prstGeom prst="rect">
+            <a:avLst/>
+          </a:prstGeom>
+          <a:noFill/>
+        </p:spPr>
+        <p:txBody>
+          <a:bodyPr wrap="square">
+            <a:spAutoFit/>
+          </a:bodyPr>
+          <a:lstStyle/>
+          <a:p>
+            <a:pPr algn="l">
+              <a:defRPr sz="1100" b="1">
+                <a:solidFill>
+                  <a:srgbClr val="0096D6"/>
+                </a:solidFill>
+                <a:latin typeface="Calibri"/>
+              </a:defRPr>
+            </a:pPr>
+            <a:r>
+              <a:t>E-ticaret</a:t>
+            </a:r>
+          </a:p>
+        </p:txBody>
+      </p:sp>
+      <p:sp>
+        <p:nvSpPr>
+          <p:cNvPr id="19" name="TextBox 18"/>
+          <p:cNvSpPr txBox="1"/>
+          <p:nvPr/>
+        </p:nvSpPr>
+        <p:spPr>
+          <a:xfrm>
+            <a:off x="7955279" y="2304288"/>
+            <a:ext cx="1463040" cy="182880"/>
+          </a:xfrm>
+          <a:prstGeom prst="rect">
+            <a:avLst/>
+          </a:prstGeom>
+          <a:noFill/>
+        </p:spPr>
+        <p:txBody>
+          <a:bodyPr wrap="square">
+            <a:spAutoFit/>
+          </a:bodyPr>
+          <a:lstStyle/>
+          <a:p>
+            <a:pPr algn="l">
+              <a:defRPr sz="1000" b="0">
+                <a:solidFill>
+                  <a:srgbClr val="333333"/>
+                </a:solidFill>
+                <a:latin typeface="Calibri"/>
+              </a:defRPr>
+            </a:pPr>
+            <a:r>
+              <a:t>Satis, sayfa goruntulenme</a:t>
+            </a:r>
+          </a:p>
+        </p:txBody>
+      </p:sp>
+      <p:sp>
+        <p:nvSpPr>
+          <p:cNvPr id="20" name="TextBox 19"/>
+          <p:cNvSpPr txBox="1"/>
+          <p:nvPr/>
+        </p:nvSpPr>
+        <p:spPr>
+          <a:xfrm>
+            <a:off x="9418320" y="2304288"/>
+            <a:ext cx="2286000" cy="182880"/>
+          </a:xfrm>
+          <a:prstGeom prst="rect">
+            <a:avLst/>
+          </a:prstGeom>
+          <a:noFill/>
+        </p:spPr>
+        <p:txBody>
+          <a:bodyPr wrap="square">
+            <a:spAutoFit/>
+          </a:bodyPr>
+          <a:lstStyle/>
+          <a:p>
+            <a:pPr algn="l">
+              <a:defRPr sz="1000" b="0">
+                <a:solidFill>
+                  <a:srgbClr val="E74C3C"/>
+                </a:solidFill>
+                <a:latin typeface="Calibri"/>
+              </a:defRPr>
+            </a:pPr>
+            <a:r>
+              <a:t>Odeme sisteminde ani dusus</a:t>
+            </a:r>
+          </a:p>
+        </p:txBody>
+      </p:sp>
+      <p:sp>
+        <p:nvSpPr>
+          <p:cNvPr id="21" name="Rectangle 20"/>
+          <p:cNvSpPr/>
+          <p:nvPr/>
+        </p:nvSpPr>
+        <p:spPr>
+          <a:xfrm>
+            <a:off x="6309360" y="2706624"/>
+            <a:ext cx="109728" cy="347472"/>
+          </a:xfrm>
+          <a:prstGeom prst="rect">
+            <a:avLst/>
+          </a:prstGeom>
+          <a:solidFill>
+            <a:srgbClr val="00897B"/>
+          </a:solidFill>
+          <a:ln>
+            <a:noFill/>
+          </a:ln>
+        </p:spPr>
+        <p:style>
+          <a:lnRef idx="1">
+            <a:schemeClr val="accent1"/>
+          </a:lnRef>
+          <a:fillRef idx="3">
+            <a:schemeClr val="accent1"/>
+          </a:fillRef>
+          <a:effectRef idx="2">
+            <a:schemeClr val="accent1"/>
+          </a:effectRef>
+          <a:fontRef idx="minor">
+            <a:schemeClr val="lt1"/>
+          </a:fontRef>
+        </p:style>
+        <p:txBody>
+          <a:bodyPr rtlCol="0" anchor="ctr"/>
+          <a:lstStyle/>
+          <a:p>
+            <a:pPr algn="ctr"/>
+          </a:p>
+        </p:txBody>
+      </p:sp>
+      <p:sp>
+        <p:nvSpPr>
+          <p:cNvPr id="22" name="TextBox 21"/>
+          <p:cNvSpPr txBox="1"/>
+          <p:nvPr/>
+        </p:nvSpPr>
+        <p:spPr>
+          <a:xfrm>
+            <a:off x="6492240" y="2688336"/>
+            <a:ext cx="1463040" cy="182880"/>
+          </a:xfrm>
+          <a:prstGeom prst="rect">
+            <a:avLst/>
+          </a:prstGeom>
+          <a:noFill/>
+        </p:spPr>
+        <p:txBody>
+          <a:bodyPr wrap="square">
+            <a:spAutoFit/>
+          </a:bodyPr>
+          <a:lstStyle/>
+          <a:p>
+            <a:pPr algn="l">
+              <a:defRPr sz="1100" b="1">
+                <a:solidFill>
+                  <a:srgbClr val="00897B"/>
+                </a:solidFill>
+                <a:latin typeface="Calibri"/>
+              </a:defRPr>
+            </a:pPr>
+            <a:r>
+              <a:t>IoT Sensorleri</a:t>
+            </a:r>
+          </a:p>
+        </p:txBody>
+      </p:sp>
+      <p:sp>
+        <p:nvSpPr>
+          <p:cNvPr id="23" name="TextBox 22"/>
+          <p:cNvSpPr txBox="1"/>
+          <p:nvPr/>
+        </p:nvSpPr>
+        <p:spPr>
+          <a:xfrm>
+            <a:off x="7955279" y="2688336"/>
+            <a:ext cx="1463040" cy="182880"/>
+          </a:xfrm>
+          <a:prstGeom prst="rect">
+            <a:avLst/>
+          </a:prstGeom>
+          <a:noFill/>
+        </p:spPr>
+        <p:txBody>
+          <a:bodyPr wrap="square">
+            <a:spAutoFit/>
+          </a:bodyPr>
+          <a:lstStyle/>
+          <a:p>
+            <a:pPr algn="l">
+              <a:defRPr sz="1000" b="0">
+                <a:solidFill>
+                  <a:srgbClr val="333333"/>
+                </a:solidFill>
+                <a:latin typeface="Calibri"/>
+              </a:defRPr>
+            </a:pPr>
+            <a:r>
+              <a:t>Sicaklik, basinc</a:t>
+            </a:r>
+          </a:p>
+        </p:txBody>
+      </p:sp>
+      <p:sp>
+        <p:nvSpPr>
+          <p:cNvPr id="24" name="TextBox 23"/>
+          <p:cNvSpPr txBox="1"/>
+          <p:nvPr/>
+        </p:nvSpPr>
+        <p:spPr>
+          <a:xfrm>
+            <a:off x="9418320" y="2688336"/>
+            <a:ext cx="2286000" cy="182880"/>
+          </a:xfrm>
+          <a:prstGeom prst="rect">
+            <a:avLst/>
+          </a:prstGeom>
+          <a:noFill/>
+        </p:spPr>
+        <p:txBody>
+          <a:bodyPr wrap="square">
+            <a:spAutoFit/>
+          </a:bodyPr>
+          <a:lstStyle/>
+          <a:p>
+            <a:pPr algn="l">
+              <a:defRPr sz="1000" b="0">
+                <a:solidFill>
+                  <a:srgbClr val="E74C3C"/>
+                </a:solidFill>
+                <a:latin typeface="Calibri"/>
+              </a:defRPr>
+            </a:pPr>
+            <a:r>
+              <a:t>Makinenin anormal titresimi</a:t>
+            </a:r>
+          </a:p>
+        </p:txBody>
+      </p:sp>
+      <p:sp>
+        <p:nvSpPr>
+          <p:cNvPr id="25" name="Rectangle 24"/>
+          <p:cNvSpPr/>
+          <p:nvPr/>
+        </p:nvSpPr>
+        <p:spPr>
+          <a:xfrm>
+            <a:off x="6309360" y="3090672"/>
+            <a:ext cx="109728" cy="347472"/>
+          </a:xfrm>
+          <a:prstGeom prst="rect">
+            <a:avLst/>
+          </a:prstGeom>
+          <a:solidFill>
+            <a:srgbClr val="8E44AD"/>
+          </a:solidFill>
+          <a:ln>
+            <a:noFill/>
+          </a:ln>
+        </p:spPr>
+        <p:style>
+          <a:lnRef idx="1">
+            <a:schemeClr val="accent1"/>
+          </a:lnRef>
+          <a:fillRef idx="3">
+            <a:schemeClr val="accent1"/>
+          </a:fillRef>
+          <a:effectRef idx="2">
+            <a:schemeClr val="accent1"/>
+          </a:effectRef>
+          <a:fontRef idx="minor">
+            <a:schemeClr val="lt1"/>
+          </a:fontRef>
+        </p:style>
+        <p:txBody>
+          <a:bodyPr rtlCol="0" anchor="ctr"/>
+          <a:lstStyle/>
+          <a:p>
+            <a:pPr algn="ctr"/>
+          </a:p>
+        </p:txBody>
+      </p:sp>
+      <p:sp>
+        <p:nvSpPr>
+          <p:cNvPr id="26" name="TextBox 25"/>
+          <p:cNvSpPr txBox="1"/>
+          <p:nvPr/>
+        </p:nvSpPr>
+        <p:spPr>
+          <a:xfrm>
+            <a:off x="6492240" y="3072384"/>
+            <a:ext cx="1463040" cy="182880"/>
+          </a:xfrm>
+          <a:prstGeom prst="rect">
+            <a:avLst/>
+          </a:prstGeom>
+          <a:noFill/>
+        </p:spPr>
+        <p:txBody>
+          <a:bodyPr wrap="square">
+            <a:spAutoFit/>
+          </a:bodyPr>
+          <a:lstStyle/>
+          <a:p>
+            <a:pPr algn="l">
+              <a:defRPr sz="1100" b="1">
+                <a:solidFill>
+                  <a:srgbClr val="8E44AD"/>
+                </a:solidFill>
+                <a:latin typeface="Calibri"/>
+              </a:defRPr>
+            </a:pPr>
+            <a:r>
+              <a:t>Uygulama Log</a:t>
+            </a:r>
+          </a:p>
+        </p:txBody>
+      </p:sp>
+      <p:sp>
+        <p:nvSpPr>
+          <p:cNvPr id="27" name="TextBox 26"/>
+          <p:cNvSpPr txBox="1"/>
+          <p:nvPr/>
+        </p:nvSpPr>
+        <p:spPr>
+          <a:xfrm>
+            <a:off x="7955279" y="3072384"/>
+            <a:ext cx="1463040" cy="182880"/>
+          </a:xfrm>
+          <a:prstGeom prst="rect">
+            <a:avLst/>
+          </a:prstGeom>
+          <a:noFill/>
+        </p:spPr>
+        <p:txBody>
+          <a:bodyPr wrap="square">
+            <a:spAutoFit/>
+          </a:bodyPr>
+          <a:lstStyle/>
+          <a:p>
+            <a:pPr algn="l">
+              <a:defRPr sz="1000" b="0">
+                <a:solidFill>
+                  <a:srgbClr val="333333"/>
+                </a:solidFill>
+                <a:latin typeface="Calibri"/>
+              </a:defRPr>
+            </a:pPr>
+            <a:r>
+              <a:t>Hata orani, yanit suresi</a:t>
+            </a:r>
+          </a:p>
+        </p:txBody>
+      </p:sp>
+      <p:sp>
+        <p:nvSpPr>
+          <p:cNvPr id="28" name="TextBox 27"/>
+          <p:cNvSpPr txBox="1"/>
+          <p:nvPr/>
+        </p:nvSpPr>
+        <p:spPr>
+          <a:xfrm>
+            <a:off x="9418320" y="3072384"/>
+            <a:ext cx="2286000" cy="182880"/>
+          </a:xfrm>
+          <a:prstGeom prst="rect">
+            <a:avLst/>
+          </a:prstGeom>
+          <a:noFill/>
+        </p:spPr>
+        <p:txBody>
+          <a:bodyPr wrap="square">
+            <a:spAutoFit/>
+          </a:bodyPr>
+          <a:lstStyle/>
+          <a:p>
+            <a:pPr algn="l">
+              <a:defRPr sz="1000" b="0">
+                <a:solidFill>
+                  <a:srgbClr val="E74C3C"/>
+                </a:solidFill>
+                <a:latin typeface="Calibri"/>
+              </a:defRPr>
+            </a:pPr>
+            <a:r>
+              <a:t>API yanitinin 10x artmasi</a:t>
+            </a:r>
+          </a:p>
+        </p:txBody>
+      </p:sp>
+      <p:sp>
+        <p:nvSpPr>
+          <p:cNvPr id="29" name="Rectangle 28"/>
+          <p:cNvSpPr/>
+          <p:nvPr/>
+        </p:nvSpPr>
+        <p:spPr>
+          <a:xfrm>
+            <a:off x="274320" y="3840480"/>
+            <a:ext cx="11612880" cy="2834640"/>
+          </a:xfrm>
+          <a:prstGeom prst="rect">
+            <a:avLst/>
+          </a:prstGeom>
+          <a:solidFill>
+            <a:srgbClr val="FFFFFF"/>
+          </a:solidFill>
+          <a:ln>
+            <a:noFill/>
+          </a:ln>
+        </p:spPr>
+        <p:style>
+          <a:lnRef idx="1">
+            <a:schemeClr val="accent1"/>
+          </a:lnRef>
+          <a:fillRef idx="3">
+            <a:schemeClr val="accent1"/>
+          </a:fillRef>
+          <a:effectRef idx="2">
+            <a:schemeClr val="accent1"/>
+          </a:effectRef>
+          <a:fontRef idx="minor">
+            <a:schemeClr val="lt1"/>
+          </a:fontRef>
+        </p:style>
+        <p:txBody>
+          <a:bodyPr rtlCol="0" anchor="ctr"/>
+          <a:lstStyle/>
+          <a:p>
+            <a:pPr algn="ctr"/>
+          </a:p>
+        </p:txBody>
+      </p:sp>
+      <p:sp>
+        <p:nvSpPr>
+          <p:cNvPr id="30" name="TextBox 29"/>
+          <p:cNvSpPr txBox="1"/>
+          <p:nvPr/>
+        </p:nvSpPr>
+        <p:spPr>
+          <a:xfrm>
+            <a:off x="457200" y="3886200"/>
+            <a:ext cx="11247120" cy="320040"/>
+          </a:xfrm>
+          <a:prstGeom prst="rect">
+            <a:avLst/>
+          </a:prstGeom>
+          <a:noFill/>
+        </p:spPr>
+        <p:txBody>
+          <a:bodyPr wrap="square">
+            <a:spAutoFit/>
+          </a:bodyPr>
+          <a:lstStyle/>
+          <a:p>
+            <a:pPr algn="l">
+              <a:defRPr sz="1800" b="1">
+                <a:solidFill>
+                  <a:srgbClr val="00528A"/>
+                </a:solidFill>
+                <a:latin typeface="Calibri"/>
+              </a:defRPr>
+            </a:pPr>
+            <a:r>
+              <a:t>Nasil Calisir? — 4 Adimli Akis</a:t>
+            </a:r>
+          </a:p>
+        </p:txBody>
+      </p:sp>
+      <p:sp>
+        <p:nvSpPr>
+          <p:cNvPr id="31" name="Rectangle 30"/>
+          <p:cNvSpPr/>
+          <p:nvPr/>
+        </p:nvSpPr>
+        <p:spPr>
+          <a:xfrm>
+            <a:off x="457200" y="4297680"/>
+            <a:ext cx="2606040" cy="2103120"/>
+          </a:xfrm>
+          <a:prstGeom prst="rect">
+            <a:avLst/>
+          </a:prstGeom>
+          <a:solidFill>
+            <a:srgbClr val="0096D6"/>
+          </a:solidFill>
+          <a:ln>
+            <a:noFill/>
+          </a:ln>
+        </p:spPr>
+        <p:style>
+          <a:lnRef idx="1">
+            <a:schemeClr val="accent1"/>
+          </a:lnRef>
+          <a:fillRef idx="3">
+            <a:schemeClr val="accent1"/>
+          </a:fillRef>
+          <a:effectRef idx="2">
+            <a:schemeClr val="accent1"/>
+          </a:effectRef>
+          <a:fontRef idx="minor">
+            <a:schemeClr val="lt1"/>
+          </a:fontRef>
+        </p:style>
+        <p:txBody>
+          <a:bodyPr rtlCol="0" anchor="ctr"/>
+          <a:lstStyle/>
+          <a:p>
+            <a:pPr algn="ctr"/>
+          </a:p>
+        </p:txBody>
+      </p:sp>
+      <p:sp>
+        <p:nvSpPr>
+          <p:cNvPr id="32" name="TextBox 31"/>
+          <p:cNvSpPr txBox="1"/>
+          <p:nvPr/>
+        </p:nvSpPr>
+        <p:spPr>
+          <a:xfrm>
+            <a:off x="548640" y="4343400"/>
+            <a:ext cx="2423160" cy="320040"/>
+          </a:xfrm>
+          <a:prstGeom prst="rect">
+            <a:avLst/>
+          </a:prstGeom>
+          <a:noFill/>
+        </p:spPr>
+        <p:txBody>
+          <a:bodyPr wrap="square">
+            <a:spAutoFit/>
+          </a:bodyPr>
+          <a:lstStyle/>
+          <a:p>
+            <a:pPr algn="l">
+              <a:defRPr sz="1400" b="1">
+                <a:solidFill>
+                  <a:srgbClr val="FFFFFF"/>
+                </a:solidFill>
+                <a:latin typeface="Calibri"/>
+              </a:defRPr>
+            </a:pPr>
+            <a:r>
+              <a:t>1. Veri Toplama</a:t>
+            </a:r>
+          </a:p>
+        </p:txBody>
+      </p:sp>
+      <p:sp>
+        <p:nvSpPr>
+          <p:cNvPr id="33" name="TextBox 32"/>
+          <p:cNvSpPr txBox="1"/>
+          <p:nvPr/>
+        </p:nvSpPr>
+        <p:spPr>
+          <a:xfrm>
+            <a:off x="548640" y="4709160"/>
+            <a:ext cx="2423160" cy="1371600"/>
+          </a:xfrm>
+          <a:prstGeom prst="rect">
+            <a:avLst/>
+          </a:prstGeom>
+          <a:noFill/>
+        </p:spPr>
+        <p:txBody>
+          <a:bodyPr wrap="square">
+            <a:spAutoFit/>
+          </a:bodyPr>
+          <a:lstStyle/>
+          <a:p>
+            <a:pPr algn="l">
+              <a:defRPr sz="1200" b="0">
+                <a:solidFill>
+                  <a:srgbClr val="FFFFFF"/>
+                </a:solidFill>
+                <a:latin typeface="Calibri"/>
+              </a:defRPr>
+            </a:pPr>
+            <a:r>
+              <a:t>OpenSearch index'lerinden</a:t>
+            </a:r>
+            <a:br/>
+            <a:r>
+              <a:t>zaman serisi verisi okur</a:t>
+            </a:r>
+            <a:br/>
+            <a:r>
+              <a:t>(orn. her 5 dakikada)</a:t>
+            </a:r>
+          </a:p>
+        </p:txBody>
+      </p:sp>
+      <p:sp>
+        <p:nvSpPr>
+          <p:cNvPr id="34" name="TextBox 33"/>
+          <p:cNvSpPr txBox="1"/>
+          <p:nvPr/>
+        </p:nvSpPr>
+        <p:spPr>
+          <a:xfrm>
+            <a:off x="2971800" y="4937760"/>
+            <a:ext cx="457200" cy="457200"/>
+          </a:xfrm>
+          <a:prstGeom prst="rect">
+            <a:avLst/>
+          </a:prstGeom>
+          <a:noFill/>
+        </p:spPr>
+        <p:txBody>
+          <a:bodyPr wrap="square">
+            <a:spAutoFit/>
+          </a:bodyPr>
+          <a:lstStyle/>
+          <a:p>
+            <a:pPr algn="l">
+              <a:defRPr sz="2400" b="1">
+                <a:solidFill>
+                  <a:srgbClr val="333333"/>
+                </a:solidFill>
+                <a:latin typeface="Calibri"/>
+              </a:defRPr>
+            </a:pPr>
+            <a:r>
+              <a:t>=&gt;</a:t>
+            </a:r>
+          </a:p>
+        </p:txBody>
+      </p:sp>
+      <p:sp>
+        <p:nvSpPr>
+          <p:cNvPr id="35" name="Rectangle 34"/>
+          <p:cNvSpPr/>
+          <p:nvPr/>
+        </p:nvSpPr>
+        <p:spPr>
+          <a:xfrm>
+            <a:off x="3337560" y="4297680"/>
+            <a:ext cx="2606040" cy="2103120"/>
+          </a:xfrm>
+          <a:prstGeom prst="rect">
+            <a:avLst/>
+          </a:prstGeom>
+          <a:solidFill>
+            <a:srgbClr val="2ECC71"/>
+          </a:solidFill>
+          <a:ln>
+            <a:noFill/>
+          </a:ln>
+        </p:spPr>
+        <p:style>
+          <a:lnRef idx="1">
+            <a:schemeClr val="accent1"/>
+          </a:lnRef>
+          <a:fillRef idx="3">
+            <a:schemeClr val="accent1"/>
+          </a:fillRef>
+          <a:effectRef idx="2">
+            <a:schemeClr val="accent1"/>
+          </a:effectRef>
+          <a:fontRef idx="minor">
+            <a:schemeClr val="lt1"/>
+          </a:fontRef>
+        </p:style>
+        <p:txBody>
+          <a:bodyPr rtlCol="0" anchor="ctr"/>
+          <a:lstStyle/>
+          <a:p>
+            <a:pPr algn="ctr"/>
+          </a:p>
+        </p:txBody>
+      </p:sp>
+      <p:sp>
+        <p:nvSpPr>
+          <p:cNvPr id="36" name="TextBox 35"/>
+          <p:cNvSpPr txBox="1"/>
+          <p:nvPr/>
+        </p:nvSpPr>
+        <p:spPr>
+          <a:xfrm>
+            <a:off x="3429000" y="4343400"/>
+            <a:ext cx="2423160" cy="320040"/>
+          </a:xfrm>
+          <a:prstGeom prst="rect">
+            <a:avLst/>
+          </a:prstGeom>
+          <a:noFill/>
+        </p:spPr>
+        <p:txBody>
+          <a:bodyPr wrap="square">
+            <a:spAutoFit/>
+          </a:bodyPr>
+          <a:lstStyle/>
+          <a:p>
+            <a:pPr algn="l">
+              <a:defRPr sz="1400" b="1">
+                <a:solidFill>
+                  <a:srgbClr val="FFFFFF"/>
+                </a:solidFill>
+                <a:latin typeface="Calibri"/>
+              </a:defRPr>
+            </a:pPr>
+            <a:r>
+              <a:t>2. Model Egitimi</a:t>
+            </a:r>
+          </a:p>
+        </p:txBody>
+      </p:sp>
+      <p:sp>
+        <p:nvSpPr>
+          <p:cNvPr id="37" name="TextBox 36"/>
+          <p:cNvSpPr txBox="1"/>
+          <p:nvPr/>
+        </p:nvSpPr>
+        <p:spPr>
+          <a:xfrm>
+            <a:off x="3429000" y="4709160"/>
+            <a:ext cx="2423160" cy="1371600"/>
+          </a:xfrm>
+          <a:prstGeom prst="rect">
+            <a:avLst/>
+          </a:prstGeom>
+          <a:noFill/>
+        </p:spPr>
+        <p:txBody>
+          <a:bodyPr wrap="square">
+            <a:spAutoFit/>
+          </a:bodyPr>
+          <a:lstStyle/>
+          <a:p>
+            <a:pPr algn="l">
+              <a:defRPr sz="1200" b="0">
+                <a:solidFill>
+                  <a:srgbClr val="FFFFFF"/>
+                </a:solidFill>
+                <a:latin typeface="Calibri"/>
+              </a:defRPr>
+            </a:pPr>
+            <a:r>
+              <a:t>Random Cut Forest (RCF)</a:t>
+            </a:r>
+            <a:br/>
+            <a:r>
+              <a:t>algoritmasi ile verinin</a:t>
+            </a:r>
+            <a:br/>
+            <a:r>
+              <a:t>'normal' davranisini ogrenir</a:t>
+            </a:r>
+          </a:p>
+        </p:txBody>
+      </p:sp>
+      <p:sp>
+        <p:nvSpPr>
+          <p:cNvPr id="38" name="TextBox 37"/>
+          <p:cNvSpPr txBox="1"/>
+          <p:nvPr/>
+        </p:nvSpPr>
+        <p:spPr>
+          <a:xfrm>
+            <a:off x="5852160" y="4937760"/>
+            <a:ext cx="457200" cy="457200"/>
+          </a:xfrm>
+          <a:prstGeom prst="rect">
+            <a:avLst/>
+          </a:prstGeom>
+          <a:noFill/>
+        </p:spPr>
+        <p:txBody>
+          <a:bodyPr wrap="square">
+            <a:spAutoFit/>
+          </a:bodyPr>
+          <a:lstStyle/>
+          <a:p>
+            <a:pPr algn="l">
+              <a:defRPr sz="2400" b="1">
+                <a:solidFill>
+                  <a:srgbClr val="333333"/>
+                </a:solidFill>
+                <a:latin typeface="Calibri"/>
+              </a:defRPr>
+            </a:pPr>
+            <a:r>
+              <a:t>=&gt;</a:t>
+            </a:r>
+          </a:p>
+        </p:txBody>
+      </p:sp>
+      <p:sp>
+        <p:nvSpPr>
+          <p:cNvPr id="39" name="Rectangle 38"/>
+          <p:cNvSpPr/>
+          <p:nvPr/>
+        </p:nvSpPr>
+        <p:spPr>
+          <a:xfrm>
+            <a:off x="6217920" y="4297680"/>
+            <a:ext cx="2606040" cy="2103120"/>
+          </a:xfrm>
+          <a:prstGeom prst="rect">
+            <a:avLst/>
+          </a:prstGeom>
+          <a:solidFill>
+            <a:srgbClr val="FF8C00"/>
+          </a:solidFill>
+          <a:ln>
+            <a:noFill/>
+          </a:ln>
+        </p:spPr>
+        <p:style>
+          <a:lnRef idx="1">
+            <a:schemeClr val="accent1"/>
+          </a:lnRef>
+          <a:fillRef idx="3">
+            <a:schemeClr val="accent1"/>
+          </a:fillRef>
+          <a:effectRef idx="2">
+            <a:schemeClr val="accent1"/>
+          </a:effectRef>
+          <a:fontRef idx="minor">
+            <a:schemeClr val="lt1"/>
+          </a:fontRef>
+        </p:style>
+        <p:txBody>
+          <a:bodyPr rtlCol="0" anchor="ctr"/>
+          <a:lstStyle/>
+          <a:p>
+            <a:pPr algn="ctr"/>
+          </a:p>
+        </p:txBody>
+      </p:sp>
+      <p:sp>
+        <p:nvSpPr>
+          <p:cNvPr id="40" name="TextBox 39"/>
+          <p:cNvSpPr txBox="1"/>
+          <p:nvPr/>
+        </p:nvSpPr>
+        <p:spPr>
+          <a:xfrm>
+            <a:off x="6309359" y="4343400"/>
+            <a:ext cx="2423160" cy="320040"/>
+          </a:xfrm>
+          <a:prstGeom prst="rect">
+            <a:avLst/>
+          </a:prstGeom>
+          <a:noFill/>
+        </p:spPr>
+        <p:txBody>
+          <a:bodyPr wrap="square">
+            <a:spAutoFit/>
+          </a:bodyPr>
+          <a:lstStyle/>
+          <a:p>
+            <a:pPr algn="l">
+              <a:defRPr sz="1400" b="1">
+                <a:solidFill>
+                  <a:srgbClr val="FFFFFF"/>
+                </a:solidFill>
+                <a:latin typeface="Calibri"/>
+              </a:defRPr>
+            </a:pPr>
+            <a:r>
+              <a:t>3. Anomali Tespiti</a:t>
+            </a:r>
+          </a:p>
+        </p:txBody>
+      </p:sp>
+      <p:sp>
+        <p:nvSpPr>
+          <p:cNvPr id="41" name="TextBox 40"/>
+          <p:cNvSpPr txBox="1"/>
+          <p:nvPr/>
+        </p:nvSpPr>
+        <p:spPr>
+          <a:xfrm>
+            <a:off x="6309359" y="4709160"/>
+            <a:ext cx="2423160" cy="1371600"/>
+          </a:xfrm>
+          <a:prstGeom prst="rect">
+            <a:avLst/>
+          </a:prstGeom>
+          <a:noFill/>
+        </p:spPr>
+        <p:txBody>
+          <a:bodyPr wrap="square">
+            <a:spAutoFit/>
+          </a:bodyPr>
+          <a:lstStyle/>
+          <a:p>
+            <a:pPr algn="l">
+              <a:defRPr sz="1200" b="0">
+                <a:solidFill>
+                  <a:srgbClr val="FFFFFF"/>
+                </a:solidFill>
+                <a:latin typeface="Calibri"/>
+              </a:defRPr>
+            </a:pPr>
+            <a:r>
+              <a:t>Yeni veriyi modelle karsilastirir</a:t>
+            </a:r>
+            <a:br/>
+            <a:r>
+              <a:t>Anomali skoru hesaplar (0-10)</a:t>
+            </a:r>
+            <a:br/>
+            <a:r>
+              <a:t>Esik asarsa -&gt; ANOMALI!</a:t>
+            </a:r>
+          </a:p>
+        </p:txBody>
+      </p:sp>
+      <p:sp>
+        <p:nvSpPr>
+          <p:cNvPr id="42" name="TextBox 41"/>
+          <p:cNvSpPr txBox="1"/>
+          <p:nvPr/>
+        </p:nvSpPr>
+        <p:spPr>
+          <a:xfrm>
+            <a:off x="8732520" y="4937760"/>
+            <a:ext cx="457200" cy="457200"/>
+          </a:xfrm>
+          <a:prstGeom prst="rect">
+            <a:avLst/>
+          </a:prstGeom>
+          <a:noFill/>
+        </p:spPr>
+        <p:txBody>
+          <a:bodyPr wrap="square">
+            <a:spAutoFit/>
+          </a:bodyPr>
+          <a:lstStyle/>
+          <a:p>
+            <a:pPr algn="l">
+              <a:defRPr sz="2400" b="1">
+                <a:solidFill>
+                  <a:srgbClr val="333333"/>
+                </a:solidFill>
+                <a:latin typeface="Calibri"/>
+              </a:defRPr>
+            </a:pPr>
+            <a:r>
+              <a:t>=&gt;</a:t>
+            </a:r>
+          </a:p>
+        </p:txBody>
+      </p:sp>
+      <p:sp>
+        <p:nvSpPr>
+          <p:cNvPr id="43" name="Rectangle 42"/>
+          <p:cNvSpPr/>
+          <p:nvPr/>
+        </p:nvSpPr>
+        <p:spPr>
+          <a:xfrm>
+            <a:off x="9098280" y="4297680"/>
+            <a:ext cx="2606040" cy="2103120"/>
+          </a:xfrm>
+          <a:prstGeom prst="rect">
+            <a:avLst/>
+          </a:prstGeom>
+          <a:solidFill>
+            <a:srgbClr val="E74C3C"/>
+          </a:solidFill>
+          <a:ln>
+            <a:noFill/>
+          </a:ln>
+        </p:spPr>
+        <p:style>
+          <a:lnRef idx="1">
+            <a:schemeClr val="accent1"/>
+          </a:lnRef>
+          <a:fillRef idx="3">
+            <a:schemeClr val="accent1"/>
+          </a:fillRef>
+          <a:effectRef idx="2">
+            <a:schemeClr val="accent1"/>
+          </a:effectRef>
+          <a:fontRef idx="minor">
+            <a:schemeClr val="lt1"/>
+          </a:fontRef>
+        </p:style>
+        <p:txBody>
+          <a:bodyPr rtlCol="0" anchor="ctr"/>
+          <a:lstStyle/>
+          <a:p>
+            <a:pPr algn="ctr"/>
+          </a:p>
+        </p:txBody>
+      </p:sp>
+      <p:sp>
+        <p:nvSpPr>
+          <p:cNvPr id="44" name="TextBox 43"/>
+          <p:cNvSpPr txBox="1"/>
+          <p:nvPr/>
+        </p:nvSpPr>
+        <p:spPr>
+          <a:xfrm>
+            <a:off x="9189719" y="4343400"/>
+            <a:ext cx="2423160" cy="320040"/>
+          </a:xfrm>
+          <a:prstGeom prst="rect">
+            <a:avLst/>
+          </a:prstGeom>
+          <a:noFill/>
+        </p:spPr>
+        <p:txBody>
+          <a:bodyPr wrap="square">
+            <a:spAutoFit/>
+          </a:bodyPr>
+          <a:lstStyle/>
+          <a:p>
+            <a:pPr algn="l">
+              <a:defRPr sz="1400" b="1">
+                <a:solidFill>
+                  <a:srgbClr val="FFFFFF"/>
+                </a:solidFill>
+                <a:latin typeface="Calibri"/>
+              </a:defRPr>
+            </a:pPr>
+            <a:r>
+              <a:t>4. Sonuc ve Uyari</a:t>
+            </a:r>
+          </a:p>
+        </p:txBody>
+      </p:sp>
+      <p:sp>
+        <p:nvSpPr>
+          <p:cNvPr id="45" name="TextBox 44"/>
+          <p:cNvSpPr txBox="1"/>
+          <p:nvPr/>
+        </p:nvSpPr>
+        <p:spPr>
+          <a:xfrm>
+            <a:off x="9189719" y="4709160"/>
+            <a:ext cx="2423160" cy="1371600"/>
+          </a:xfrm>
+          <a:prstGeom prst="rect">
+            <a:avLst/>
+          </a:prstGeom>
+          <a:noFill/>
+        </p:spPr>
+        <p:txBody>
+          <a:bodyPr wrap="square">
+            <a:spAutoFit/>
+          </a:bodyPr>
+          <a:lstStyle/>
+          <a:p>
+            <a:pPr algn="l">
+              <a:defRPr sz="1200" b="0">
+                <a:solidFill>
+                  <a:srgbClr val="FFFFFF"/>
+                </a:solidFill>
+                <a:latin typeface="Calibri"/>
+              </a:defRPr>
+            </a:pPr>
+            <a:r>
+              <a:t>Anomali detaylari kaydedilir</a:t>
+            </a:r>
+            <a:br/>
+            <a:r>
+              <a:t>Alerting eklentisi ile</a:t>
+            </a:r>
+            <a:br/>
+            <a:r>
+              <a:t>bildirim gonderilir</a:t>
+            </a:r>
+          </a:p>
+        </p:txBody>
+      </p:sp>
+    </p:spTree>
+  </p:cSld>
+  <p:clrMapOvr>
+    <a:masterClrMapping/>
+  </p:clrMapOvr>
+</p:sld>
+</file>
+
+<file path=ppt/slides/slide14.xml><?xml version="1.0" encoding="utf-8"?>
+<p:sld xmlns:a="http://schemas.openxmlformats.org/drawingml/2006/main" xmlns:p="http://schemas.openxmlformats.org/presentationml/2006/main" xmlns:r="http://schemas.openxmlformats.org/officeDocument/2006/relationships">
+  <p:cSld>
+    <p:bg>
+      <p:bgPr>
+        <a:solidFill>
+          <a:srgbClr val="F5F6FA"/>
+        </a:solidFill>
+        <a:effectLst/>
+      </p:bgPr>
+    </p:bg>
+    <p:spTree>
+      <p:nvGrpSpPr>
+        <p:cNvPr id="1" name=""/>
+        <p:cNvGrpSpPr/>
+        <p:nvPr/>
+      </p:nvGrpSpPr>
+      <p:grpSpPr/>
+      <p:sp>
+        <p:nvSpPr>
+          <p:cNvPr id="2" name="Rectangle 1"/>
+          <p:cNvSpPr/>
+          <p:nvPr/>
+        </p:nvSpPr>
+        <p:spPr>
+          <a:xfrm>
+            <a:off x="0" y="0"/>
+            <a:ext cx="12191695" cy="914400"/>
+          </a:xfrm>
+          <a:prstGeom prst="rect">
+            <a:avLst/>
+          </a:prstGeom>
+          <a:solidFill>
+            <a:srgbClr val="00528A"/>
+          </a:solidFill>
+          <a:ln>
+            <a:noFill/>
+          </a:ln>
+        </p:spPr>
+        <p:style>
+          <a:lnRef idx="1">
+            <a:schemeClr val="accent1"/>
+          </a:lnRef>
+          <a:fillRef idx="3">
+            <a:schemeClr val="accent1"/>
+          </a:fillRef>
+          <a:effectRef idx="2">
+            <a:schemeClr val="accent1"/>
+          </a:effectRef>
+          <a:fontRef idx="minor">
+            <a:schemeClr val="lt1"/>
+          </a:fontRef>
+        </p:style>
+        <p:txBody>
+          <a:bodyPr rtlCol="0" anchor="ctr"/>
+          <a:lstStyle/>
+          <a:p>
+            <a:pPr algn="ctr"/>
+          </a:p>
+        </p:txBody>
+      </p:sp>
+      <p:sp>
+        <p:nvSpPr>
+          <p:cNvPr id="3" name="TextBox 2"/>
+          <p:cNvSpPr txBox="1"/>
+          <p:nvPr/>
+        </p:nvSpPr>
+        <p:spPr>
+          <a:xfrm>
+            <a:off x="731520" y="137160"/>
+            <a:ext cx="10058400" cy="594360"/>
+          </a:xfrm>
+          <a:prstGeom prst="rect">
+            <a:avLst/>
+          </a:prstGeom>
+          <a:noFill/>
+        </p:spPr>
+        <p:txBody>
+          <a:bodyPr wrap="square">
+            <a:spAutoFit/>
+          </a:bodyPr>
+          <a:lstStyle/>
+          <a:p>
+            <a:pPr algn="l">
+              <a:defRPr sz="2700" b="1">
+                <a:solidFill>
+                  <a:srgbClr val="FFFFFF"/>
+                </a:solidFill>
+                <a:latin typeface="Calibri"/>
+              </a:defRPr>
+            </a:pPr>
+            <a:r>
+              <a:t>Java Bilesenleri, RCF Algoritmasi ve Neden Bu Proje?</a:t>
+            </a:r>
+          </a:p>
+        </p:txBody>
+      </p:sp>
+      <p:sp>
+        <p:nvSpPr>
+          <p:cNvPr id="4" name="Rectangle 3"/>
+          <p:cNvSpPr/>
+          <p:nvPr/>
+        </p:nvSpPr>
+        <p:spPr>
+          <a:xfrm>
+            <a:off x="274320" y="1097280"/>
+            <a:ext cx="5669280" cy="2468880"/>
+          </a:xfrm>
+          <a:prstGeom prst="rect">
+            <a:avLst/>
+          </a:prstGeom>
+          <a:solidFill>
+            <a:srgbClr val="FFFFFF"/>
+          </a:solidFill>
+          <a:ln>
+            <a:noFill/>
+          </a:ln>
+        </p:spPr>
+        <p:style>
+          <a:lnRef idx="1">
+            <a:schemeClr val="accent1"/>
+          </a:lnRef>
+          <a:fillRef idx="3">
+            <a:schemeClr val="accent1"/>
+          </a:fillRef>
+          <a:effectRef idx="2">
+            <a:schemeClr val="accent1"/>
+          </a:effectRef>
+          <a:fontRef idx="minor">
+            <a:schemeClr val="lt1"/>
+          </a:fontRef>
+        </p:style>
+        <p:txBody>
+          <a:bodyPr rtlCol="0" anchor="ctr"/>
+          <a:lstStyle/>
+          <a:p>
+            <a:pPr algn="ctr"/>
+          </a:p>
+        </p:txBody>
+      </p:sp>
+      <p:sp>
+        <p:nvSpPr>
+          <p:cNvPr id="5" name="TextBox 4"/>
+          <p:cNvSpPr txBox="1"/>
+          <p:nvPr/>
+        </p:nvSpPr>
+        <p:spPr>
+          <a:xfrm>
+            <a:off x="457200" y="1143000"/>
+            <a:ext cx="5303520" cy="320040"/>
+          </a:xfrm>
+          <a:prstGeom prst="rect">
+            <a:avLst/>
+          </a:prstGeom>
+          <a:noFill/>
+        </p:spPr>
+        <p:txBody>
+          <a:bodyPr wrap="square">
+            <a:spAutoFit/>
+          </a:bodyPr>
+          <a:lstStyle/>
+          <a:p>
+            <a:pPr algn="l">
+              <a:defRPr sz="1700" b="1">
+                <a:solidFill>
+                  <a:srgbClr val="00528A"/>
+                </a:solidFill>
+                <a:latin typeface="Calibri"/>
+              </a:defRPr>
+            </a:pPr>
+            <a:r>
+              <a:t>Projenin Java Kod Yapisi</a:t>
+            </a:r>
+          </a:p>
+        </p:txBody>
+      </p:sp>
+      <p:sp>
+        <p:nvSpPr>
+          <p:cNvPr id="6" name="Rectangle 5"/>
+          <p:cNvSpPr/>
+          <p:nvPr/>
+        </p:nvSpPr>
+        <p:spPr>
+          <a:xfrm>
+            <a:off x="365760" y="1554480"/>
+            <a:ext cx="109728" cy="256032"/>
+          </a:xfrm>
+          <a:prstGeom prst="rect">
+            <a:avLst/>
+          </a:prstGeom>
+          <a:solidFill>
+            <a:srgbClr val="0096D6"/>
+          </a:solidFill>
+          <a:ln>
+            <a:noFill/>
+          </a:ln>
+        </p:spPr>
+        <p:style>
+          <a:lnRef idx="1">
+            <a:schemeClr val="accent1"/>
+          </a:lnRef>
+          <a:fillRef idx="3">
+            <a:schemeClr val="accent1"/>
+          </a:fillRef>
+          <a:effectRef idx="2">
+            <a:schemeClr val="accent1"/>
+          </a:effectRef>
+          <a:fontRef idx="minor">
+            <a:schemeClr val="lt1"/>
+          </a:fontRef>
+        </p:style>
+        <p:txBody>
+          <a:bodyPr rtlCol="0" anchor="ctr"/>
+          <a:lstStyle/>
+          <a:p>
+            <a:pPr algn="ctr"/>
+          </a:p>
+        </p:txBody>
+      </p:sp>
+      <p:sp>
+        <p:nvSpPr>
+          <p:cNvPr id="7" name="TextBox 6"/>
+          <p:cNvSpPr txBox="1"/>
+          <p:nvPr/>
+        </p:nvSpPr>
+        <p:spPr>
+          <a:xfrm>
+            <a:off x="548640" y="1536192"/>
+            <a:ext cx="1645920" cy="228600"/>
+          </a:xfrm>
+          <a:prstGeom prst="rect">
+            <a:avLst/>
+          </a:prstGeom>
+          <a:noFill/>
+        </p:spPr>
+        <p:txBody>
+          <a:bodyPr wrap="square">
+            <a:spAutoFit/>
+          </a:bodyPr>
+          <a:lstStyle/>
+          <a:p>
+            <a:pPr algn="l">
+              <a:defRPr sz="1200" b="1">
+                <a:solidFill>
+                  <a:srgbClr val="0096D6"/>
+                </a:solidFill>
+                <a:latin typeface="Calibri"/>
+              </a:defRPr>
+            </a:pPr>
+            <a:r>
+              <a:t>Detector</a:t>
+            </a:r>
+          </a:p>
+        </p:txBody>
+      </p:sp>
+      <p:sp>
+        <p:nvSpPr>
+          <p:cNvPr id="8" name="TextBox 7"/>
+          <p:cNvSpPr txBox="1"/>
+          <p:nvPr/>
+        </p:nvSpPr>
+        <p:spPr>
+          <a:xfrm>
+            <a:off x="2286000" y="1536192"/>
+            <a:ext cx="3566160" cy="228600"/>
+          </a:xfrm>
+          <a:prstGeom prst="rect">
+            <a:avLst/>
+          </a:prstGeom>
+          <a:noFill/>
+        </p:spPr>
+        <p:txBody>
+          <a:bodyPr wrap="square">
+            <a:spAutoFit/>
+          </a:bodyPr>
+          <a:lstStyle/>
+          <a:p>
+            <a:pPr algn="l">
+              <a:defRPr sz="1100" b="0">
+                <a:solidFill>
+                  <a:srgbClr val="333333"/>
+                </a:solidFill>
+                <a:latin typeface="Calibri"/>
+              </a:defRPr>
+            </a:pPr>
+            <a:r>
+              <a:t>Anomali dedektoru tanimlar (hangi index, alan, periyot)</a:t>
+            </a:r>
+          </a:p>
+        </p:txBody>
+      </p:sp>
+      <p:sp>
+        <p:nvSpPr>
+          <p:cNvPr id="9" name="Rectangle 8"/>
+          <p:cNvSpPr/>
+          <p:nvPr/>
+        </p:nvSpPr>
+        <p:spPr>
+          <a:xfrm>
+            <a:off x="365760" y="1856231"/>
+            <a:ext cx="109728" cy="256032"/>
+          </a:xfrm>
+          <a:prstGeom prst="rect">
+            <a:avLst/>
+          </a:prstGeom>
+          <a:solidFill>
+            <a:srgbClr val="2ECC71"/>
+          </a:solidFill>
+          <a:ln>
+            <a:noFill/>
+          </a:ln>
+        </p:spPr>
+        <p:style>
+          <a:lnRef idx="1">
+            <a:schemeClr val="accent1"/>
+          </a:lnRef>
+          <a:fillRef idx="3">
+            <a:schemeClr val="accent1"/>
+          </a:fillRef>
+          <a:effectRef idx="2">
+            <a:schemeClr val="accent1"/>
+          </a:effectRef>
+          <a:fontRef idx="minor">
+            <a:schemeClr val="lt1"/>
+          </a:fontRef>
+        </p:style>
+        <p:txBody>
+          <a:bodyPr rtlCol="0" anchor="ctr"/>
+          <a:lstStyle/>
+          <a:p>
+            <a:pPr algn="ctr"/>
+          </a:p>
+        </p:txBody>
+      </p:sp>
+      <p:sp>
+        <p:nvSpPr>
+          <p:cNvPr id="10" name="TextBox 9"/>
+          <p:cNvSpPr txBox="1"/>
+          <p:nvPr/>
+        </p:nvSpPr>
+        <p:spPr>
+          <a:xfrm>
+            <a:off x="548640" y="1837943"/>
+            <a:ext cx="1645920" cy="228600"/>
+          </a:xfrm>
+          <a:prstGeom prst="rect">
+            <a:avLst/>
+          </a:prstGeom>
+          <a:noFill/>
+        </p:spPr>
+        <p:txBody>
+          <a:bodyPr wrap="square">
+            <a:spAutoFit/>
+          </a:bodyPr>
+          <a:lstStyle/>
+          <a:p>
+            <a:pPr algn="l">
+              <a:defRPr sz="1200" b="1">
+                <a:solidFill>
+                  <a:srgbClr val="2ECC71"/>
+                </a:solidFill>
+                <a:latin typeface="Calibri"/>
+              </a:defRPr>
+            </a:pPr>
+            <a:r>
+              <a:t>Model (RCF)</a:t>
+            </a:r>
+          </a:p>
+        </p:txBody>
+      </p:sp>
+      <p:sp>
+        <p:nvSpPr>
+          <p:cNvPr id="11" name="TextBox 10"/>
+          <p:cNvSpPr txBox="1"/>
+          <p:nvPr/>
+        </p:nvSpPr>
+        <p:spPr>
+          <a:xfrm>
+            <a:off x="2286000" y="1837943"/>
+            <a:ext cx="3566160" cy="228600"/>
+          </a:xfrm>
+          <a:prstGeom prst="rect">
+            <a:avLst/>
+          </a:prstGeom>
+          <a:noFill/>
+        </p:spPr>
+        <p:txBody>
+          <a:bodyPr wrap="square">
+            <a:spAutoFit/>
+          </a:bodyPr>
+          <a:lstStyle/>
+          <a:p>
+            <a:pPr algn="l">
+              <a:defRPr sz="1100" b="0">
+                <a:solidFill>
+                  <a:srgbClr val="333333"/>
+                </a:solidFill>
+                <a:latin typeface="Calibri"/>
+              </a:defRPr>
+            </a:pPr>
+            <a:r>
+              <a:t>Random Cut Forest makine ogrenmesi modeli</a:t>
+            </a:r>
+          </a:p>
+        </p:txBody>
+      </p:sp>
+      <p:sp>
+        <p:nvSpPr>
+          <p:cNvPr id="12" name="Rectangle 11"/>
+          <p:cNvSpPr/>
+          <p:nvPr/>
+        </p:nvSpPr>
+        <p:spPr>
+          <a:xfrm>
+            <a:off x="365760" y="2157984"/>
+            <a:ext cx="109728" cy="256032"/>
+          </a:xfrm>
+          <a:prstGeom prst="rect">
+            <a:avLst/>
+          </a:prstGeom>
+          <a:solidFill>
+            <a:srgbClr val="FF8C00"/>
+          </a:solidFill>
+          <a:ln>
+            <a:noFill/>
+          </a:ln>
+        </p:spPr>
+        <p:style>
+          <a:lnRef idx="1">
+            <a:schemeClr val="accent1"/>
+          </a:lnRef>
+          <a:fillRef idx="3">
+            <a:schemeClr val="accent1"/>
+          </a:fillRef>
+          <a:effectRef idx="2">
+            <a:schemeClr val="accent1"/>
+          </a:effectRef>
+          <a:fontRef idx="minor">
+            <a:schemeClr val="lt1"/>
+          </a:fontRef>
+        </p:style>
+        <p:txBody>
+          <a:bodyPr rtlCol="0" anchor="ctr"/>
+          <a:lstStyle/>
+          <a:p>
+            <a:pPr algn="ctr"/>
+          </a:p>
+        </p:txBody>
+      </p:sp>
+      <p:sp>
+        <p:nvSpPr>
+          <p:cNvPr id="13" name="TextBox 12"/>
+          <p:cNvSpPr txBox="1"/>
+          <p:nvPr/>
+        </p:nvSpPr>
+        <p:spPr>
+          <a:xfrm>
+            <a:off x="548640" y="2139696"/>
+            <a:ext cx="1645920" cy="228600"/>
+          </a:xfrm>
+          <a:prstGeom prst="rect">
+            <a:avLst/>
+          </a:prstGeom>
+          <a:noFill/>
+        </p:spPr>
+        <p:txBody>
+          <a:bodyPr wrap="square">
+            <a:spAutoFit/>
+          </a:bodyPr>
+          <a:lstStyle/>
+          <a:p>
+            <a:pPr algn="l">
+              <a:defRPr sz="1200" b="1">
+                <a:solidFill>
+                  <a:srgbClr val="FF8C00"/>
+                </a:solidFill>
+                <a:latin typeface="Calibri"/>
+              </a:defRPr>
+            </a:pPr>
+            <a:r>
+              <a:t>Runner</a:t>
+            </a:r>
+          </a:p>
+        </p:txBody>
+      </p:sp>
+      <p:sp>
+        <p:nvSpPr>
+          <p:cNvPr id="14" name="TextBox 13"/>
+          <p:cNvSpPr txBox="1"/>
+          <p:nvPr/>
+        </p:nvSpPr>
+        <p:spPr>
+          <a:xfrm>
+            <a:off x="2286000" y="2139696"/>
+            <a:ext cx="3566160" cy="228600"/>
+          </a:xfrm>
+          <a:prstGeom prst="rect">
+            <a:avLst/>
+          </a:prstGeom>
+          <a:noFill/>
+        </p:spPr>
+        <p:txBody>
+          <a:bodyPr wrap="square">
+            <a:spAutoFit/>
+          </a:bodyPr>
+          <a:lstStyle/>
+          <a:p>
+            <a:pPr algn="l">
+              <a:defRPr sz="1100" b="0">
+                <a:solidFill>
+                  <a:srgbClr val="333333"/>
+                </a:solidFill>
+                <a:latin typeface="Calibri"/>
+              </a:defRPr>
+            </a:pPr>
+            <a:r>
+              <a:t>Dedektoru periyodik calistirir</a:t>
+            </a:r>
+          </a:p>
+        </p:txBody>
+      </p:sp>
+      <p:sp>
+        <p:nvSpPr>
+          <p:cNvPr id="15" name="Rectangle 14"/>
+          <p:cNvSpPr/>
+          <p:nvPr/>
+        </p:nvSpPr>
+        <p:spPr>
+          <a:xfrm>
+            <a:off x="365760" y="2459736"/>
+            <a:ext cx="109728" cy="256032"/>
+          </a:xfrm>
+          <a:prstGeom prst="rect">
+            <a:avLst/>
+          </a:prstGeom>
+          <a:solidFill>
+            <a:srgbClr val="8E44AD"/>
+          </a:solidFill>
+          <a:ln>
+            <a:noFill/>
+          </a:ln>
+        </p:spPr>
+        <p:style>
+          <a:lnRef idx="1">
+            <a:schemeClr val="accent1"/>
+          </a:lnRef>
+          <a:fillRef idx="3">
+            <a:schemeClr val="accent1"/>
+          </a:fillRef>
+          <a:effectRef idx="2">
+            <a:schemeClr val="accent1"/>
+          </a:effectRef>
+          <a:fontRef idx="minor">
+            <a:schemeClr val="lt1"/>
+          </a:fontRef>
+        </p:style>
+        <p:txBody>
+          <a:bodyPr rtlCol="0" anchor="ctr"/>
+          <a:lstStyle/>
+          <a:p>
+            <a:pPr algn="ctr"/>
+          </a:p>
+        </p:txBody>
+      </p:sp>
+      <p:sp>
+        <p:nvSpPr>
+          <p:cNvPr id="16" name="TextBox 15"/>
+          <p:cNvSpPr txBox="1"/>
+          <p:nvPr/>
+        </p:nvSpPr>
+        <p:spPr>
+          <a:xfrm>
+            <a:off x="548640" y="2441448"/>
+            <a:ext cx="1645920" cy="228600"/>
+          </a:xfrm>
+          <a:prstGeom prst="rect">
+            <a:avLst/>
+          </a:prstGeom>
+          <a:noFill/>
+        </p:spPr>
+        <p:txBody>
+          <a:bodyPr wrap="square">
+            <a:spAutoFit/>
+          </a:bodyPr>
+          <a:lstStyle/>
+          <a:p>
+            <a:pPr algn="l">
+              <a:defRPr sz="1200" b="1">
+                <a:solidFill>
+                  <a:srgbClr val="8E44AD"/>
+                </a:solidFill>
+                <a:latin typeface="Calibri"/>
+              </a:defRPr>
+            </a:pPr>
+            <a:r>
+              <a:t>Result</a:t>
+            </a:r>
+          </a:p>
+        </p:txBody>
+      </p:sp>
+      <p:sp>
+        <p:nvSpPr>
+          <p:cNvPr id="17" name="TextBox 16"/>
+          <p:cNvSpPr txBox="1"/>
+          <p:nvPr/>
+        </p:nvSpPr>
+        <p:spPr>
+          <a:xfrm>
+            <a:off x="2286000" y="2441448"/>
+            <a:ext cx="3566160" cy="228600"/>
+          </a:xfrm>
+          <a:prstGeom prst="rect">
+            <a:avLst/>
+          </a:prstGeom>
+          <a:noFill/>
+        </p:spPr>
+        <p:txBody>
+          <a:bodyPr wrap="square">
+            <a:spAutoFit/>
+          </a:bodyPr>
+          <a:lstStyle/>
+          <a:p>
+            <a:pPr algn="l">
+              <a:defRPr sz="1100" b="0">
+                <a:solidFill>
+                  <a:srgbClr val="333333"/>
+                </a:solidFill>
+                <a:latin typeface="Calibri"/>
+              </a:defRPr>
+            </a:pPr>
+            <a:r>
+              <a:t>Tespit edilen anomalileri saklar</a:t>
+            </a:r>
+          </a:p>
+        </p:txBody>
+      </p:sp>
+      <p:sp>
+        <p:nvSpPr>
+          <p:cNvPr id="18" name="Rectangle 17"/>
+          <p:cNvSpPr/>
+          <p:nvPr/>
+        </p:nvSpPr>
+        <p:spPr>
+          <a:xfrm>
+            <a:off x="365760" y="2761488"/>
+            <a:ext cx="109728" cy="256032"/>
+          </a:xfrm>
+          <a:prstGeom prst="rect">
+            <a:avLst/>
+          </a:prstGeom>
+          <a:solidFill>
+            <a:srgbClr val="00897B"/>
+          </a:solidFill>
+          <a:ln>
+            <a:noFill/>
+          </a:ln>
+        </p:spPr>
+        <p:style>
+          <a:lnRef idx="1">
+            <a:schemeClr val="accent1"/>
+          </a:lnRef>
+          <a:fillRef idx="3">
+            <a:schemeClr val="accent1"/>
+          </a:fillRef>
+          <a:effectRef idx="2">
+            <a:schemeClr val="accent1"/>
+          </a:effectRef>
+          <a:fontRef idx="minor">
+            <a:schemeClr val="lt1"/>
+          </a:fontRef>
+        </p:style>
+        <p:txBody>
+          <a:bodyPr rtlCol="0" anchor="ctr"/>
+          <a:lstStyle/>
+          <a:p>
+            <a:pPr algn="ctr"/>
+          </a:p>
+        </p:txBody>
+      </p:sp>
+      <p:sp>
+        <p:nvSpPr>
+          <p:cNvPr id="19" name="TextBox 18"/>
+          <p:cNvSpPr txBox="1"/>
+          <p:nvPr/>
+        </p:nvSpPr>
+        <p:spPr>
+          <a:xfrm>
+            <a:off x="548640" y="2743200"/>
+            <a:ext cx="1645920" cy="228600"/>
+          </a:xfrm>
+          <a:prstGeom prst="rect">
+            <a:avLst/>
+          </a:prstGeom>
+          <a:noFill/>
+        </p:spPr>
+        <p:txBody>
+          <a:bodyPr wrap="square">
+            <a:spAutoFit/>
+          </a:bodyPr>
+          <a:lstStyle/>
+          <a:p>
+            <a:pPr algn="l">
+              <a:defRPr sz="1200" b="1">
+                <a:solidFill>
+                  <a:srgbClr val="00897B"/>
+                </a:solidFill>
+                <a:latin typeface="Calibri"/>
+              </a:defRPr>
+            </a:pPr>
+            <a:r>
+              <a:t>REST API</a:t>
+            </a:r>
+          </a:p>
+        </p:txBody>
+      </p:sp>
+      <p:sp>
+        <p:nvSpPr>
+          <p:cNvPr id="20" name="TextBox 19"/>
+          <p:cNvSpPr txBox="1"/>
+          <p:nvPr/>
+        </p:nvSpPr>
+        <p:spPr>
+          <a:xfrm>
+            <a:off x="2286000" y="2743200"/>
+            <a:ext cx="3566160" cy="228600"/>
+          </a:xfrm>
+          <a:prstGeom prst="rect">
+            <a:avLst/>
+          </a:prstGeom>
+          <a:noFill/>
+        </p:spPr>
+        <p:txBody>
+          <a:bodyPr wrap="square">
+            <a:spAutoFit/>
+          </a:bodyPr>
+          <a:lstStyle/>
+          <a:p>
+            <a:pPr algn="l">
+              <a:defRPr sz="1100" b="0">
+                <a:solidFill>
+                  <a:srgbClr val="333333"/>
+                </a:solidFill>
+                <a:latin typeface="Calibri"/>
+              </a:defRPr>
+            </a:pPr>
+            <a:r>
+              <a:t>Kullanicinin dedektoru olusturma/yonetme API'si</a:t>
+            </a:r>
+          </a:p>
+        </p:txBody>
+      </p:sp>
+      <p:sp>
+        <p:nvSpPr>
+          <p:cNvPr id="21" name="Rectangle 20"/>
+          <p:cNvSpPr/>
+          <p:nvPr/>
+        </p:nvSpPr>
+        <p:spPr>
+          <a:xfrm>
+            <a:off x="365760" y="3063240"/>
+            <a:ext cx="109728" cy="256032"/>
+          </a:xfrm>
+          <a:prstGeom prst="rect">
+            <a:avLst/>
+          </a:prstGeom>
+          <a:solidFill>
+            <a:srgbClr val="333333"/>
+          </a:solidFill>
+          <a:ln>
+            <a:noFill/>
+          </a:ln>
+        </p:spPr>
+        <p:style>
+          <a:lnRef idx="1">
+            <a:schemeClr val="accent1"/>
+          </a:lnRef>
+          <a:fillRef idx="3">
+            <a:schemeClr val="accent1"/>
+          </a:fillRef>
+          <a:effectRef idx="2">
+            <a:schemeClr val="accent1"/>
+          </a:effectRef>
+          <a:fontRef idx="minor">
+            <a:schemeClr val="lt1"/>
+          </a:fontRef>
+        </p:style>
+        <p:txBody>
+          <a:bodyPr rtlCol="0" anchor="ctr"/>
+          <a:lstStyle/>
+          <a:p>
+            <a:pPr algn="ctr"/>
+          </a:p>
+        </p:txBody>
+      </p:sp>
+      <p:sp>
+        <p:nvSpPr>
+          <p:cNvPr id="22" name="TextBox 21"/>
+          <p:cNvSpPr txBox="1"/>
+          <p:nvPr/>
+        </p:nvSpPr>
+        <p:spPr>
+          <a:xfrm>
+            <a:off x="548640" y="3044952"/>
+            <a:ext cx="1645920" cy="228600"/>
+          </a:xfrm>
+          <a:prstGeom prst="rect">
+            <a:avLst/>
+          </a:prstGeom>
+          <a:noFill/>
+        </p:spPr>
+        <p:txBody>
+          <a:bodyPr wrap="square">
+            <a:spAutoFit/>
+          </a:bodyPr>
+          <a:lstStyle/>
+          <a:p>
+            <a:pPr algn="l">
+              <a:defRPr sz="1200" b="1">
+                <a:solidFill>
+                  <a:srgbClr val="333333"/>
+                </a:solidFill>
+                <a:latin typeface="Calibri"/>
+              </a:defRPr>
+            </a:pPr>
+            <a:r>
+              <a:t>Transport</a:t>
+            </a:r>
+          </a:p>
+        </p:txBody>
+      </p:sp>
+      <p:sp>
+        <p:nvSpPr>
+          <p:cNvPr id="23" name="TextBox 22"/>
+          <p:cNvSpPr txBox="1"/>
+          <p:nvPr/>
+        </p:nvSpPr>
+        <p:spPr>
+          <a:xfrm>
+            <a:off x="2286000" y="3044952"/>
+            <a:ext cx="3566160" cy="228600"/>
+          </a:xfrm>
+          <a:prstGeom prst="rect">
+            <a:avLst/>
+          </a:prstGeom>
+          <a:noFill/>
+        </p:spPr>
+        <p:txBody>
+          <a:bodyPr wrap="square">
+            <a:spAutoFit/>
+          </a:bodyPr>
+          <a:lstStyle/>
+          <a:p>
+            <a:pPr algn="l">
+              <a:defRPr sz="1100" b="0">
+                <a:solidFill>
+                  <a:srgbClr val="333333"/>
+                </a:solidFill>
+                <a:latin typeface="Calibri"/>
+              </a:defRPr>
+            </a:pPr>
+            <a:r>
+              <a:t>OpenSearch dugumleri arasi iletisim</a:t>
+            </a:r>
+          </a:p>
+        </p:txBody>
+      </p:sp>
+      <p:sp>
+        <p:nvSpPr>
+          <p:cNvPr id="24" name="Rectangle 23"/>
+          <p:cNvSpPr/>
+          <p:nvPr/>
+        </p:nvSpPr>
+        <p:spPr>
+          <a:xfrm>
+            <a:off x="365760" y="3364992"/>
+            <a:ext cx="109728" cy="256032"/>
+          </a:xfrm>
+          <a:prstGeom prst="rect">
+            <a:avLst/>
+          </a:prstGeom>
+          <a:solidFill>
+            <a:srgbClr val="E74C3C"/>
+          </a:solidFill>
+          <a:ln>
+            <a:noFill/>
+          </a:ln>
+        </p:spPr>
+        <p:style>
+          <a:lnRef idx="1">
+            <a:schemeClr val="accent1"/>
+          </a:lnRef>
+          <a:fillRef idx="3">
+            <a:schemeClr val="accent1"/>
+          </a:fillRef>
+          <a:effectRef idx="2">
+            <a:schemeClr val="accent1"/>
+          </a:effectRef>
+          <a:fontRef idx="minor">
+            <a:schemeClr val="lt1"/>
+          </a:fontRef>
+        </p:style>
+        <p:txBody>
+          <a:bodyPr rtlCol="0" anchor="ctr"/>
+          <a:lstStyle/>
+          <a:p>
+            <a:pPr algn="ctr"/>
+          </a:p>
+        </p:txBody>
+      </p:sp>
+      <p:sp>
+        <p:nvSpPr>
+          <p:cNvPr id="25" name="TextBox 24"/>
+          <p:cNvSpPr txBox="1"/>
+          <p:nvPr/>
+        </p:nvSpPr>
+        <p:spPr>
+          <a:xfrm>
+            <a:off x="548640" y="3346704"/>
+            <a:ext cx="1645920" cy="228600"/>
+          </a:xfrm>
+          <a:prstGeom prst="rect">
+            <a:avLst/>
+          </a:prstGeom>
+          <a:noFill/>
+        </p:spPr>
+        <p:txBody>
+          <a:bodyPr wrap="square">
+            <a:spAutoFit/>
+          </a:bodyPr>
+          <a:lstStyle/>
+          <a:p>
+            <a:pPr algn="l">
+              <a:defRPr sz="1200" b="1">
+                <a:solidFill>
+                  <a:srgbClr val="E74C3C"/>
+                </a:solidFill>
+                <a:latin typeface="Calibri"/>
+              </a:defRPr>
+            </a:pPr>
+            <a:r>
+              <a:t>Feature</a:t>
+            </a:r>
+          </a:p>
+        </p:txBody>
+      </p:sp>
+      <p:sp>
+        <p:nvSpPr>
+          <p:cNvPr id="26" name="TextBox 25"/>
+          <p:cNvSpPr txBox="1"/>
+          <p:nvPr/>
+        </p:nvSpPr>
+        <p:spPr>
+          <a:xfrm>
+            <a:off x="2286000" y="3346704"/>
+            <a:ext cx="3566160" cy="228600"/>
+          </a:xfrm>
+          <a:prstGeom prst="rect">
+            <a:avLst/>
+          </a:prstGeom>
+          <a:noFill/>
+        </p:spPr>
+        <p:txBody>
+          <a:bodyPr wrap="square">
+            <a:spAutoFit/>
+          </a:bodyPr>
+          <a:lstStyle/>
+          <a:p>
+            <a:pPr algn="l">
+              <a:defRPr sz="1100" b="0">
+                <a:solidFill>
+                  <a:srgbClr val="333333"/>
+                </a:solidFill>
+                <a:latin typeface="Calibri"/>
+              </a:defRPr>
+            </a:pPr>
+            <a:r>
+              <a:t>Veriden ozellik cikarma (aggregation)</a:t>
+            </a:r>
+          </a:p>
+        </p:txBody>
+      </p:sp>
+      <p:sp>
+        <p:nvSpPr>
+          <p:cNvPr id="27" name="Rectangle 26"/>
+          <p:cNvSpPr/>
+          <p:nvPr/>
+        </p:nvSpPr>
+        <p:spPr>
+          <a:xfrm>
+            <a:off x="6217920" y="1097280"/>
+            <a:ext cx="5669280" cy="2468880"/>
+          </a:xfrm>
+          <a:prstGeom prst="rect">
+            <a:avLst/>
+          </a:prstGeom>
+          <a:solidFill>
+            <a:srgbClr val="FFFFFF"/>
+          </a:solidFill>
+          <a:ln>
+            <a:noFill/>
+          </a:ln>
+        </p:spPr>
+        <p:style>
+          <a:lnRef idx="1">
+            <a:schemeClr val="accent1"/>
+          </a:lnRef>
+          <a:fillRef idx="3">
+            <a:schemeClr val="accent1"/>
+          </a:fillRef>
+          <a:effectRef idx="2">
+            <a:schemeClr val="accent1"/>
+          </a:effectRef>
+          <a:fontRef idx="minor">
+            <a:schemeClr val="lt1"/>
+          </a:fontRef>
+        </p:style>
+        <p:txBody>
+          <a:bodyPr rtlCol="0" anchor="ctr"/>
+          <a:lstStyle/>
+          <a:p>
+            <a:pPr algn="ctr"/>
+          </a:p>
+        </p:txBody>
+      </p:sp>
+      <p:sp>
+        <p:nvSpPr>
+          <p:cNvPr id="28" name="TextBox 27"/>
+          <p:cNvSpPr txBox="1"/>
+          <p:nvPr/>
+        </p:nvSpPr>
+        <p:spPr>
+          <a:xfrm>
+            <a:off x="6400800" y="1143000"/>
+            <a:ext cx="5303520" cy="320040"/>
+          </a:xfrm>
+          <a:prstGeom prst="rect">
+            <a:avLst/>
+          </a:prstGeom>
+          <a:noFill/>
+        </p:spPr>
+        <p:txBody>
+          <a:bodyPr wrap="square">
+            <a:spAutoFit/>
+          </a:bodyPr>
+          <a:lstStyle/>
+          <a:p>
+            <a:pPr algn="l">
+              <a:defRPr sz="1700" b="1">
+                <a:solidFill>
+                  <a:srgbClr val="00528A"/>
+                </a:solidFill>
+                <a:latin typeface="Calibri"/>
+              </a:defRPr>
+            </a:pPr>
+            <a:r>
+              <a:t>Random Cut Forest (RCF) Algoritmasi</a:t>
+            </a:r>
+          </a:p>
+        </p:txBody>
+      </p:sp>
+      <p:sp>
+        <p:nvSpPr>
+          <p:cNvPr id="29" name="TextBox 28"/>
+          <p:cNvSpPr txBox="1"/>
+          <p:nvPr/>
+        </p:nvSpPr>
+        <p:spPr>
+          <a:xfrm>
+            <a:off x="6400800" y="1508760"/>
+            <a:ext cx="5303520" cy="1097280"/>
+          </a:xfrm>
+          <a:prstGeom prst="rect">
+            <a:avLst/>
+          </a:prstGeom>
+          <a:noFill/>
+        </p:spPr>
+        <p:txBody>
+          <a:bodyPr wrap="square">
+            <a:spAutoFit/>
+          </a:bodyPr>
+          <a:lstStyle/>
+          <a:p>
+            <a:pPr>
+              <a:spcAft>
+                <a:spcPts val="200"/>
+              </a:spcAft>
+              <a:defRPr sz="1200">
+                <a:solidFill>
+                  <a:srgbClr val="333333"/>
+                </a:solidFill>
+                <a:latin typeface="Calibri"/>
+              </a:defRPr>
+            </a:pPr>
+            <a:r>
+              <a:t>Amazon'un gelistirdigi anomali tespit algoritmasi:</a:t>
+            </a:r>
+          </a:p>
+          <a:p>
+            <a:pPr>
+              <a:spcAft>
+                <a:spcPts val="200"/>
+              </a:spcAft>
+              <a:defRPr sz="1200">
+                <a:solidFill>
+                  <a:srgbClr val="333333"/>
+                </a:solidFill>
+                <a:latin typeface="Calibri"/>
+              </a:defRPr>
+            </a:pPr>
+          </a:p>
+          <a:p>
+            <a:pPr>
+              <a:spcAft>
+                <a:spcPts val="200"/>
+              </a:spcAft>
+              <a:defRPr sz="1200">
+                <a:solidFill>
+                  <a:srgbClr val="333333"/>
+                </a:solidFill>
+                <a:latin typeface="Calibri"/>
+              </a:defRPr>
+            </a:pPr>
+            <a:r>
+              <a:t>1. Egitim: Gecmis veriden rastgele agaclar olusturur</a:t>
+            </a:r>
+          </a:p>
+          <a:p>
+            <a:pPr>
+              <a:spcAft>
+                <a:spcPts val="200"/>
+              </a:spcAft>
+              <a:defRPr sz="1200">
+                <a:solidFill>
+                  <a:srgbClr val="333333"/>
+                </a:solidFill>
+                <a:latin typeface="Calibri"/>
+              </a:defRPr>
+            </a:pPr>
+            <a:r>
+              <a:t>2. Tahmin: Yeni veriyi agaca eklemeye calisir</a:t>
+            </a:r>
+          </a:p>
+          <a:p>
+            <a:pPr>
+              <a:spcAft>
+                <a:spcPts val="200"/>
+              </a:spcAft>
+              <a:defRPr sz="1200">
+                <a:solidFill>
+                  <a:srgbClr val="333333"/>
+                </a:solidFill>
+                <a:latin typeface="Calibri"/>
+              </a:defRPr>
+            </a:pPr>
+            <a:r>
+              <a:t>3. Skor: Agaci ne kadar degistiriyorsa skor o kadar yuksek</a:t>
+            </a:r>
+          </a:p>
+          <a:p>
+            <a:pPr>
+              <a:spcAft>
+                <a:spcPts val="200"/>
+              </a:spcAft>
+              <a:defRPr sz="1200">
+                <a:solidFill>
+                  <a:srgbClr val="333333"/>
+                </a:solidFill>
+                <a:latin typeface="Calibri"/>
+              </a:defRPr>
+            </a:pPr>
+            <a:r>
+              <a:t>4. Karar: Skor esigi asarsa -&gt; ANOMALI</a:t>
+            </a:r>
+          </a:p>
+        </p:txBody>
+      </p:sp>
+      <p:sp>
+        <p:nvSpPr>
+          <p:cNvPr id="30" name="Rectangle 29"/>
+          <p:cNvSpPr/>
+          <p:nvPr/>
+        </p:nvSpPr>
+        <p:spPr>
+          <a:xfrm>
+            <a:off x="6400800" y="2606040"/>
+            <a:ext cx="5303520" cy="777240"/>
+          </a:xfrm>
+          <a:prstGeom prst="rect">
+            <a:avLst/>
+          </a:prstGeom>
+          <a:solidFill>
+            <a:srgbClr val="2D2D2D"/>
+          </a:solidFill>
+          <a:ln>
+            <a:noFill/>
+          </a:ln>
+        </p:spPr>
+        <p:style>
+          <a:lnRef idx="1">
+            <a:schemeClr val="accent1"/>
+          </a:lnRef>
+          <a:fillRef idx="3">
+            <a:schemeClr val="accent1"/>
+          </a:fillRef>
+          <a:effectRef idx="2">
+            <a:schemeClr val="accent1"/>
+          </a:effectRef>
+          <a:fontRef idx="minor">
+            <a:schemeClr val="lt1"/>
+          </a:fontRef>
+        </p:style>
+        <p:txBody>
+          <a:bodyPr rtlCol="0" anchor="ctr"/>
+          <a:lstStyle/>
+          <a:p>
+            <a:pPr algn="ctr"/>
+          </a:p>
+        </p:txBody>
+      </p:sp>
+      <p:sp>
+        <p:nvSpPr>
+          <p:cNvPr id="31" name="TextBox 30"/>
+          <p:cNvSpPr txBox="1"/>
+          <p:nvPr/>
+        </p:nvSpPr>
+        <p:spPr>
+          <a:xfrm>
+            <a:off x="6492240" y="2624328"/>
+            <a:ext cx="5120640" cy="731520"/>
+          </a:xfrm>
+          <a:prstGeom prst="rect">
+            <a:avLst/>
+          </a:prstGeom>
+          <a:noFill/>
+        </p:spPr>
+        <p:txBody>
+          <a:bodyPr wrap="square">
+            <a:spAutoFit/>
+          </a:bodyPr>
+          <a:lstStyle/>
+          <a:p>
+            <a:pPr algn="l">
+              <a:defRPr sz="1200" b="0">
+                <a:solidFill>
+                  <a:srgbClr val="2ECC71"/>
+                </a:solidFill>
+                <a:latin typeface="Calibri"/>
+              </a:defRPr>
+            </a:pPr>
+            <a:r>
+              <a:t>Normal:   --*--*--*--*--*--*--     skor: 1-2 (dusuk)</a:t>
+            </a:r>
+            <a:br/>
+            <a:r>
+              <a:t>Anomali:  --*--*--*--------*--*--  skor: 8-9 (yuksek!)</a:t>
+            </a:r>
+            <a:br/>
+            <a:r>
+              <a:t>                       ^ ANOMALI NOKTASI</a:t>
+            </a:r>
+          </a:p>
+        </p:txBody>
+      </p:sp>
+      <p:sp>
+        <p:nvSpPr>
+          <p:cNvPr id="32" name="Rectangle 31"/>
+          <p:cNvSpPr/>
+          <p:nvPr/>
+        </p:nvSpPr>
+        <p:spPr>
+          <a:xfrm>
+            <a:off x="274320" y="3749039"/>
+            <a:ext cx="11612880" cy="1645920"/>
+          </a:xfrm>
+          <a:prstGeom prst="rect">
+            <a:avLst/>
+          </a:prstGeom>
+          <a:solidFill>
+            <a:srgbClr val="FFFFFF"/>
+          </a:solidFill>
+          <a:ln>
+            <a:noFill/>
+          </a:ln>
+        </p:spPr>
+        <p:style>
+          <a:lnRef idx="1">
+            <a:schemeClr val="accent1"/>
+          </a:lnRef>
+          <a:fillRef idx="3">
+            <a:schemeClr val="accent1"/>
+          </a:fillRef>
+          <a:effectRef idx="2">
+            <a:schemeClr val="accent1"/>
+          </a:effectRef>
+          <a:fontRef idx="minor">
+            <a:schemeClr val="lt1"/>
+          </a:fontRef>
+        </p:style>
+        <p:txBody>
+          <a:bodyPr rtlCol="0" anchor="ctr"/>
+          <a:lstStyle/>
+          <a:p>
+            <a:pPr algn="ctr"/>
+          </a:p>
+        </p:txBody>
+      </p:sp>
+      <p:sp>
+        <p:nvSpPr>
+          <p:cNvPr id="33" name="TextBox 32"/>
+          <p:cNvSpPr txBox="1"/>
+          <p:nvPr/>
+        </p:nvSpPr>
+        <p:spPr>
+          <a:xfrm>
+            <a:off x="457200" y="3794760"/>
+            <a:ext cx="11247120" cy="320040"/>
+          </a:xfrm>
+          <a:prstGeom prst="rect">
+            <a:avLst/>
+          </a:prstGeom>
+          <a:noFill/>
+        </p:spPr>
+        <p:txBody>
+          <a:bodyPr wrap="square">
+            <a:spAutoFit/>
+          </a:bodyPr>
+          <a:lstStyle/>
+          <a:p>
+            <a:pPr algn="l">
+              <a:defRPr sz="1700" b="1">
+                <a:solidFill>
+                  <a:srgbClr val="00528A"/>
+                </a:solidFill>
+                <a:latin typeface="Calibri"/>
+              </a:defRPr>
+            </a:pPr>
+            <a:r>
+              <a:t>Neden Bu Proje QMOOD Analizi Icin Uygun?</a:t>
+            </a:r>
+          </a:p>
+        </p:txBody>
+      </p:sp>
+      <p:sp>
+        <p:nvSpPr>
+          <p:cNvPr id="34" name="Rectangle 33"/>
+          <p:cNvSpPr/>
+          <p:nvPr/>
+        </p:nvSpPr>
+        <p:spPr>
+          <a:xfrm>
+            <a:off x="365760" y="4160520"/>
+            <a:ext cx="2103120" cy="1051560"/>
+          </a:xfrm>
+          <a:prstGeom prst="rect">
+            <a:avLst/>
+          </a:prstGeom>
+          <a:solidFill>
+            <a:srgbClr val="0096D6"/>
+          </a:solidFill>
+          <a:ln>
+            <a:noFill/>
+          </a:ln>
+        </p:spPr>
+        <p:style>
+          <a:lnRef idx="1">
+            <a:schemeClr val="accent1"/>
+          </a:lnRef>
+          <a:fillRef idx="3">
+            <a:schemeClr val="accent1"/>
+          </a:fillRef>
+          <a:effectRef idx="2">
+            <a:schemeClr val="accent1"/>
+          </a:effectRef>
+          <a:fontRef idx="minor">
+            <a:schemeClr val="lt1"/>
+          </a:fontRef>
+        </p:style>
+        <p:txBody>
+          <a:bodyPr rtlCol="0" anchor="ctr"/>
+          <a:lstStyle/>
+          <a:p>
+            <a:pPr algn="ctr"/>
+          </a:p>
+        </p:txBody>
+      </p:sp>
+      <p:sp>
+        <p:nvSpPr>
+          <p:cNvPr id="35" name="TextBox 34"/>
+          <p:cNvSpPr txBox="1"/>
+          <p:nvPr/>
+        </p:nvSpPr>
+        <p:spPr>
+          <a:xfrm>
+            <a:off x="411480" y="4187952"/>
+            <a:ext cx="2011680" cy="274320"/>
+          </a:xfrm>
+          <a:prstGeom prst="rect">
+            <a:avLst/>
+          </a:prstGeom>
+          <a:noFill/>
+        </p:spPr>
+        <p:txBody>
+          <a:bodyPr wrap="square">
+            <a:spAutoFit/>
+          </a:bodyPr>
+          <a:lstStyle/>
+          <a:p>
+            <a:pPr algn="ctr">
+              <a:defRPr sz="1300" b="1">
+                <a:solidFill>
+                  <a:srgbClr val="FFFFFF"/>
+                </a:solidFill>
+                <a:latin typeface="Calibri"/>
+              </a:defRPr>
+            </a:pPr>
+            <a:r>
+              <a:t>Java Dili</a:t>
+            </a:r>
+          </a:p>
+        </p:txBody>
+      </p:sp>
+      <p:sp>
+        <p:nvSpPr>
+          <p:cNvPr id="36" name="TextBox 35"/>
+          <p:cNvSpPr txBox="1"/>
+          <p:nvPr/>
+        </p:nvSpPr>
+        <p:spPr>
+          <a:xfrm>
+            <a:off x="411480" y="4462272"/>
+            <a:ext cx="2011680" cy="640080"/>
+          </a:xfrm>
+          <a:prstGeom prst="rect">
+            <a:avLst/>
+          </a:prstGeom>
+          <a:noFill/>
+        </p:spPr>
+        <p:txBody>
+          <a:bodyPr wrap="square">
+            <a:spAutoFit/>
+          </a:bodyPr>
+          <a:lstStyle/>
+          <a:p>
+            <a:pPr algn="ctr">
+              <a:defRPr sz="1100" b="0">
+                <a:solidFill>
+                  <a:srgbClr val="FFFFFF"/>
+                </a:solidFill>
+                <a:latin typeface="Calibri"/>
+              </a:defRPr>
+            </a:pPr>
+            <a:r>
+              <a:t>QMOOD ve CK Tool</a:t>
+            </a:r>
+            <a:br/>
+            <a:r>
+              <a:t>Java icin tasarlanmis</a:t>
+            </a:r>
+          </a:p>
+        </p:txBody>
+      </p:sp>
+      <p:sp>
+        <p:nvSpPr>
+          <p:cNvPr id="37" name="Rectangle 36"/>
+          <p:cNvSpPr/>
+          <p:nvPr/>
+        </p:nvSpPr>
+        <p:spPr>
+          <a:xfrm>
+            <a:off x="2651760" y="4160520"/>
+            <a:ext cx="2103120" cy="1051560"/>
+          </a:xfrm>
+          <a:prstGeom prst="rect">
+            <a:avLst/>
+          </a:prstGeom>
+          <a:solidFill>
+            <a:srgbClr val="2ECC71"/>
+          </a:solidFill>
+          <a:ln>
+            <a:noFill/>
+          </a:ln>
+        </p:spPr>
+        <p:style>
+          <a:lnRef idx="1">
+            <a:schemeClr val="accent1"/>
+          </a:lnRef>
+          <a:fillRef idx="3">
+            <a:schemeClr val="accent1"/>
+          </a:fillRef>
+          <a:effectRef idx="2">
+            <a:schemeClr val="accent1"/>
+          </a:effectRef>
+          <a:fontRef idx="minor">
+            <a:schemeClr val="lt1"/>
+          </a:fontRef>
+        </p:style>
+        <p:txBody>
+          <a:bodyPr rtlCol="0" anchor="ctr"/>
+          <a:lstStyle/>
+          <a:p>
+            <a:pPr algn="ctr"/>
+          </a:p>
+        </p:txBody>
+      </p:sp>
+      <p:sp>
+        <p:nvSpPr>
+          <p:cNvPr id="38" name="TextBox 37"/>
+          <p:cNvSpPr txBox="1"/>
+          <p:nvPr/>
+        </p:nvSpPr>
+        <p:spPr>
+          <a:xfrm>
+            <a:off x="2697479" y="4187952"/>
+            <a:ext cx="2011680" cy="274320"/>
+          </a:xfrm>
+          <a:prstGeom prst="rect">
+            <a:avLst/>
+          </a:prstGeom>
+          <a:noFill/>
+        </p:spPr>
+        <p:txBody>
+          <a:bodyPr wrap="square">
+            <a:spAutoFit/>
+          </a:bodyPr>
+          <a:lstStyle/>
+          <a:p>
+            <a:pPr algn="ctr">
+              <a:defRPr sz="1300" b="1">
+                <a:solidFill>
+                  <a:srgbClr val="FFFFFF"/>
+                </a:solidFill>
+                <a:latin typeface="Calibri"/>
+              </a:defRPr>
+            </a:pPr>
+            <a:r>
+              <a:t>Uygun Boyut</a:t>
+            </a:r>
+          </a:p>
+        </p:txBody>
+      </p:sp>
+      <p:sp>
+        <p:nvSpPr>
+          <p:cNvPr id="39" name="TextBox 38"/>
+          <p:cNvSpPr txBox="1"/>
+          <p:nvPr/>
+        </p:nvSpPr>
+        <p:spPr>
+          <a:xfrm>
+            <a:off x="2697479" y="4462272"/>
+            <a:ext cx="2011680" cy="640080"/>
+          </a:xfrm>
+          <a:prstGeom prst="rect">
+            <a:avLst/>
+          </a:prstGeom>
+          <a:noFill/>
+        </p:spPr>
+        <p:txBody>
+          <a:bodyPr wrap="square">
+            <a:spAutoFit/>
+          </a:bodyPr>
+          <a:lstStyle/>
+          <a:p>
+            <a:pPr algn="ctr">
+              <a:defRPr sz="1100" b="0">
+                <a:solidFill>
+                  <a:srgbClr val="FFFFFF"/>
+                </a:solidFill>
+                <a:latin typeface="Calibri"/>
+              </a:defRPr>
+            </a:pPr>
+            <a:r>
+              <a:t>288-609 sinif</a:t>
+            </a:r>
+            <a:br/>
+            <a:r>
+              <a:t>ne kucuk ne buyuk</a:t>
+            </a:r>
+          </a:p>
+        </p:txBody>
+      </p:sp>
+      <p:sp>
+        <p:nvSpPr>
+          <p:cNvPr id="40" name="Rectangle 39"/>
+          <p:cNvSpPr/>
+          <p:nvPr/>
+        </p:nvSpPr>
+        <p:spPr>
+          <a:xfrm>
+            <a:off x="4937760" y="4160520"/>
+            <a:ext cx="2103120" cy="1051560"/>
+          </a:xfrm>
+          <a:prstGeom prst="rect">
+            <a:avLst/>
+          </a:prstGeom>
+          <a:solidFill>
+            <a:srgbClr val="FF8C00"/>
+          </a:solidFill>
+          <a:ln>
+            <a:noFill/>
+          </a:ln>
+        </p:spPr>
+        <p:style>
+          <a:lnRef idx="1">
+            <a:schemeClr val="accent1"/>
+          </a:lnRef>
+          <a:fillRef idx="3">
+            <a:schemeClr val="accent1"/>
+          </a:fillRef>
+          <a:effectRef idx="2">
+            <a:schemeClr val="accent1"/>
+          </a:effectRef>
+          <a:fontRef idx="minor">
+            <a:schemeClr val="lt1"/>
+          </a:fontRef>
+        </p:style>
+        <p:txBody>
+          <a:bodyPr rtlCol="0" anchor="ctr"/>
+          <a:lstStyle/>
+          <a:p>
+            <a:pPr algn="ctr"/>
+          </a:p>
+        </p:txBody>
+      </p:sp>
+      <p:sp>
+        <p:nvSpPr>
+          <p:cNvPr id="41" name="TextBox 40"/>
+          <p:cNvSpPr txBox="1"/>
+          <p:nvPr/>
+        </p:nvSpPr>
+        <p:spPr>
+          <a:xfrm>
+            <a:off x="4983480" y="4187952"/>
+            <a:ext cx="2011680" cy="274320"/>
+          </a:xfrm>
+          <a:prstGeom prst="rect">
+            <a:avLst/>
+          </a:prstGeom>
+          <a:noFill/>
+        </p:spPr>
+        <p:txBody>
+          <a:bodyPr wrap="square">
+            <a:spAutoFit/>
+          </a:bodyPr>
+          <a:lstStyle/>
+          <a:p>
+            <a:pPr algn="ctr">
+              <a:defRPr sz="1300" b="1">
+                <a:solidFill>
+                  <a:srgbClr val="FFFFFF"/>
+                </a:solidFill>
+                <a:latin typeface="Calibri"/>
+              </a:defRPr>
+            </a:pPr>
+            <a:r>
+              <a:t>Zengin OOP</a:t>
+            </a:r>
+          </a:p>
+        </p:txBody>
+      </p:sp>
+      <p:sp>
+        <p:nvSpPr>
+          <p:cNvPr id="42" name="TextBox 41"/>
+          <p:cNvSpPr txBox="1"/>
+          <p:nvPr/>
+        </p:nvSpPr>
+        <p:spPr>
+          <a:xfrm>
+            <a:off x="4983480" y="4462272"/>
+            <a:ext cx="2011680" cy="640080"/>
+          </a:xfrm>
+          <a:prstGeom prst="rect">
+            <a:avLst/>
+          </a:prstGeom>
+          <a:noFill/>
+        </p:spPr>
+        <p:txBody>
+          <a:bodyPr wrap="square">
+            <a:spAutoFit/>
+          </a:bodyPr>
+          <a:lstStyle/>
+          <a:p>
+            <a:pPr algn="ctr">
+              <a:defRPr sz="1100" b="0">
+                <a:solidFill>
+                  <a:srgbClr val="FFFFFF"/>
+                </a:solidFill>
+                <a:latin typeface="Calibri"/>
+              </a:defRPr>
+            </a:pPr>
+            <a:r>
+              <a:t>Kalitim, arayuzler,</a:t>
+            </a:r>
+            <a:br/>
+            <a:r>
+              <a:t>soyut siniflar yogun</a:t>
+            </a:r>
+          </a:p>
+        </p:txBody>
+      </p:sp>
+      <p:sp>
+        <p:nvSpPr>
+          <p:cNvPr id="43" name="Rectangle 42"/>
+          <p:cNvSpPr/>
+          <p:nvPr/>
+        </p:nvSpPr>
+        <p:spPr>
+          <a:xfrm>
+            <a:off x="7223760" y="4160520"/>
+            <a:ext cx="2103120" cy="1051560"/>
+          </a:xfrm>
+          <a:prstGeom prst="rect">
+            <a:avLst/>
+          </a:prstGeom>
+          <a:solidFill>
+            <a:srgbClr val="8E44AD"/>
+          </a:solidFill>
+          <a:ln>
+            <a:noFill/>
+          </a:ln>
+        </p:spPr>
+        <p:style>
+          <a:lnRef idx="1">
+            <a:schemeClr val="accent1"/>
+          </a:lnRef>
+          <a:fillRef idx="3">
+            <a:schemeClr val="accent1"/>
+          </a:fillRef>
+          <a:effectRef idx="2">
+            <a:schemeClr val="accent1"/>
+          </a:effectRef>
+          <a:fontRef idx="minor">
+            <a:schemeClr val="lt1"/>
+          </a:fontRef>
+        </p:style>
+        <p:txBody>
+          <a:bodyPr rtlCol="0" anchor="ctr"/>
+          <a:lstStyle/>
+          <a:p>
+            <a:pPr algn="ctr"/>
+          </a:p>
+        </p:txBody>
+      </p:sp>
+      <p:sp>
+        <p:nvSpPr>
+          <p:cNvPr id="44" name="TextBox 43"/>
+          <p:cNvSpPr txBox="1"/>
+          <p:nvPr/>
+        </p:nvSpPr>
+        <p:spPr>
+          <a:xfrm>
+            <a:off x="7269480" y="4187952"/>
+            <a:ext cx="2011680" cy="274320"/>
+          </a:xfrm>
+          <a:prstGeom prst="rect">
+            <a:avLst/>
+          </a:prstGeom>
+          <a:noFill/>
+        </p:spPr>
+        <p:txBody>
+          <a:bodyPr wrap="square">
+            <a:spAutoFit/>
+          </a:bodyPr>
+          <a:lstStyle/>
+          <a:p>
+            <a:pPr algn="ctr">
+              <a:defRPr sz="1300" b="1">
+                <a:solidFill>
+                  <a:srgbClr val="FFFFFF"/>
+                </a:solidFill>
+                <a:latin typeface="Calibri"/>
+              </a:defRPr>
+            </a:pPr>
+            <a:r>
+              <a:t>70+ Surum</a:t>
+            </a:r>
+          </a:p>
+        </p:txBody>
+      </p:sp>
+      <p:sp>
+        <p:nvSpPr>
+          <p:cNvPr id="45" name="TextBox 44"/>
+          <p:cNvSpPr txBox="1"/>
+          <p:nvPr/>
+        </p:nvSpPr>
+        <p:spPr>
+          <a:xfrm>
+            <a:off x="7269480" y="4462272"/>
+            <a:ext cx="2011680" cy="640080"/>
+          </a:xfrm>
+          <a:prstGeom prst="rect">
+            <a:avLst/>
+          </a:prstGeom>
+          <a:noFill/>
+        </p:spPr>
+        <p:txBody>
+          <a:bodyPr wrap="square">
+            <a:spAutoFit/>
+          </a:bodyPr>
+          <a:lstStyle/>
+          <a:p>
+            <a:pPr algn="ctr">
+              <a:defRPr sz="1100" b="0">
+                <a:solidFill>
+                  <a:srgbClr val="FFFFFF"/>
+                </a:solidFill>
+                <a:latin typeface="Calibri"/>
+              </a:defRPr>
+            </a:pPr>
+            <a:r>
+              <a:t>3 major versiyon</a:t>
+            </a:r>
+            <a:br/>
+            <a:r>
+              <a:t>(1.x, 2.x, 3.x)</a:t>
+            </a:r>
+          </a:p>
+        </p:txBody>
+      </p:sp>
+      <p:sp>
+        <p:nvSpPr>
+          <p:cNvPr id="46" name="Rectangle 45"/>
+          <p:cNvSpPr/>
+          <p:nvPr/>
+        </p:nvSpPr>
+        <p:spPr>
+          <a:xfrm>
+            <a:off x="9509760" y="4160520"/>
+            <a:ext cx="2103120" cy="1051560"/>
+          </a:xfrm>
+          <a:prstGeom prst="rect">
+            <a:avLst/>
+          </a:prstGeom>
+          <a:solidFill>
+            <a:srgbClr val="E74C3C"/>
+          </a:solidFill>
+          <a:ln>
+            <a:noFill/>
+          </a:ln>
+        </p:spPr>
+        <p:style>
+          <a:lnRef idx="1">
+            <a:schemeClr val="accent1"/>
+          </a:lnRef>
+          <a:fillRef idx="3">
+            <a:schemeClr val="accent1"/>
+          </a:fillRef>
+          <a:effectRef idx="2">
+            <a:schemeClr val="accent1"/>
+          </a:effectRef>
+          <a:fontRef idx="minor">
+            <a:schemeClr val="lt1"/>
+          </a:fontRef>
+        </p:style>
+        <p:txBody>
+          <a:bodyPr rtlCol="0" anchor="ctr"/>
+          <a:lstStyle/>
+          <a:p>
+            <a:pPr algn="ctr"/>
+          </a:p>
+        </p:txBody>
+      </p:sp>
+      <p:sp>
+        <p:nvSpPr>
+          <p:cNvPr id="47" name="TextBox 46"/>
+          <p:cNvSpPr txBox="1"/>
+          <p:nvPr/>
+        </p:nvSpPr>
+        <p:spPr>
+          <a:xfrm>
+            <a:off x="9555480" y="4187952"/>
+            <a:ext cx="2011680" cy="274320"/>
+          </a:xfrm>
+          <a:prstGeom prst="rect">
+            <a:avLst/>
+          </a:prstGeom>
+          <a:noFill/>
+        </p:spPr>
+        <p:txBody>
+          <a:bodyPr wrap="square">
+            <a:spAutoFit/>
+          </a:bodyPr>
+          <a:lstStyle/>
+          <a:p>
+            <a:pPr algn="ctr">
+              <a:defRPr sz="1300" b="1">
+                <a:solidFill>
+                  <a:srgbClr val="FFFFFF"/>
+                </a:solidFill>
+                <a:latin typeface="Calibri"/>
+              </a:defRPr>
+            </a:pPr>
+            <a:r>
+              <a:t>Endustriyel</a:t>
+            </a:r>
+          </a:p>
+        </p:txBody>
+      </p:sp>
+      <p:sp>
+        <p:nvSpPr>
+          <p:cNvPr id="48" name="TextBox 47"/>
+          <p:cNvSpPr txBox="1"/>
+          <p:nvPr/>
+        </p:nvSpPr>
+        <p:spPr>
+          <a:xfrm>
+            <a:off x="9555480" y="4462272"/>
+            <a:ext cx="2011680" cy="640080"/>
+          </a:xfrm>
+          <a:prstGeom prst="rect">
+            <a:avLst/>
+          </a:prstGeom>
+          <a:noFill/>
+        </p:spPr>
+        <p:txBody>
+          <a:bodyPr wrap="square">
+            <a:spAutoFit/>
+          </a:bodyPr>
+          <a:lstStyle/>
+          <a:p>
+            <a:pPr algn="ctr">
+              <a:defRPr sz="1100" b="0">
+                <a:solidFill>
+                  <a:srgbClr val="FFFFFF"/>
+                </a:solidFill>
+                <a:latin typeface="Calibri"/>
+              </a:defRPr>
+            </a:pPr>
+            <a:r>
+              <a:t>Amazon/AWS</a:t>
+            </a:r>
+            <a:br/>
+            <a:r>
+              <a:t>uretimde kullaniyor</a:t>
+            </a:r>
+          </a:p>
+        </p:txBody>
+      </p:sp>
+      <p:sp>
+        <p:nvSpPr>
+          <p:cNvPr id="49" name="Rectangle 48"/>
+          <p:cNvSpPr/>
+          <p:nvPr/>
+        </p:nvSpPr>
+        <p:spPr>
+          <a:xfrm>
+            <a:off x="274320" y="5577840"/>
+            <a:ext cx="11612880" cy="1051560"/>
+          </a:xfrm>
+          <a:prstGeom prst="rect">
+            <a:avLst/>
+          </a:prstGeom>
+          <a:solidFill>
+            <a:srgbClr val="FFF3E0"/>
+          </a:solidFill>
+          <a:ln>
+            <a:noFill/>
+          </a:ln>
+        </p:spPr>
+        <p:style>
+          <a:lnRef idx="1">
+            <a:schemeClr val="accent1"/>
+          </a:lnRef>
+          <a:fillRef idx="3">
+            <a:schemeClr val="accent1"/>
+          </a:fillRef>
+          <a:effectRef idx="2">
+            <a:schemeClr val="accent1"/>
+          </a:effectRef>
+          <a:fontRef idx="minor">
+            <a:schemeClr val="lt1"/>
+          </a:fontRef>
+        </p:style>
+        <p:txBody>
+          <a:bodyPr rtlCol="0" anchor="ctr"/>
+          <a:lstStyle/>
+          <a:p>
+            <a:pPr algn="ctr"/>
+          </a:p>
+        </p:txBody>
+      </p:sp>
+      <p:sp>
+        <p:nvSpPr>
+          <p:cNvPr id="50" name="TextBox 49"/>
+          <p:cNvSpPr txBox="1"/>
+          <p:nvPr/>
+        </p:nvSpPr>
+        <p:spPr>
+          <a:xfrm>
+            <a:off x="457200" y="5623560"/>
+            <a:ext cx="11247120" cy="274320"/>
+          </a:xfrm>
+          <a:prstGeom prst="rect">
+            <a:avLst/>
+          </a:prstGeom>
+          <a:noFill/>
+        </p:spPr>
+        <p:txBody>
+          <a:bodyPr wrap="square">
+            <a:spAutoFit/>
+          </a:bodyPr>
+          <a:lstStyle/>
+          <a:p>
+            <a:pPr algn="l">
+              <a:defRPr sz="1500" b="1">
+                <a:solidFill>
+                  <a:srgbClr val="FF8C00"/>
+                </a:solidFill>
+                <a:latin typeface="Calibri"/>
+              </a:defRPr>
+            </a:pPr>
+            <a:r>
+              <a:t>v2.16.0.0'da Ne Oldu? — 227 Yeni Sinifin Nedeni</a:t>
+            </a:r>
+          </a:p>
+        </p:txBody>
+      </p:sp>
+      <p:sp>
+        <p:nvSpPr>
+          <p:cNvPr id="51" name="TextBox 50"/>
+          <p:cNvSpPr txBox="1"/>
+          <p:nvPr/>
+        </p:nvSpPr>
+        <p:spPr>
+          <a:xfrm>
+            <a:off x="457200" y="5897880"/>
+            <a:ext cx="11247120" cy="640080"/>
+          </a:xfrm>
+          <a:prstGeom prst="rect">
+            <a:avLst/>
+          </a:prstGeom>
+          <a:noFill/>
+        </p:spPr>
+        <p:txBody>
+          <a:bodyPr wrap="square">
+            <a:spAutoFit/>
+          </a:bodyPr>
+          <a:lstStyle/>
+          <a:p>
+            <a:pPr>
+              <a:spcAft>
+                <a:spcPts val="300"/>
+              </a:spcAft>
+              <a:defRPr sz="1200">
+                <a:solidFill>
+                  <a:srgbClr val="333333"/>
+                </a:solidFill>
+                <a:latin typeface="Calibri"/>
+              </a:defRPr>
+            </a:pPr>
+            <a:r>
+              <a:t>-&gt; Yeni anomali tespit modelleri eklendi (forecasting, HC detectors)      -&gt; Coklu veri akisi destegi (high-cardinality entity detection)      -&gt; Yeni REST API endpoint'leri</a:t>
+            </a:r>
+          </a:p>
+          <a:p>
+            <a:pPr>
+              <a:spcAft>
+                <a:spcPts val="300"/>
+              </a:spcAft>
+              <a:defRPr sz="1200">
+                <a:solidFill>
+                  <a:srgbClr val="333333"/>
+                </a:solidFill>
+                <a:latin typeface="Calibri"/>
+              </a:defRPr>
+            </a:pPr>
+            <a:r>
+              <a:t>-&gt; Sonuc: Sinif sayisi 364 -&gt; 591 (+%62), ama yeni siniflar daha kucuk ve odakli (WMC dustu, LCOM dustu)</a:t>
             </a:r>
           </a:p>
         </p:txBody>

</xml_diff>